<commit_message>
docs: add images to professional presentation deck
</commit_message>
<xml_diff>
--- a/presentation/presentasi_uas_ml.pptx
+++ b/presentation/presentasi_uas_ml.pptx
@@ -3093,7 +3093,7 @@
     <p:bg>
       <p:bgPr>
         <a:solidFill>
-          <a:srgbClr val="1A5276"/>
+          <a:srgbClr val="1F2761"/>
         </a:solidFill>
         <a:effectLst/>
       </p:bgPr>
@@ -3113,8 +3113,8 @@
         </p:nvSpPr>
         <p:spPr>
           <a:xfrm>
-            <a:off x="731520" y="1828800"/>
-            <a:ext cx="10698480" cy="731520"/>
+            <a:off x="731520" y="1645920"/>
+            <a:ext cx="10698480" cy="2011680"/>
           </a:xfrm>
           <a:prstGeom prst="rect">
             <a:avLst/>
@@ -3122,7 +3122,7 @@
           <a:noFill/>
         </p:spPr>
         <p:txBody>
-          <a:bodyPr wrap="none">
+          <a:bodyPr wrap="square">
             <a:spAutoFit/>
           </a:bodyPr>
           <a:lstStyle/>
@@ -3135,7 +3135,22 @@
               </a:defRPr>
             </a:pPr>
             <a:r>
-              <a:t>Prediksi Kelulusan Mahasiswa</a:t>
+              <a:t>PREDIKSI KELULUSAN MAHASISWA</a:t>
+            </a:r>
+          </a:p>
+          <a:p>
+            <a:pPr>
+              <a:spcBef>
+                <a:spcPts val="1000"/>
+              </a:spcBef>
+              <a:defRPr sz="2200">
+                <a:solidFill>
+                  <a:srgbClr val="CADCFC"/>
+                </a:solidFill>
+              </a:defRPr>
+            </a:pPr>
+            <a:r>
+              <a:t>Menggunakan Klasifikasi Machine Learning &amp; Optimasi Berbasis OBE</a:t>
             </a:r>
           </a:p>
         </p:txBody>
@@ -3148,8 +3163,8 @@
         </p:nvSpPr>
         <p:spPr>
           <a:xfrm>
-            <a:off x="731520" y="2743200"/>
-            <a:ext cx="10698480" cy="457200"/>
+            <a:off x="731520" y="3931920"/>
+            <a:ext cx="10698480" cy="1371600"/>
           </a:xfrm>
           <a:prstGeom prst="rect">
             <a:avLst/>
@@ -3163,53 +3178,25 @@
           <a:lstStyle/>
           <a:p>
             <a:pPr>
-              <a:defRPr sz="2800">
-                <a:solidFill>
-                  <a:srgbClr val="FFFFFF"/>
-                </a:solidFill>
-              </a:defRPr>
-            </a:pPr>
-            <a:r>
-              <a:t>Menggunakan Machine Learning</a:t>
-            </a:r>
-          </a:p>
-        </p:txBody>
-      </p:sp>
-      <p:sp>
-        <p:nvSpPr>
-          <p:cNvPr id="4" name="TextBox 3"/>
-          <p:cNvSpPr txBox="1"/>
-          <p:nvPr/>
-        </p:nvSpPr>
-        <p:spPr>
-          <a:xfrm>
-            <a:off x="731520" y="3840480"/>
-            <a:ext cx="10698480" cy="457200"/>
-          </a:xfrm>
-          <a:prstGeom prst="rect">
-            <a:avLst/>
-          </a:prstGeom>
-          <a:noFill/>
-        </p:spPr>
-        <p:txBody>
-          <a:bodyPr wrap="none">
-            <a:spAutoFit/>
-          </a:bodyPr>
-          <a:lstStyle/>
-          <a:p>
-            <a:pPr>
-              <a:defRPr sz="1800">
+              <a:spcBef>
+                <a:spcPts val="500"/>
+              </a:spcBef>
+              <a:defRPr sz="1600">
                 <a:solidFill>
                   <a:srgbClr val="CADCFC"/>
                 </a:solidFill>
               </a:defRPr>
             </a:pPr>
             <a:r>
-              <a:t>Na'ilah Azfa Zarqarida — A11.2024.15549</a:t>
+              <a:t>Oleh: Na'ilah Azfa Zarqarida (NIM: A11.2024.15549)</a:t>
             </a:r>
             <a:br/>
             <a:r>
-              <a:t>A11.4401 &amp; A11.4410 — UAS Pembelajaran Mesin</a:t>
+              <a:t>Kelompok: A11.4401 &amp; A11.4410 — Universitas Dian Nuswantoro</a:t>
+            </a:r>
+            <a:br/>
+            <a:r>
+              <a:t>UAS Pembelajaran Mesin 2026</a:t>
             </a:r>
           </a:p>
         </p:txBody>
@@ -3228,7 +3215,7 @@
     <p:bg>
       <p:bgPr>
         <a:solidFill>
-          <a:srgbClr val="1A5276"/>
+          <a:srgbClr val="1F2761"/>
         </a:solidFill>
         <a:effectLst/>
       </p:bgPr>
@@ -3248,8 +3235,8 @@
         </p:nvSpPr>
         <p:spPr>
           <a:xfrm>
-            <a:off x="731520" y="2286000"/>
-            <a:ext cx="10698480" cy="731520"/>
+            <a:off x="731520" y="2011680"/>
+            <a:ext cx="10698480" cy="2743200"/>
           </a:xfrm>
           <a:prstGeom prst="rect">
             <a:avLst/>
@@ -3262,85 +3249,60 @@
           </a:bodyPr>
           <a:lstStyle/>
           <a:p>
-            <a:pPr>
-              <a:defRPr sz="4400" b="1">
+            <a:pPr algn="ctr">
+              <a:defRPr sz="5400" b="1">
                 <a:solidFill>
                   <a:srgbClr val="FFFFFF"/>
                 </a:solidFill>
               </a:defRPr>
             </a:pPr>
             <a:r>
-              <a:t>Terima Kasih</a:t>
-            </a:r>
-          </a:p>
-        </p:txBody>
-      </p:sp>
-      <p:sp>
-        <p:nvSpPr>
-          <p:cNvPr id="3" name="TextBox 2"/>
-          <p:cNvSpPr txBox="1"/>
-          <p:nvPr/>
-        </p:nvSpPr>
-        <p:spPr>
-          <a:xfrm>
-            <a:off x="731520" y="3200400"/>
-            <a:ext cx="10698480" cy="457200"/>
-          </a:xfrm>
-          <a:prstGeom prst="rect">
-            <a:avLst/>
-          </a:prstGeom>
-          <a:noFill/>
-        </p:spPr>
-        <p:txBody>
-          <a:bodyPr wrap="none">
-            <a:spAutoFit/>
-          </a:bodyPr>
-          <a:lstStyle/>
-          <a:p>
-            <a:pPr>
+              <a:t>TERIMA KASIH</a:t>
+            </a:r>
+          </a:p>
+          <a:p>
+            <a:pPr algn="ctr">
+              <a:spcBef>
+                <a:spcPts val="1500"/>
+              </a:spcBef>
+              <a:defRPr sz="1600">
+                <a:solidFill>
+                  <a:srgbClr val="CADCFC"/>
+                </a:solidFill>
+              </a:defRPr>
+            </a:pPr>
+            <a:r>
+              <a:t>Seluruh source code, dataset, dan laporan lengkap dapat diakses pada repository GitHub:</a:t>
+            </a:r>
+          </a:p>
+          <a:p>
+            <a:pPr algn="ctr">
+              <a:spcBef>
+                <a:spcPts val="1000"/>
+              </a:spcBef>
+              <a:defRPr sz="2000" b="1">
+                <a:solidFill>
+                  <a:srgbClr val="FFFFFF"/>
+                </a:solidFill>
+              </a:defRPr>
+            </a:pPr>
+            <a:r>
+              <a:t>https://github.com/hafizmuzani011-collab/uas-ml-kelulusan</a:t>
+            </a:r>
+          </a:p>
+          <a:p>
+            <a:pPr algn="ctr">
+              <a:spcBef>
+                <a:spcPts val="2000"/>
+              </a:spcBef>
               <a:defRPr sz="1800">
                 <a:solidFill>
-                  <a:srgbClr val="FFFFFF"/>
-                </a:solidFill>
-              </a:defRPr>
-            </a:pPr>
-            <a:r>
-              <a:t>github.com/hafizmuzani011-collab/uas-ml-kelulusan</a:t>
-            </a:r>
-          </a:p>
-        </p:txBody>
-      </p:sp>
-      <p:sp>
-        <p:nvSpPr>
-          <p:cNvPr id="4" name="TextBox 3"/>
-          <p:cNvSpPr txBox="1"/>
-          <p:nvPr/>
-        </p:nvSpPr>
-        <p:spPr>
-          <a:xfrm>
-            <a:off x="731520" y="4114800"/>
-            <a:ext cx="10698480" cy="457200"/>
-          </a:xfrm>
-          <a:prstGeom prst="rect">
-            <a:avLst/>
-          </a:prstGeom>
-          <a:noFill/>
-        </p:spPr>
-        <p:txBody>
-          <a:bodyPr wrap="none">
-            <a:spAutoFit/>
-          </a:bodyPr>
-          <a:lstStyle/>
-          <a:p>
-            <a:pPr>
-              <a:defRPr sz="2000">
-                <a:solidFill>
-                  <a:srgbClr val="FFFFFF"/>
-                </a:solidFill>
-              </a:defRPr>
-            </a:pPr>
-            <a:r>
-              <a:t>Wassalamualaikum Wr. Wb.</a:t>
+                  <a:srgbClr val="CADCFC"/>
+                </a:solidFill>
+              </a:defRPr>
+            </a:pPr>
+            <a:r>
+              <a:t>Wassalamualaikum Warahmatullahi Wabarakatuh</a:t>
             </a:r>
           </a:p>
         </p:txBody>
@@ -3359,7 +3321,7 @@
     <p:bg>
       <p:bgPr>
         <a:solidFill>
-          <a:srgbClr val="2C3E50"/>
+          <a:srgbClr val="1F2761"/>
         </a:solidFill>
         <a:effectLst/>
       </p:bgPr>
@@ -3379,7 +3341,7 @@
         </p:nvSpPr>
         <p:spPr>
           <a:xfrm>
-            <a:off x="731520" y="274320"/>
+            <a:off x="731520" y="365760"/>
             <a:ext cx="10698480" cy="731520"/>
           </a:xfrm>
           <a:prstGeom prst="rect">
@@ -3388,7 +3350,7 @@
           <a:noFill/>
         </p:spPr>
         <p:txBody>
-          <a:bodyPr wrap="none">
+          <a:bodyPr wrap="square">
             <a:spAutoFit/>
           </a:bodyPr>
           <a:lstStyle/>
@@ -3401,7 +3363,7 @@
               </a:defRPr>
             </a:pPr>
             <a:r>
-              <a:t>Latar Belakang &amp; Tujuan</a:t>
+              <a:t>Latar Belakang &amp; Urgensi Masalah</a:t>
             </a:r>
           </a:p>
         </p:txBody>
@@ -3427,100 +3389,125 @@
             <a:spAutoFit/>
           </a:bodyPr>
           <a:lstStyle/>
+          <a:p/>
+          <a:p>
+            <a:pPr>
+              <a:spcBef>
+                <a:spcPts val="800"/>
+              </a:spcBef>
+              <a:defRPr sz="1800" b="1">
+                <a:solidFill>
+                  <a:srgbClr val="FFFFFF"/>
+                </a:solidFill>
+              </a:defRPr>
+            </a:pPr>
+            <a:r>
+              <a:t>🔴 Potret Krisis Dropout di Perguruan Tinggi</a:t>
+            </a:r>
+          </a:p>
           <a:p>
             <a:pPr>
               <a:spcAft>
-                <a:spcPts val="400"/>
+                <a:spcPts val="800"/>
               </a:spcAft>
-              <a:defRPr sz="1600" b="0">
-                <a:solidFill>
-                  <a:srgbClr val="F2F2F2"/>
-                </a:solidFill>
-              </a:defRPr>
-            </a:pPr>
-            <a:r>
-              <a:t>🔴 Dataset UCI: 39% mahasiswa dropout — masalah serius bagi institusi</a:t>
+              <a:defRPr sz="1400">
+                <a:solidFill>
+                  <a:srgbClr val="CADCFC"/>
+                </a:solidFill>
+              </a:defRPr>
+            </a:pPr>
+            <a:r>
+              <a:t>   Berdasarkan dataset UCI Academic Success, tercatat angka dropout mahasiswa mencapai 39% (dari total 4.424 mahasiswa). Ini menunjukkan kerentanan besar dalam proses studi mahasiswa.</a:t>
+            </a:r>
+          </a:p>
+          <a:p>
+            <a:pPr>
+              <a:spcBef>
+                <a:spcPts val="800"/>
+              </a:spcBef>
+              <a:defRPr sz="1800" b="1">
+                <a:solidFill>
+                  <a:srgbClr val="FFFFFF"/>
+                </a:solidFill>
+              </a:defRPr>
+            </a:pPr>
+            <a:r>
+              <a:t>🏫 Dampak Kritis bagi Institusi Pendidikan</a:t>
             </a:r>
           </a:p>
           <a:p>
             <a:pPr>
               <a:spcAft>
-                <a:spcPts val="400"/>
+                <a:spcPts val="800"/>
               </a:spcAft>
-              <a:defRPr sz="1600" b="0">
-                <a:solidFill>
-                  <a:srgbClr val="F2F2F2"/>
-                </a:solidFill>
-              </a:defRPr>
-            </a:pPr>
+              <a:defRPr sz="1400">
+                <a:solidFill>
+                  <a:srgbClr val="CADCFC"/>
+                </a:solidFill>
+              </a:defRPr>
+            </a:pPr>
+            <a:r>
+              <a:t>   Tingginya angka dropout merusak Indikator Kinerja Utama (IKU) universitas, menyebabkan inefisiensi alokasi anggaran, serta merugikan masa depan mahasiswa.</a:t>
+            </a:r>
+          </a:p>
+          <a:p>
+            <a:pPr>
+              <a:spcBef>
+                <a:spcPts val="800"/>
+              </a:spcBef>
+              <a:defRPr sz="1800" b="1">
+                <a:solidFill>
+                  <a:srgbClr val="FFFFFF"/>
+                </a:solidFill>
+              </a:defRPr>
+            </a:pPr>
+            <a:r>
+              <a:t>🎯 Solusi Prediksi Dini (Early Warning System)</a:t>
+            </a:r>
           </a:p>
           <a:p>
             <a:pPr>
               <a:spcAft>
-                <a:spcPts val="400"/>
+                <a:spcPts val="800"/>
               </a:spcAft>
-              <a:defRPr sz="1600" b="0">
-                <a:solidFill>
-                  <a:srgbClr val="F2F2F2"/>
-                </a:solidFill>
-              </a:defRPr>
-            </a:pPr>
-            <a:r>
-              <a:t>🎯 Tujuan: Sistem deteksi dini mahasiswa berisiko dropout</a:t>
+              <a:defRPr sz="1400">
+                <a:solidFill>
+                  <a:srgbClr val="CADCFC"/>
+                </a:solidFill>
+              </a:defRPr>
+            </a:pPr>
+            <a:r>
+              <a:t>   Project ini bertujuan mengembangkan sistem klasifikasi cerdas untuk mendeteksi risiko dropout secara otomatis sebelum semester akhir, agar dosen wali dapat melakukan pembinaan preventif.</a:t>
+            </a:r>
+          </a:p>
+          <a:p>
+            <a:pPr>
+              <a:spcBef>
+                <a:spcPts val="800"/>
+              </a:spcBef>
+              <a:defRPr sz="1800" b="1">
+                <a:solidFill>
+                  <a:srgbClr val="FFFFFF"/>
+                </a:solidFill>
+              </a:defRPr>
+            </a:pPr>
+            <a:r>
+              <a:t>📚 Keselarasan dengan OBE (Outcome-Based Education)</a:t>
             </a:r>
           </a:p>
           <a:p>
             <a:pPr>
               <a:spcAft>
-                <a:spcPts val="400"/>
+                <a:spcPts val="800"/>
               </a:spcAft>
-              <a:defRPr sz="1600" b="0">
-                <a:solidFill>
-                  <a:srgbClr val="F2F2F2"/>
-                </a:solidFill>
-              </a:defRPr>
-            </a:pPr>
-          </a:p>
-          <a:p>
-            <a:pPr>
-              <a:spcAft>
-                <a:spcPts val="400"/>
-              </a:spcAft>
-              <a:defRPr sz="1600" b="0">
-                <a:solidFill>
-                  <a:srgbClr val="F2F2F2"/>
-                </a:solidFill>
-              </a:defRPr>
-            </a:pPr>
-            <a:r>
-              <a:t>📌 OBE: CPL-8 (Analitik ML) &amp; CPL-10 (Etika Teknologi)</a:t>
-            </a:r>
-          </a:p>
-          <a:p>
-            <a:pPr>
-              <a:spcAft>
-                <a:spcPts val="400"/>
-              </a:spcAft>
-              <a:defRPr sz="1600" b="0">
-                <a:solidFill>
-                  <a:srgbClr val="F2F2F2"/>
-                </a:solidFill>
-              </a:defRPr>
-            </a:pPr>
-          </a:p>
-          <a:p>
-            <a:pPr>
-              <a:spcAft>
-                <a:spcPts val="400"/>
-              </a:spcAft>
-              <a:defRPr sz="1600" b="0">
-                <a:solidFill>
-                  <a:srgbClr val="F2F2F2"/>
-                </a:solidFill>
-              </a:defRPr>
-            </a:pPr>
-            <a:r>
-              <a:t>📊 Output: Klasifikasi Lulus Tepat Waktu vs Tidak Lulus</a:t>
+              <a:defRPr sz="1400">
+                <a:solidFill>
+                  <a:srgbClr val="CADCFC"/>
+                </a:solidFill>
+              </a:defRPr>
+            </a:pPr>
+            <a:r>
+              <a:t>   Memenuhi capaian pembelajaran CPL-8 (keterampilan analitik dan pemodelan machine learning) serta CPL-10 (pemahaman dampak etis dan tanggung jawab sosial pemanfaatan AI).</a:t>
             </a:r>
           </a:p>
         </p:txBody>
@@ -3559,7 +3546,7 @@
         </p:nvSpPr>
         <p:spPr>
           <a:xfrm>
-            <a:off x="731520" y="274320"/>
+            <a:off x="731520" y="365760"/>
             <a:ext cx="10698480" cy="731520"/>
           </a:xfrm>
           <a:prstGeom prst="rect">
@@ -3568,7 +3555,7 @@
           <a:noFill/>
         </p:spPr>
         <p:txBody>
-          <a:bodyPr wrap="none">
+          <a:bodyPr wrap="square">
             <a:spAutoFit/>
           </a:bodyPr>
           <a:lstStyle/>
@@ -3581,7 +3568,7 @@
               </a:defRPr>
             </a:pPr>
             <a:r>
-              <a:t>Dataset &amp; Preprocessing</a:t>
+              <a:t>Dataset &amp; Data Preprocessing Pipeline</a:t>
             </a:r>
           </a:p>
         </p:txBody>
@@ -3594,8 +3581,8 @@
         </p:nvSpPr>
         <p:spPr>
           <a:xfrm>
-            <a:off x="731520" y="1371600"/>
-            <a:ext cx="10698480" cy="4572000"/>
+            <a:off x="731520" y="1280160"/>
+            <a:ext cx="10698480" cy="4754880"/>
           </a:xfrm>
           <a:prstGeom prst="rect">
             <a:avLst/>
@@ -3607,156 +3594,155 @@
             <a:spAutoFit/>
           </a:bodyPr>
           <a:lstStyle/>
+          <a:p/>
+          <a:p>
+            <a:pPr>
+              <a:spcBef>
+                <a:spcPts val="600"/>
+              </a:spcBef>
+              <a:defRPr sz="1600" b="1">
+                <a:solidFill>
+                  <a:srgbClr val="2C3E50"/>
+                </a:solidFill>
+              </a:defRPr>
+            </a:pPr>
+            <a:r>
+              <a:t>1. Dataset &amp; Filtering</a:t>
+            </a:r>
+          </a:p>
           <a:p>
             <a:pPr>
               <a:spcAft>
-                <a:spcPts val="400"/>
+                <a:spcPts val="600"/>
               </a:spcAft>
-              <a:defRPr sz="1600" b="0">
+              <a:defRPr sz="1300">
+                <a:solidFill>
+                  <a:srgbClr val="7F8C8D"/>
+                </a:solidFill>
+              </a:defRPr>
+            </a:pPr>
+            <a:r>
+              <a:t>   Menggunakan dataset UCI 'Predict Students Dropout'. Data Enrolled disaring keluar sehingga menyisakan 3.630 baris data biner: Kelas 1 (Graduate) vs Kelas 0 (Dropout).</a:t>
+            </a:r>
+          </a:p>
+          <a:p>
+            <a:pPr>
+              <a:spcBef>
+                <a:spcPts val="600"/>
+              </a:spcBef>
+              <a:defRPr sz="1600" b="1">
                 <a:solidFill>
                   <a:srgbClr val="2C3E50"/>
                 </a:solidFill>
               </a:defRPr>
             </a:pPr>
             <a:r>
-              <a:t>📦 Sumber: UCI Predict Students Dropout (4.424 → 3.630 baris)</a:t>
+              <a:t>2. Seleksi 10 Fitur Terbaik (Mutual Information)</a:t>
             </a:r>
           </a:p>
           <a:p>
             <a:pPr>
               <a:spcAft>
-                <a:spcPts val="400"/>
+                <a:spcPts val="600"/>
               </a:spcAft>
-              <a:defRPr sz="1600" b="0">
+              <a:defRPr sz="1300">
+                <a:solidFill>
+                  <a:srgbClr val="7F8C8D"/>
+                </a:solidFill>
+              </a:defRPr>
+            </a:pPr>
+            <a:r>
+              <a:t>   Fitur dipilih berdasarkan skor informasi timbal-balik tertinggi, seperti IPK Semester 1-2, SKS yang disetujui, Usia saat mendaftar, Status pembayaran UKT, dan Penerima Beasiswa.</a:t>
+            </a:r>
+          </a:p>
+          <a:p>
+            <a:pPr>
+              <a:spcBef>
+                <a:spcPts val="600"/>
+              </a:spcBef>
+              <a:defRPr sz="1600" b="1">
                 <a:solidFill>
                   <a:srgbClr val="2C3E50"/>
                 </a:solidFill>
               </a:defRPr>
             </a:pPr>
+            <a:r>
+              <a:t>3. Stratified Data Splitting (80/20)</a:t>
+            </a:r>
           </a:p>
           <a:p>
             <a:pPr>
               <a:spcAft>
-                <a:spcPts val="400"/>
+                <a:spcPts val="600"/>
               </a:spcAft>
-              <a:defRPr sz="1600" b="0">
+              <a:defRPr sz="1300">
+                <a:solidFill>
+                  <a:srgbClr val="7F8C8D"/>
+                </a:solidFill>
+              </a:defRPr>
+            </a:pPr>
+            <a:r>
+              <a:t>   Pemisahan data training (2.904 baris) dan testing (726 baris) dengan mempertahankan proporsi kelas asli untuk menjaga objektivitas evaluasi.</a:t>
+            </a:r>
+          </a:p>
+          <a:p>
+            <a:pPr>
+              <a:spcBef>
+                <a:spcPts val="600"/>
+              </a:spcBef>
+              <a:defRPr sz="1600" b="1">
                 <a:solidFill>
                   <a:srgbClr val="2C3E50"/>
                 </a:solidFill>
               </a:defRPr>
             </a:pPr>
             <a:r>
-              <a:t>🔧 Pipeline:</a:t>
+              <a:t>4. Robust Scaling (StandardScaler)</a:t>
             </a:r>
           </a:p>
           <a:p>
             <a:pPr>
               <a:spcAft>
-                <a:spcPts val="400"/>
+                <a:spcPts val="600"/>
               </a:spcAft>
-              <a:defRPr sz="1600" b="0">
+              <a:defRPr sz="1300">
+                <a:solidFill>
+                  <a:srgbClr val="7F8C8D"/>
+                </a:solidFill>
+              </a:defRPr>
+            </a:pPr>
+            <a:r>
+              <a:t>   Normalisasi semua fitur numerik agar tidak ada bias rentang nilai pada KNN dan SVM. Parameter fit hanya diambil dari training set.</a:t>
+            </a:r>
+          </a:p>
+          <a:p>
+            <a:pPr>
+              <a:spcBef>
+                <a:spcPts val="600"/>
+              </a:spcBef>
+              <a:defRPr sz="1600" b="1">
                 <a:solidFill>
                   <a:srgbClr val="2C3E50"/>
                 </a:solidFill>
               </a:defRPr>
             </a:pPr>
             <a:r>
-              <a:t>  1. Filter Enrolled → 3.630 data biner (Graduate/Dropout)</a:t>
+              <a:t>5. Class Imbalance Handling (SMOTE)</a:t>
             </a:r>
           </a:p>
           <a:p>
             <a:pPr>
               <a:spcAft>
-                <a:spcPts val="400"/>
+                <a:spcPts val="600"/>
               </a:spcAft>
-              <a:defRPr sz="1600" b="0">
-                <a:solidFill>
-                  <a:srgbClr val="2C3E50"/>
-                </a:solidFill>
-              </a:defRPr>
-            </a:pPr>
-            <a:r>
-              <a:t>  2. Feature Selection: 10 fitur via Mutual Information</a:t>
-            </a:r>
-          </a:p>
-          <a:p>
-            <a:pPr>
-              <a:spcAft>
-                <a:spcPts val="400"/>
-              </a:spcAft>
-              <a:defRPr sz="1600" b="0">
-                <a:solidFill>
-                  <a:srgbClr val="2C3E50"/>
-                </a:solidFill>
-              </a:defRPr>
-            </a:pPr>
-            <a:r>
-              <a:t>  3. Train-Test Split: 80/20 (stratified)</a:t>
-            </a:r>
-          </a:p>
-          <a:p>
-            <a:pPr>
-              <a:spcAft>
-                <a:spcPts val="400"/>
-              </a:spcAft>
-              <a:defRPr sz="1600" b="0">
-                <a:solidFill>
-                  <a:srgbClr val="2C3E50"/>
-                </a:solidFill>
-              </a:defRPr>
-            </a:pPr>
-            <a:r>
-              <a:t>  4. StandardScaler: Normalisasi fitur numerik</a:t>
-            </a:r>
-          </a:p>
-          <a:p>
-            <a:pPr>
-              <a:spcAft>
-                <a:spcPts val="400"/>
-              </a:spcAft>
-              <a:defRPr sz="1600" b="0">
-                <a:solidFill>
-                  <a:srgbClr val="2C3E50"/>
-                </a:solidFill>
-              </a:defRPr>
-            </a:pPr>
-            <a:r>
-              <a:t>  5. SMOTE: Synthetic oversampling (hanya data training)</a:t>
-            </a:r>
-          </a:p>
-        </p:txBody>
-      </p:sp>
-      <p:sp>
-        <p:nvSpPr>
-          <p:cNvPr id="4" name="TextBox 3"/>
-          <p:cNvSpPr txBox="1"/>
-          <p:nvPr/>
-        </p:nvSpPr>
-        <p:spPr>
-          <a:xfrm>
-            <a:off x="731520" y="5303520"/>
-            <a:ext cx="10698480" cy="457200"/>
-          </a:xfrm>
-          <a:prstGeom prst="rect">
-            <a:avLst/>
-          </a:prstGeom>
-          <a:noFill/>
-        </p:spPr>
-        <p:txBody>
-          <a:bodyPr wrap="none">
-            <a:spAutoFit/>
-          </a:bodyPr>
-          <a:lstStyle/>
-          <a:p>
-            <a:pPr>
-              <a:defRPr sz="1600">
-                <a:solidFill>
-                  <a:srgbClr val="028090"/>
-                </a:solidFill>
-              </a:defRPr>
-            </a:pPr>
-            <a:r>
-              <a:t>✅ Tidak ada data leakage (split sebelum SMOTE)</a:t>
+              <a:defRPr sz="1300">
+                <a:solidFill>
+                  <a:srgbClr val="7F8C8D"/>
+                </a:solidFill>
+              </a:defRPr>
+            </a:pPr>
+            <a:r>
+              <a:t>   Penerapan SMOTE pada data training untuk menyeimbangkan kelas minoritas (Dropout) secara sintetis menjadi 50:50. Data test dibiarkan murni.</a:t>
             </a:r>
           </a:p>
         </p:txBody>
@@ -3775,7 +3761,7 @@
     <p:bg>
       <p:bgPr>
         <a:solidFill>
-          <a:srgbClr val="028090"/>
+          <a:srgbClr val="1F2761"/>
         </a:solidFill>
         <a:effectLst/>
       </p:bgPr>
@@ -3795,7 +3781,7 @@
         </p:nvSpPr>
         <p:spPr>
           <a:xfrm>
-            <a:off x="731520" y="274320"/>
+            <a:off x="731520" y="365760"/>
             <a:ext cx="10698480" cy="731520"/>
           </a:xfrm>
           <a:prstGeom prst="rect">
@@ -3804,7 +3790,7 @@
           <a:noFill/>
         </p:spPr>
         <p:txBody>
-          <a:bodyPr wrap="none">
+          <a:bodyPr wrap="square">
             <a:spAutoFit/>
           </a:bodyPr>
           <a:lstStyle/>
@@ -3817,7 +3803,7 @@
               </a:defRPr>
             </a:pPr>
             <a:r>
-              <a:t>Desain Eksperimen</a:t>
+              <a:t>Desain Eksperimen &amp; Strategi Optimasi</a:t>
             </a:r>
           </a:p>
         </p:txBody>
@@ -3843,148 +3829,124 @@
             <a:spAutoFit/>
           </a:bodyPr>
           <a:lstStyle/>
-          <a:p>
-            <a:pPr>
+          <a:p/>
+          <a:p>
+            <a:pPr>
+              <a:spcBef>
+                <a:spcPts val="800"/>
+              </a:spcBef>
+              <a:defRPr sz="1700" b="1">
+                <a:solidFill>
+                  <a:srgbClr val="FFFFFF"/>
+                </a:solidFill>
+              </a:defRPr>
+            </a:pPr>
+            <a:r>
+              <a:t>📊 Tiga Model Klasifikasi</a:t>
+            </a:r>
+          </a:p>
+          <a:p>
+            <a:pPr>
+              <a:spcBef>
+                <a:spcPts val="300"/>
+              </a:spcBef>
               <a:spcAft>
-                <a:spcPts val="400"/>
+                <a:spcPts val="800"/>
               </a:spcAft>
-              <a:defRPr sz="1600" b="0">
+              <a:defRPr sz="1300">
+                <a:solidFill>
+                  <a:srgbClr val="CADCFC"/>
+                </a:solidFill>
+              </a:defRPr>
+            </a:pPr>
+            <a:r>
+              <a:t>1) K-Nearest Neighbors (KNN)</a:t>
+            </a:r>
+            <a:br/>
+            <a:r>
+              <a:t>2) Naive Bayes (GaussianNB)</a:t>
+            </a:r>
+            <a:br/>
+            <a:r>
+              <a:t>3) Support Vector Machine (SVM) dengan Kernel RBF</a:t>
+            </a:r>
+          </a:p>
+          <a:p>
+            <a:pPr>
+              <a:spcBef>
+                <a:spcPts val="800"/>
+              </a:spcBef>
+              <a:defRPr sz="1700" b="1">
                 <a:solidFill>
                   <a:srgbClr val="FFFFFF"/>
                 </a:solidFill>
               </a:defRPr>
             </a:pPr>
             <a:r>
-              <a:t>3 MODEL BASELINE</a:t>
-            </a:r>
-          </a:p>
-          <a:p>
-            <a:pPr>
+              <a:t>⚙️ Empat Strategi Optimasi Utama</a:t>
+            </a:r>
+          </a:p>
+          <a:p>
+            <a:pPr>
+              <a:spcBef>
+                <a:spcPts val="300"/>
+              </a:spcBef>
               <a:spcAft>
-                <a:spcPts val="400"/>
+                <a:spcPts val="800"/>
               </a:spcAft>
-              <a:defRPr sz="1600" b="0">
+              <a:defRPr sz="1300">
+                <a:solidFill>
+                  <a:srgbClr val="CADCFC"/>
+                </a:solidFill>
+              </a:defRPr>
+            </a:pPr>
+            <a:r>
+              <a:t>• Hyperparameter Tuning: GridSearchCV mencari parameter K terbaik pada KNN, smoothing parameter pada NB, dan parameter regulasi C pada SVM.</a:t>
+            </a:r>
+            <a:br/>
+            <a:r>
+              <a:t>• Cross-Validation: 5-Fold Stratified CV digunakan untuk menjamin generalisasi parameter.</a:t>
+            </a:r>
+            <a:br/>
+            <a:r>
+              <a:t>• Dimensionality/Feature Selection: Seleksi 10 fitur Mutual Information.</a:t>
+            </a:r>
+            <a:br/>
+            <a:r>
+              <a:t>• Class Balancing: SMOTE oversampling.</a:t>
+            </a:r>
+          </a:p>
+          <a:p>
+            <a:pPr>
+              <a:spcBef>
+                <a:spcPts val="800"/>
+              </a:spcBef>
+              <a:defRPr sz="1700" b="1">
                 <a:solidFill>
                   <a:srgbClr val="FFFFFF"/>
                 </a:solidFill>
               </a:defRPr>
             </a:pPr>
             <a:r>
-              <a:t>   • KNN (k=5)  • Naive Bayes Gaussian  • SVM (RBF, class_weight=balanced)</a:t>
-            </a:r>
-          </a:p>
-          <a:p>
-            <a:pPr>
+              <a:t>📈 Pemilihan Metrik Utama (F1-Macro &amp; Balanced Accuracy)</a:t>
+            </a:r>
+          </a:p>
+          <a:p>
+            <a:pPr>
+              <a:spcBef>
+                <a:spcPts val="300"/>
+              </a:spcBef>
               <a:spcAft>
-                <a:spcPts val="400"/>
+                <a:spcPts val="800"/>
               </a:spcAft>
-              <a:defRPr sz="1600" b="0">
-                <a:solidFill>
-                  <a:srgbClr val="FFFFFF"/>
-                </a:solidFill>
-              </a:defRPr>
-            </a:pPr>
-          </a:p>
-          <a:p>
-            <a:pPr>
-              <a:spcAft>
-                <a:spcPts val="400"/>
-              </a:spcAft>
-              <a:defRPr sz="1600" b="0">
-                <a:solidFill>
-                  <a:srgbClr val="FFFFFF"/>
-                </a:solidFill>
-              </a:defRPr>
-            </a:pPr>
-            <a:r>
-              <a:t>4 STRATEGI OPTIMASI</a:t>
-            </a:r>
-          </a:p>
-          <a:p>
-            <a:pPr>
-              <a:spcAft>
-                <a:spcPts val="400"/>
-              </a:spcAft>
-              <a:defRPr sz="1600" b="0">
-                <a:solidFill>
-                  <a:srgbClr val="FFFFFF"/>
-                </a:solidFill>
-              </a:defRPr>
-            </a:pPr>
-            <a:r>
-              <a:t>   1️⃣ Hyperparameter Tuning (GridSearchCV)</a:t>
-            </a:r>
-          </a:p>
-          <a:p>
-            <a:pPr>
-              <a:spcAft>
-                <a:spcPts val="400"/>
-              </a:spcAft>
-              <a:defRPr sz="1600" b="0">
-                <a:solidFill>
-                  <a:srgbClr val="FFFFFF"/>
-                </a:solidFill>
-              </a:defRPr>
-            </a:pPr>
-            <a:r>
-              <a:t>   2️⃣ Stratified K-Fold Cross Validation (k=5)</a:t>
-            </a:r>
-          </a:p>
-          <a:p>
-            <a:pPr>
-              <a:spcAft>
-                <a:spcPts val="400"/>
-              </a:spcAft>
-              <a:defRPr sz="1600" b="0">
-                <a:solidFill>
-                  <a:srgbClr val="FFFFFF"/>
-                </a:solidFill>
-              </a:defRPr>
-            </a:pPr>
-            <a:r>
-              <a:t>   3️⃣ Feature Selection (Mutual Information)</a:t>
-            </a:r>
-          </a:p>
-          <a:p>
-            <a:pPr>
-              <a:spcAft>
-                <a:spcPts val="400"/>
-              </a:spcAft>
-              <a:defRPr sz="1600" b="0">
-                <a:solidFill>
-                  <a:srgbClr val="FFFFFF"/>
-                </a:solidFill>
-              </a:defRPr>
-            </a:pPr>
-            <a:r>
-              <a:t>   4️⃣ SMOTE (Class Imbalance Handling)</a:t>
-            </a:r>
-          </a:p>
-          <a:p>
-            <a:pPr>
-              <a:spcAft>
-                <a:spcPts val="400"/>
-              </a:spcAft>
-              <a:defRPr sz="1600" b="0">
-                <a:solidFill>
-                  <a:srgbClr val="FFFFFF"/>
-                </a:solidFill>
-              </a:defRPr>
-            </a:pPr>
-          </a:p>
-          <a:p>
-            <a:pPr>
-              <a:spcAft>
-                <a:spcPts val="400"/>
-              </a:spcAft>
-              <a:defRPr sz="1600" b="0">
-                <a:solidFill>
-                  <a:srgbClr val="FFFFFF"/>
-                </a:solidFill>
-              </a:defRPr>
-            </a:pPr>
-            <a:r>
-              <a:t>📐 Scoring Utama: f1_macro (bukan accuracy)</a:t>
+              <a:defRPr sz="1300">
+                <a:solidFill>
+                  <a:srgbClr val="CADCFC"/>
+                </a:solidFill>
+              </a:defRPr>
+            </a:pPr>
+            <a:r>
+              <a:t>Metrik F1-Macro dipilih sebagai metrik prioritas pengganti akurasi karena mampu menilai keadilan model terhadap kedua kelas target secara seimbang (tidak bias mayoritas).</a:t>
             </a:r>
           </a:p>
         </p:txBody>
@@ -4023,7 +3985,7 @@
         </p:nvSpPr>
         <p:spPr>
           <a:xfrm>
-            <a:off x="731520" y="274320"/>
+            <a:off x="731520" y="365760"/>
             <a:ext cx="10698480" cy="731520"/>
           </a:xfrm>
           <a:prstGeom prst="rect">
@@ -4032,7 +3994,7 @@
           <a:noFill/>
         </p:spPr>
         <p:txBody>
-          <a:bodyPr wrap="none">
+          <a:bodyPr wrap="square">
             <a:spAutoFit/>
           </a:bodyPr>
           <a:lstStyle/>
@@ -4045,7 +4007,7 @@
               </a:defRPr>
             </a:pPr>
             <a:r>
-              <a:t>Hasil Baseline vs Optimized</a:t>
+              <a:t>Hasil Eksperimen &amp; Model Terbaik</a:t>
             </a:r>
           </a:p>
         </p:txBody>
@@ -4059,8 +4021,8 @@
           <p:nvPr/>
         </p:nvGraphicFramePr>
         <p:xfrm>
-          <a:off x="731520" y="1645920"/>
-          <a:ext cx="10607040" cy="3200400"/>
+          <a:off x="731520" y="1371600"/>
+          <a:ext cx="5303520" cy="3474720"/>
         </p:xfrm>
         <a:graphic>
           <a:graphicData uri="http://schemas.openxmlformats.org/drawingml/2006/table">
@@ -4069,18 +4031,18 @@
                 <a:tableStyleId>{5C22544A-7EE6-4342-B048-85BDC9FD1C3A}</a:tableStyleId>
               </a:tblPr>
               <a:tblGrid>
-                <a:gridCol w="4572000"/>
-                <a:gridCol w="3017520"/>
-                <a:gridCol w="3017520"/>
+                <a:gridCol w="2377440"/>
+                <a:gridCol w="1463040"/>
+                <a:gridCol w="1463040"/>
               </a:tblGrid>
-              <a:tr h="457200">
+              <a:tr h="496388">
                 <a:tc>
                   <a:txBody>
                     <a:bodyPr/>
                     <a:lstStyle/>
                     <a:p>
                       <a:pPr algn="l">
-                        <a:defRPr sz="1400" b="1">
+                        <a:defRPr sz="1200" b="1">
                           <a:solidFill>
                             <a:srgbClr val="FFFFFF"/>
                           </a:solidFill>
@@ -4103,7 +4065,7 @@
                     <a:lstStyle/>
                     <a:p>
                       <a:pPr algn="ctr">
-                        <a:defRPr sz="1400" b="1">
+                        <a:defRPr sz="1200" b="1">
                           <a:solidFill>
                             <a:srgbClr val="FFFFFF"/>
                           </a:solidFill>
@@ -4126,7 +4088,7 @@
                     <a:lstStyle/>
                     <a:p>
                       <a:pPr algn="ctr">
-                        <a:defRPr sz="1400" b="1">
+                        <a:defRPr sz="1200" b="1">
                           <a:solidFill>
                             <a:srgbClr val="FFFFFF"/>
                           </a:solidFill>
@@ -4144,14 +4106,14 @@
                   </a:tcPr>
                 </a:tc>
               </a:tr>
-              <a:tr h="457200">
+              <a:tr h="496388">
                 <a:tc>
                   <a:txBody>
                     <a:bodyPr/>
                     <a:lstStyle/>
                     <a:p>
                       <a:pPr algn="l">
-                        <a:defRPr sz="1400"/>
+                        <a:defRPr sz="1200"/>
                       </a:pPr>
                       <a:r>
                         <a:t>KNN Baseline</a:t>
@@ -4166,7 +4128,7 @@
                     <a:lstStyle/>
                     <a:p>
                       <a:pPr algn="ctr">
-                        <a:defRPr sz="1400"/>
+                        <a:defRPr sz="1200"/>
                       </a:pPr>
                       <a:r>
                         <a:t>0.869</a:t>
@@ -4181,7 +4143,7 @@
                     <a:lstStyle/>
                     <a:p>
                       <a:pPr algn="ctr">
-                        <a:defRPr sz="1400"/>
+                        <a:defRPr sz="1200"/>
                       </a:pPr>
                       <a:r>
                         <a:t>0.879</a:t>
@@ -4191,14 +4153,14 @@
                   <a:tcPr/>
                 </a:tc>
               </a:tr>
-              <a:tr h="457200">
+              <a:tr h="496388">
                 <a:tc>
                   <a:txBody>
                     <a:bodyPr/>
                     <a:lstStyle/>
                     <a:p>
                       <a:pPr algn="l">
-                        <a:defRPr sz="1400"/>
+                        <a:defRPr sz="1200"/>
                       </a:pPr>
                       <a:r>
                         <a:t>Naive Bayes Baseline</a:t>
@@ -4207,7 +4169,7 @@
                   </a:txBody>
                   <a:tcPr>
                     <a:solidFill>
-                      <a:srgbClr val="ECF0F1"/>
+                      <a:srgbClr val="F9F9F9"/>
                     </a:solidFill>
                   </a:tcPr>
                 </a:tc>
@@ -4217,7 +4179,7 @@
                     <a:lstStyle/>
                     <a:p>
                       <a:pPr algn="ctr">
-                        <a:defRPr sz="1400"/>
+                        <a:defRPr sz="1200"/>
                       </a:pPr>
                       <a:r>
                         <a:t>0.829</a:t>
@@ -4226,7 +4188,7 @@
                   </a:txBody>
                   <a:tcPr>
                     <a:solidFill>
-                      <a:srgbClr val="ECF0F1"/>
+                      <a:srgbClr val="F9F9F9"/>
                     </a:solidFill>
                   </a:tcPr>
                 </a:tc>
@@ -4236,7 +4198,7 @@
                     <a:lstStyle/>
                     <a:p>
                       <a:pPr algn="ctr">
-                        <a:defRPr sz="1400"/>
+                        <a:defRPr sz="1200"/>
                       </a:pPr>
                       <a:r>
                         <a:t>0.844</a:t>
@@ -4245,19 +4207,19 @@
                   </a:txBody>
                   <a:tcPr>
                     <a:solidFill>
-                      <a:srgbClr val="ECF0F1"/>
+                      <a:srgbClr val="F9F9F9"/>
                     </a:solidFill>
                   </a:tcPr>
                 </a:tc>
               </a:tr>
-              <a:tr h="457200">
+              <a:tr h="496388">
                 <a:tc>
                   <a:txBody>
                     <a:bodyPr/>
                     <a:lstStyle/>
                     <a:p>
                       <a:pPr algn="l">
-                        <a:defRPr sz="1400" b="1"/>
+                        <a:defRPr sz="1200" b="1"/>
                       </a:pPr>
                       <a:r>
                         <a:t>SVM Baseline 🏆</a:t>
@@ -4276,7 +4238,7 @@
                     <a:lstStyle/>
                     <a:p>
                       <a:pPr algn="ctr">
-                        <a:defRPr sz="1400" b="1"/>
+                        <a:defRPr sz="1200" b="1"/>
                       </a:pPr>
                       <a:r>
                         <a:t>0.887</a:t>
@@ -4295,7 +4257,7 @@
                     <a:lstStyle/>
                     <a:p>
                       <a:pPr algn="ctr">
-                        <a:defRPr sz="1400" b="1"/>
+                        <a:defRPr sz="1200" b="1"/>
                       </a:pPr>
                       <a:r>
                         <a:t>0.894</a:t>
@@ -4309,14 +4271,14 @@
                   </a:tcPr>
                 </a:tc>
               </a:tr>
-              <a:tr h="457200">
+              <a:tr h="496388">
                 <a:tc>
                   <a:txBody>
                     <a:bodyPr/>
                     <a:lstStyle/>
                     <a:p>
                       <a:pPr algn="l">
-                        <a:defRPr sz="1400"/>
+                        <a:defRPr sz="1200"/>
                       </a:pPr>
                       <a:r>
                         <a:t>KNN Optimized</a:t>
@@ -4325,7 +4287,7 @@
                   </a:txBody>
                   <a:tcPr>
                     <a:solidFill>
-                      <a:srgbClr val="ECF0F1"/>
+                      <a:srgbClr val="F9F9F9"/>
                     </a:solidFill>
                   </a:tcPr>
                 </a:tc>
@@ -4335,7 +4297,7 @@
                     <a:lstStyle/>
                     <a:p>
                       <a:pPr algn="ctr">
-                        <a:defRPr sz="1400"/>
+                        <a:defRPr sz="1200"/>
                       </a:pPr>
                       <a:r>
                         <a:t>0.876</a:t>
@@ -4344,7 +4306,7 @@
                   </a:txBody>
                   <a:tcPr>
                     <a:solidFill>
-                      <a:srgbClr val="ECF0F1"/>
+                      <a:srgbClr val="F9F9F9"/>
                     </a:solidFill>
                   </a:tcPr>
                 </a:tc>
@@ -4354,7 +4316,7 @@
                     <a:lstStyle/>
                     <a:p>
                       <a:pPr algn="ctr">
-                        <a:defRPr sz="1400"/>
+                        <a:defRPr sz="1200"/>
                       </a:pPr>
                       <a:r>
                         <a:t>0.884</a:t>
@@ -4363,19 +4325,19 @@
                   </a:txBody>
                   <a:tcPr>
                     <a:solidFill>
-                      <a:srgbClr val="ECF0F1"/>
+                      <a:srgbClr val="F9F9F9"/>
                     </a:solidFill>
                   </a:tcPr>
                 </a:tc>
               </a:tr>
-              <a:tr h="457200">
+              <a:tr h="496388">
                 <a:tc>
                   <a:txBody>
                     <a:bodyPr/>
                     <a:lstStyle/>
                     <a:p>
                       <a:pPr algn="l">
-                        <a:defRPr sz="1400"/>
+                        <a:defRPr sz="1200"/>
                       </a:pPr>
                       <a:r>
                         <a:t>Naive Bayes Optimized</a:t>
@@ -4390,7 +4352,7 @@
                     <a:lstStyle/>
                     <a:p>
                       <a:pPr algn="ctr">
-                        <a:defRPr sz="1400"/>
+                        <a:defRPr sz="1200"/>
                       </a:pPr>
                       <a:r>
                         <a:t>0.838</a:t>
@@ -4405,7 +4367,7 @@
                     <a:lstStyle/>
                     <a:p>
                       <a:pPr algn="ctr">
-                        <a:defRPr sz="1400"/>
+                        <a:defRPr sz="1200"/>
                       </a:pPr>
                       <a:r>
                         <a:t>0.853</a:t>
@@ -4415,14 +4377,14 @@
                   <a:tcPr/>
                 </a:tc>
               </a:tr>
-              <a:tr h="457200">
+              <a:tr h="496392">
                 <a:tc>
                   <a:txBody>
                     <a:bodyPr/>
                     <a:lstStyle/>
                     <a:p>
                       <a:pPr algn="l">
-                        <a:defRPr sz="1400"/>
+                        <a:defRPr sz="1200"/>
                       </a:pPr>
                       <a:r>
                         <a:t>SVM Optimized</a:t>
@@ -4431,7 +4393,7 @@
                   </a:txBody>
                   <a:tcPr>
                     <a:solidFill>
-                      <a:srgbClr val="ECF0F1"/>
+                      <a:srgbClr val="F9F9F9"/>
                     </a:solidFill>
                   </a:tcPr>
                 </a:tc>
@@ -4441,7 +4403,7 @@
                     <a:lstStyle/>
                     <a:p>
                       <a:pPr algn="ctr">
-                        <a:defRPr sz="1400"/>
+                        <a:defRPr sz="1200"/>
                       </a:pPr>
                       <a:r>
                         <a:t>0.884</a:t>
@@ -4450,7 +4412,7 @@
                   </a:txBody>
                   <a:tcPr>
                     <a:solidFill>
-                      <a:srgbClr val="ECF0F1"/>
+                      <a:srgbClr val="F9F9F9"/>
                     </a:solidFill>
                   </a:tcPr>
                 </a:tc>
@@ -4460,7 +4422,7 @@
                     <a:lstStyle/>
                     <a:p>
                       <a:pPr algn="ctr">
-                        <a:defRPr sz="1400"/>
+                        <a:defRPr sz="1200"/>
                       </a:pPr>
                       <a:r>
                         <a:t>0.891</a:t>
@@ -4469,7 +4431,7 @@
                   </a:txBody>
                   <a:tcPr>
                     <a:solidFill>
-                      <a:srgbClr val="ECF0F1"/>
+                      <a:srgbClr val="F9F9F9"/>
                     </a:solidFill>
                   </a:tcPr>
                 </a:tc>
@@ -4478,16 +4440,40 @@
           </a:graphicData>
         </a:graphic>
       </p:graphicFrame>
-      <p:sp>
-        <p:nvSpPr>
-          <p:cNvPr id="4" name="TextBox 3"/>
+      <p:pic>
+        <p:nvPicPr>
+          <p:cNvPr id="4" name="Picture 3" descr="performance_comparison.png"/>
+          <p:cNvPicPr>
+            <a:picLocks noChangeAspect="1"/>
+          </p:cNvPicPr>
+          <p:nvPr/>
+        </p:nvPicPr>
+        <p:blipFill>
+          <a:blip r:embed="rId2"/>
+          <a:stretch>
+            <a:fillRect/>
+          </a:stretch>
+        </p:blipFill>
+        <p:spPr>
+          <a:xfrm>
+            <a:off x="6400800" y="1371600"/>
+            <a:ext cx="5029200" cy="2828925"/>
+          </a:xfrm>
+          <a:prstGeom prst="rect">
+            <a:avLst/>
+          </a:prstGeom>
+        </p:spPr>
+      </p:pic>
+      <p:sp>
+        <p:nvSpPr>
+          <p:cNvPr id="5" name="TextBox 4"/>
           <p:cNvSpPr txBox="1"/>
           <p:nvPr/>
         </p:nvSpPr>
         <p:spPr>
           <a:xfrm>
             <a:off x="731520" y="5120640"/>
-            <a:ext cx="10698480" cy="457200"/>
+            <a:ext cx="10698480" cy="1097280"/>
           </a:xfrm>
           <a:prstGeom prst="rect">
             <a:avLst/>
@@ -4501,14 +4487,18 @@
           <a:lstStyle/>
           <a:p>
             <a:pPr>
-              <a:defRPr sz="1800">
-                <a:solidFill>
-                  <a:srgbClr val="028090"/>
-                </a:solidFill>
-              </a:defRPr>
-            </a:pPr>
-            <a:r>
-              <a:t>🏆 Model Terbaik: SVM Baseline (kernel RBF + class_weight=balanced)</a:t>
+              <a:defRPr sz="1300" b="1">
+                <a:solidFill>
+                  <a:srgbClr val="2C3E50"/>
+                </a:solidFill>
+              </a:defRPr>
+            </a:pPr>
+            <a:r>
+              <a:t>🏆 MODEL TERBAIK: SVM Baseline (Kernel RBF, C=1.0, class_weight='balanced') dengan F1-Macro 0.8869.</a:t>
+            </a:r>
+            <a:br/>
+            <a:r>
+              <a:t>Optimasi eksternal (SMOTE + 8 fitur) mengalami sedikit degradasi F1 (0.884) karena hilangnya beberapa informasi prediktif.</a:t>
             </a:r>
           </a:p>
         </p:txBody>
@@ -4522,219 +4512,6 @@
 </file>
 
 <file path=ppt/slides/slide6.xml><?xml version="1.0" encoding="utf-8"?>
-<p:sld xmlns:a="http://schemas.openxmlformats.org/drawingml/2006/main" xmlns:p="http://schemas.openxmlformats.org/presentationml/2006/main" xmlns:r="http://schemas.openxmlformats.org/officeDocument/2006/relationships">
-  <p:cSld>
-    <p:bg>
-      <p:bgPr>
-        <a:solidFill>
-          <a:srgbClr val="2C3E50"/>
-        </a:solidFill>
-        <a:effectLst/>
-      </p:bgPr>
-    </p:bg>
-    <p:spTree>
-      <p:nvGrpSpPr>
-        <p:cNvPr id="1" name=""/>
-        <p:cNvGrpSpPr/>
-        <p:nvPr/>
-      </p:nvGrpSpPr>
-      <p:grpSpPr/>
-      <p:sp>
-        <p:nvSpPr>
-          <p:cNvPr id="2" name="TextBox 1"/>
-          <p:cNvSpPr txBox="1"/>
-          <p:nvPr/>
-        </p:nvSpPr>
-        <p:spPr>
-          <a:xfrm>
-            <a:off x="731520" y="274320"/>
-            <a:ext cx="10698480" cy="731520"/>
-          </a:xfrm>
-          <a:prstGeom prst="rect">
-            <a:avLst/>
-          </a:prstGeom>
-          <a:noFill/>
-        </p:spPr>
-        <p:txBody>
-          <a:bodyPr wrap="none">
-            <a:spAutoFit/>
-          </a:bodyPr>
-          <a:lstStyle/>
-          <a:p>
-            <a:pPr>
-              <a:defRPr sz="3600" b="1">
-                <a:solidFill>
-                  <a:srgbClr val="FFFFFF"/>
-                </a:solidFill>
-              </a:defRPr>
-            </a:pPr>
-            <a:r>
-              <a:t>Error Analysis</a:t>
-            </a:r>
-          </a:p>
-        </p:txBody>
-      </p:sp>
-      <p:sp>
-        <p:nvSpPr>
-          <p:cNvPr id="3" name="TextBox 2"/>
-          <p:cNvSpPr txBox="1"/>
-          <p:nvPr/>
-        </p:nvSpPr>
-        <p:spPr>
-          <a:xfrm>
-            <a:off x="731520" y="1371600"/>
-            <a:ext cx="10698480" cy="4572000"/>
-          </a:xfrm>
-          <a:prstGeom prst="rect">
-            <a:avLst/>
-          </a:prstGeom>
-          <a:noFill/>
-        </p:spPr>
-        <p:txBody>
-          <a:bodyPr wrap="square">
-            <a:spAutoFit/>
-          </a:bodyPr>
-          <a:lstStyle/>
-          <a:p>
-            <a:pPr>
-              <a:spcAft>
-                <a:spcPts val="400"/>
-              </a:spcAft>
-              <a:defRPr sz="1600" b="0">
-                <a:solidFill>
-                  <a:srgbClr val="F2F2F2"/>
-                </a:solidFill>
-              </a:defRPr>
-            </a:pPr>
-            <a:r>
-              <a:t>📊 Confusion Matrix SVM Baseline:</a:t>
-            </a:r>
-          </a:p>
-          <a:p>
-            <a:pPr>
-              <a:spcAft>
-                <a:spcPts val="400"/>
-              </a:spcAft>
-              <a:defRPr sz="1600" b="0">
-                <a:solidFill>
-                  <a:srgbClr val="F2F2F2"/>
-                </a:solidFill>
-              </a:defRPr>
-            </a:pPr>
-            <a:r>
-              <a:t>  • TP: 415  • TN: 234</a:t>
-            </a:r>
-          </a:p>
-          <a:p>
-            <a:pPr>
-              <a:spcAft>
-                <a:spcPts val="400"/>
-              </a:spcAft>
-              <a:defRPr sz="1600" b="0">
-                <a:solidFill>
-                  <a:srgbClr val="F2F2F2"/>
-                </a:solidFill>
-              </a:defRPr>
-            </a:pPr>
-            <a:r>
-              <a:t>  • FP: 50 (dropout diprediksi lulus)</a:t>
-            </a:r>
-          </a:p>
-          <a:p>
-            <a:pPr>
-              <a:spcAft>
-                <a:spcPts val="400"/>
-              </a:spcAft>
-              <a:defRPr sz="1600" b="0">
-                <a:solidFill>
-                  <a:srgbClr val="F2F2F2"/>
-                </a:solidFill>
-              </a:defRPr>
-            </a:pPr>
-            <a:r>
-              <a:t>  • FN: 27 (lulus diprediksi dropout)</a:t>
-            </a:r>
-          </a:p>
-          <a:p>
-            <a:pPr>
-              <a:spcAft>
-                <a:spcPts val="400"/>
-              </a:spcAft>
-              <a:defRPr sz="1600" b="0">
-                <a:solidFill>
-                  <a:srgbClr val="F2F2F2"/>
-                </a:solidFill>
-              </a:defRPr>
-            </a:pPr>
-          </a:p>
-          <a:p>
-            <a:pPr>
-              <a:spcAft>
-                <a:spcPts val="400"/>
-              </a:spcAft>
-              <a:defRPr sz="1600" b="0">
-                <a:solidFill>
-                  <a:srgbClr val="F2F2F2"/>
-                </a:solidFill>
-              </a:defRPr>
-            </a:pPr>
-            <a:r>
-              <a:t>🧠 Pola: Mahasiswa dengan SKS tinggi tapi dropout karena</a:t>
-            </a:r>
-          </a:p>
-          <a:p>
-            <a:pPr>
-              <a:spcAft>
-                <a:spcPts val="400"/>
-              </a:spcAft>
-              <a:defRPr sz="1600" b="0">
-                <a:solidFill>
-                  <a:srgbClr val="F2F2F2"/>
-                </a:solidFill>
-              </a:defRPr>
-            </a:pPr>
-            <a:r>
-              <a:t>faktor non-akademik (ekonomi/keluarga) sulit dideteksi model.</a:t>
-            </a:r>
-          </a:p>
-          <a:p>
-            <a:pPr>
-              <a:spcAft>
-                <a:spcPts val="400"/>
-              </a:spcAft>
-              <a:defRPr sz="1600" b="0">
-                <a:solidFill>
-                  <a:srgbClr val="F2F2F2"/>
-                </a:solidFill>
-              </a:defRPr>
-            </a:pPr>
-          </a:p>
-          <a:p>
-            <a:pPr>
-              <a:spcAft>
-                <a:spcPts val="400"/>
-              </a:spcAft>
-              <a:defRPr sz="1600" b="0">
-                <a:solidFill>
-                  <a:srgbClr val="F2F2F2"/>
-                </a:solidFill>
-              </a:defRPr>
-            </a:pPr>
-            <a:r>
-              <a:t>💡 Insight: Model perlu dilengkapi data non-akademik</a:t>
-            </a:r>
-          </a:p>
-        </p:txBody>
-      </p:sp>
-    </p:spTree>
-  </p:cSld>
-  <p:clrMapOvr>
-    <a:masterClrMapping/>
-  </p:clrMapOvr>
-</p:sld>
-</file>
-
-<file path=ppt/slides/slide7.xml><?xml version="1.0" encoding="utf-8"?>
 <p:sld xmlns:a="http://schemas.openxmlformats.org/drawingml/2006/main" xmlns:p="http://schemas.openxmlformats.org/presentationml/2006/main" xmlns:r="http://schemas.openxmlformats.org/officeDocument/2006/relationships">
   <p:cSld>
     <p:bg>
@@ -4760,7 +4537,7 @@
         </p:nvSpPr>
         <p:spPr>
           <a:xfrm>
-            <a:off x="731520" y="274320"/>
+            <a:off x="731520" y="365760"/>
             <a:ext cx="10698480" cy="731520"/>
           </a:xfrm>
           <a:prstGeom prst="rect">
@@ -4769,7 +4546,7 @@
           <a:noFill/>
         </p:spPr>
         <p:txBody>
-          <a:bodyPr wrap="none">
+          <a:bodyPr wrap="square">
             <a:spAutoFit/>
           </a:bodyPr>
           <a:lstStyle/>
@@ -4782,7 +4559,210 @@
               </a:defRPr>
             </a:pPr>
             <a:r>
-              <a:t>Pembahasan &amp; Trade-off</a:t>
+              <a:t>Empirical Error Analysis</a:t>
+            </a:r>
+          </a:p>
+        </p:txBody>
+      </p:sp>
+      <p:sp>
+        <p:nvSpPr>
+          <p:cNvPr id="3" name="TextBox 2"/>
+          <p:cNvSpPr txBox="1"/>
+          <p:nvPr/>
+        </p:nvSpPr>
+        <p:spPr>
+          <a:xfrm>
+            <a:off x="731520" y="1371600"/>
+            <a:ext cx="5303520" cy="4572000"/>
+          </a:xfrm>
+          <a:prstGeom prst="rect">
+            <a:avLst/>
+          </a:prstGeom>
+          <a:noFill/>
+        </p:spPr>
+        <p:txBody>
+          <a:bodyPr wrap="square">
+            <a:spAutoFit/>
+          </a:bodyPr>
+          <a:lstStyle/>
+          <a:p/>
+          <a:p>
+            <a:pPr>
+              <a:spcBef>
+                <a:spcPts val="600"/>
+              </a:spcBef>
+              <a:defRPr sz="1500" b="1">
+                <a:solidFill>
+                  <a:srgbClr val="2C3E50"/>
+                </a:solidFill>
+              </a:defRPr>
+            </a:pPr>
+            <a:r>
+              <a:t>📊 Distribusi Kesalahan Model</a:t>
+            </a:r>
+          </a:p>
+          <a:p>
+            <a:pPr>
+              <a:spcAft>
+                <a:spcPts val="600"/>
+              </a:spcAft>
+              <a:defRPr sz="1200">
+                <a:solidFill>
+                  <a:srgbClr val="7F8C8D"/>
+                </a:solidFill>
+              </a:defRPr>
+            </a:pPr>
+            <a:r>
+              <a:t>• True Positive: 415 | True Negative: 234</a:t>
+            </a:r>
+            <a:br/>
+            <a:r>
+              <a:t>• False Positive (FP): 50 | False Negative (FN): 27</a:t>
+            </a:r>
+          </a:p>
+          <a:p>
+            <a:pPr>
+              <a:spcBef>
+                <a:spcPts val="600"/>
+              </a:spcBef>
+              <a:defRPr sz="1500" b="1">
+                <a:solidFill>
+                  <a:srgbClr val="2C3E50"/>
+                </a:solidFill>
+              </a:defRPr>
+            </a:pPr>
+            <a:r>
+              <a:t>🕵️ Pola Kesalahan yang Ditemukan</a:t>
+            </a:r>
+          </a:p>
+          <a:p>
+            <a:pPr>
+              <a:spcAft>
+                <a:spcPts val="600"/>
+              </a:spcAft>
+              <a:defRPr sz="1200">
+                <a:solidFill>
+                  <a:srgbClr val="7F8C8D"/>
+                </a:solidFill>
+              </a:defRPr>
+            </a:pPr>
+            <a:r>
+              <a:t>Mahasiswa yang memiliki SKS tinggi (Semester 1 &amp; 2 lengkap) tetapi mendadak dropout sering kali gagal dideteksi oleh model (terprediksi Graduate).</a:t>
+            </a:r>
+          </a:p>
+          <a:p>
+            <a:pPr>
+              <a:spcBef>
+                <a:spcPts val="600"/>
+              </a:spcBef>
+              <a:defRPr sz="1500" b="1">
+                <a:solidFill>
+                  <a:srgbClr val="2C3E50"/>
+                </a:solidFill>
+              </a:defRPr>
+            </a:pPr>
+            <a:r>
+              <a:t>💡 Penyebab Logis Kegagalan Model</a:t>
+            </a:r>
+          </a:p>
+          <a:p>
+            <a:pPr>
+              <a:spcAft>
+                <a:spcPts val="600"/>
+              </a:spcAft>
+              <a:defRPr sz="1200">
+                <a:solidFill>
+                  <a:srgbClr val="7F8C8D"/>
+                </a:solidFill>
+              </a:defRPr>
+            </a:pPr>
+            <a:r>
+              <a:t>Banyak mahasiswa dropout karena faktor eksternal (seperti kesulitan finansial pribadi, masalah kesehatan, atau faktor keluarga) yang datanya tidak terekam dalam atribut akademis. Ini membuktikan batasan machine learning tabular akademik.</a:t>
+            </a:r>
+          </a:p>
+        </p:txBody>
+      </p:sp>
+      <p:pic>
+        <p:nvPicPr>
+          <p:cNvPr id="4" name="Picture 3" descr="confusion_matrix.png"/>
+          <p:cNvPicPr>
+            <a:picLocks noChangeAspect="1"/>
+          </p:cNvPicPr>
+          <p:nvPr/>
+        </p:nvPicPr>
+        <p:blipFill>
+          <a:blip r:embed="rId2"/>
+          <a:stretch>
+            <a:fillRect/>
+          </a:stretch>
+        </p:blipFill>
+        <p:spPr>
+          <a:xfrm>
+            <a:off x="6583680" y="1371600"/>
+            <a:ext cx="4572000" cy="3810000"/>
+          </a:xfrm>
+          <a:prstGeom prst="rect">
+            <a:avLst/>
+          </a:prstGeom>
+        </p:spPr>
+      </p:pic>
+    </p:spTree>
+  </p:cSld>
+  <p:clrMapOvr>
+    <a:masterClrMapping/>
+  </p:clrMapOvr>
+</p:sld>
+</file>
+
+<file path=ppt/slides/slide7.xml><?xml version="1.0" encoding="utf-8"?>
+<p:sld xmlns:a="http://schemas.openxmlformats.org/drawingml/2006/main" xmlns:p="http://schemas.openxmlformats.org/presentationml/2006/main" xmlns:r="http://schemas.openxmlformats.org/officeDocument/2006/relationships">
+  <p:cSld>
+    <p:bg>
+      <p:bgPr>
+        <a:solidFill>
+          <a:srgbClr val="1F2761"/>
+        </a:solidFill>
+        <a:effectLst/>
+      </p:bgPr>
+    </p:bg>
+    <p:spTree>
+      <p:nvGrpSpPr>
+        <p:cNvPr id="1" name=""/>
+        <p:cNvGrpSpPr/>
+        <p:nvPr/>
+      </p:nvGrpSpPr>
+      <p:grpSpPr/>
+      <p:sp>
+        <p:nvSpPr>
+          <p:cNvPr id="2" name="TextBox 1"/>
+          <p:cNvSpPr txBox="1"/>
+          <p:nvPr/>
+        </p:nvSpPr>
+        <p:spPr>
+          <a:xfrm>
+            <a:off x="731520" y="365760"/>
+            <a:ext cx="10698480" cy="731520"/>
+          </a:xfrm>
+          <a:prstGeom prst="rect">
+            <a:avLst/>
+          </a:prstGeom>
+          <a:noFill/>
+        </p:spPr>
+        <p:txBody>
+          <a:bodyPr wrap="square">
+            <a:spAutoFit/>
+          </a:bodyPr>
+          <a:lstStyle/>
+          <a:p>
+            <a:pPr>
+              <a:defRPr sz="3600" b="1">
+                <a:solidFill>
+                  <a:srgbClr val="FFFFFF"/>
+                </a:solidFill>
+              </a:defRPr>
+            </a:pPr>
+            <a:r>
+              <a:t>Pembahasan Akademik &amp; Implikasi Institusi</a:t>
             </a:r>
           </a:p>
         </p:txBody>
@@ -4808,148 +4788,87 @@
             <a:spAutoFit/>
           </a:bodyPr>
           <a:lstStyle/>
+          <a:p/>
+          <a:p>
+            <a:pPr>
+              <a:defRPr sz="1800" b="1">
+                <a:solidFill>
+                  <a:srgbClr val="FFFFFF"/>
+                </a:solidFill>
+              </a:defRPr>
+            </a:pPr>
+            <a:r>
+              <a:t>⚖️ Trade-off Akurasi vs Kompleksitas vs Interpretabilitas</a:t>
+            </a:r>
+          </a:p>
           <a:p>
             <a:pPr>
               <a:spcAft>
-                <a:spcPts val="400"/>
+                <a:spcPts val="1200"/>
               </a:spcAft>
-              <a:defRPr sz="1600" b="0">
-                <a:solidFill>
-                  <a:srgbClr val="2C3E50"/>
-                </a:solidFill>
-              </a:defRPr>
-            </a:pPr>
-            <a:r>
-              <a:t>⚖️ Perbandingan Model:</a:t>
+              <a:defRPr sz="1400">
+                <a:solidFill>
+                  <a:srgbClr val="CADCFC"/>
+                </a:solidFill>
+              </a:defRPr>
+            </a:pPr>
+            <a:r>
+              <a:t>   • SVM RBF: Akurasi &amp; F1-Macro tertinggi (0.887), tetapi sulit diinterpretasikan secara langsung (black-box).</a:t>
+            </a:r>
+            <a:br/>
+            <a:r>
+              <a:t>   • Naive Bayes: Paling cepat dan sangat mudah diinterpretasikan secara statistik, tetapi recall kelas Dropout-nya paling rendah.</a:t>
+            </a:r>
+            <a:br/>
+            <a:r>
+              <a:t>   • K-Nearest Neighbors: Sederhana dan intuitif, tetapi sensitif terhadap noise dan penentuan nilai K.</a:t>
+            </a:r>
+          </a:p>
+          <a:p>
+            <a:pPr>
+              <a:defRPr sz="1800" b="1">
+                <a:solidFill>
+                  <a:srgbClr val="FFFFFF"/>
+                </a:solidFill>
+              </a:defRPr>
+            </a:pPr>
+            <a:r>
+              <a:t>🏛️ Implikasi untuk Institusi Pendidikan</a:t>
             </a:r>
           </a:p>
           <a:p>
             <a:pPr>
               <a:spcAft>
-                <a:spcPts val="400"/>
+                <a:spcPts val="1200"/>
               </a:spcAft>
-              <a:defRPr sz="1600" b="0">
-                <a:solidFill>
-                  <a:srgbClr val="2C3E50"/>
-                </a:solidFill>
-              </a:defRPr>
-            </a:pPr>
-            <a:r>
-              <a:t>  • SVM RBF: Akurasi tinggi ↔ Kurang interpretabel</a:t>
-            </a:r>
-          </a:p>
-          <a:p>
-            <a:pPr>
-              <a:spcAft>
-                <a:spcPts val="400"/>
-              </a:spcAft>
-              <a:defRPr sz="1600" b="0">
-                <a:solidFill>
-                  <a:srgbClr val="2C3E50"/>
-                </a:solidFill>
-              </a:defRPr>
-            </a:pPr>
-            <a:r>
-              <a:t>  • Naive Bayes: Interpretabel ↔ Recall dropout rendah</a:t>
-            </a:r>
-          </a:p>
-          <a:p>
-            <a:pPr>
-              <a:spcAft>
-                <a:spcPts val="400"/>
-              </a:spcAft>
-              <a:defRPr sz="1600" b="0">
-                <a:solidFill>
-                  <a:srgbClr val="2C3E50"/>
-                </a:solidFill>
-              </a:defRPr>
-            </a:pPr>
-            <a:r>
-              <a:t>  • KNN: Sederhana ↔ Sensitif terhadap K</a:t>
-            </a:r>
-          </a:p>
-          <a:p>
-            <a:pPr>
-              <a:spcAft>
-                <a:spcPts val="400"/>
-              </a:spcAft>
-              <a:defRPr sz="1600" b="0">
-                <a:solidFill>
-                  <a:srgbClr val="2C3E50"/>
-                </a:solidFill>
-              </a:defRPr>
-            </a:pPr>
-          </a:p>
-          <a:p>
-            <a:pPr>
-              <a:spcAft>
-                <a:spcPts val="400"/>
-              </a:spcAft>
-              <a:defRPr sz="1600" b="0">
-                <a:solidFill>
-                  <a:srgbClr val="2C3E50"/>
-                </a:solidFill>
-              </a:defRPr>
-            </a:pPr>
-            <a:r>
-              <a:t>🏛️ Implikasi Institusi:</a:t>
-            </a:r>
-          </a:p>
-          <a:p>
-            <a:pPr>
-              <a:spcAft>
-                <a:spcPts val="400"/>
-              </a:spcAft>
-              <a:defRPr sz="1600" b="0">
-                <a:solidFill>
-                  <a:srgbClr val="2C3E50"/>
-                </a:solidFill>
-              </a:defRPr>
-            </a:pPr>
-            <a:r>
-              <a:t>  → Early Warning System untuk intervensi dini</a:t>
-            </a:r>
-          </a:p>
-          <a:p>
-            <a:pPr>
-              <a:spcAft>
-                <a:spcPts val="400"/>
-              </a:spcAft>
-              <a:defRPr sz="1600" b="0">
-                <a:solidFill>
-                  <a:srgbClr val="2C3E50"/>
-                </a:solidFill>
-              </a:defRPr>
-            </a:pPr>
-            <a:r>
-              <a:t>  → Konseling akademik &amp; bantuan finansial</a:t>
-            </a:r>
-          </a:p>
-          <a:p>
-            <a:pPr>
-              <a:spcAft>
-                <a:spcPts val="400"/>
-              </a:spcAft>
-              <a:defRPr sz="1600" b="0">
-                <a:solidFill>
-                  <a:srgbClr val="2C3E50"/>
-                </a:solidFill>
-              </a:defRPr>
-            </a:pPr>
-          </a:p>
-          <a:p>
-            <a:pPr>
-              <a:spcAft>
-                <a:spcPts val="400"/>
-              </a:spcAft>
-              <a:defRPr sz="1600" b="0">
-                <a:solidFill>
-                  <a:srgbClr val="2C3E50"/>
-                </a:solidFill>
-              </a:defRPr>
-            </a:pPr>
-            <a:r>
-              <a:t>⚠️ DECISION SUPPORT — BUKAN KEPUTUSAN FINAL</a:t>
+              <a:defRPr sz="1400">
+                <a:solidFill>
+                  <a:srgbClr val="CADCFC"/>
+                </a:solidFill>
+              </a:defRPr>
+            </a:pPr>
+            <a:r>
+              <a:t>   1. Pemasangan Early Warning System (EWS): Membantu Biro Akademik mendeteksi mahasiswa terancam DO sejak semester 2.</a:t>
+            </a:r>
+            <a:br/>
+            <a:r>
+              <a:t>   2. Program Intervensi Preventif: Pihak kampus dapat memberikan beasiswa bagi yang terkendala ukt atau konseling khusus.</a:t>
+            </a:r>
+            <a:br/>
+            <a:r>
+              <a:t>   3. Tanggung Jawab Sosial: Meminimalisir angka putus kuliah secara signifikan guna meningkatkan reputasi institusi.</a:t>
+            </a:r>
+          </a:p>
+          <a:p>
+            <a:pPr>
+              <a:defRPr sz="1300" b="1">
+                <a:solidFill>
+                  <a:srgbClr val="FF8C8C"/>
+                </a:solidFill>
+              </a:defRPr>
+            </a:pPr>
+            <a:r>
+              <a:t>⚠️ BATASAN ETIS: Model HANYA berfungsi sebagai sistem pendukung keputusan (Decision Support System) bagi dosen wali. Keputusan drop out tidak boleh dilakukan secara otomatis oleh sistem AI.</a:t>
             </a:r>
           </a:p>
         </p:txBody>
@@ -4968,7 +4887,7 @@
     <p:bg>
       <p:bgPr>
         <a:solidFill>
-          <a:srgbClr val="028090"/>
+          <a:srgbClr val="FFFFFF"/>
         </a:solidFill>
         <a:effectLst/>
       </p:bgPr>
@@ -4988,7 +4907,7 @@
         </p:nvSpPr>
         <p:spPr>
           <a:xfrm>
-            <a:off x="731520" y="274320"/>
+            <a:off x="731520" y="365760"/>
             <a:ext cx="10698480" cy="731520"/>
           </a:xfrm>
           <a:prstGeom prst="rect">
@@ -4997,7 +4916,7 @@
           <a:noFill/>
         </p:spPr>
         <p:txBody>
-          <a:bodyPr wrap="none">
+          <a:bodyPr wrap="square">
             <a:spAutoFit/>
           </a:bodyPr>
           <a:lstStyle/>
@@ -5005,12 +4924,12 @@
             <a:pPr>
               <a:defRPr sz="3600" b="1">
                 <a:solidFill>
-                  <a:srgbClr val="FFFFFF"/>
-                </a:solidFill>
-              </a:defRPr>
-            </a:pPr>
-            <a:r>
-              <a:t>Desain Aplikasi</a:t>
+                  <a:srgbClr val="2C3E50"/>
+                </a:solidFill>
+              </a:defRPr>
+            </a:pPr>
+            <a:r>
+              <a:t>Desain Aplikasi &amp; Antarmuka UI/UX</a:t>
             </a:r>
           </a:p>
         </p:txBody>
@@ -5036,148 +4955,125 @@
             <a:spAutoFit/>
           </a:bodyPr>
           <a:lstStyle/>
+          <a:p/>
+          <a:p>
+            <a:pPr>
+              <a:spcBef>
+                <a:spcPts val="600"/>
+              </a:spcBef>
+              <a:defRPr sz="1600" b="1">
+                <a:solidFill>
+                  <a:srgbClr val="2C3E50"/>
+                </a:solidFill>
+              </a:defRPr>
+            </a:pPr>
+            <a:r>
+              <a:t>🖥️ Streamlit Frontend Dashboard</a:t>
+            </a:r>
+          </a:p>
           <a:p>
             <a:pPr>
               <a:spcAft>
-                <a:spcPts val="400"/>
+                <a:spcPts val="600"/>
               </a:spcAft>
-              <a:defRPr sz="1600" b="0">
-                <a:solidFill>
-                  <a:srgbClr val="FFFFFF"/>
-                </a:solidFill>
-              </a:defRPr>
-            </a:pPr>
-            <a:r>
-              <a:t>🖥️ Streamlit — 4 Halaman:</a:t>
+              <a:defRPr sz="1300">
+                <a:solidFill>
+                  <a:srgbClr val="7F8C8D"/>
+                </a:solidFill>
+              </a:defRPr>
+            </a:pPr>
+            <a:r>
+              <a:t>Didesain dengan 4 menu utama: (1) Prediksi Mandiri: Form interaktif 10 input dengan output status kelulusan + tingkat kepercayaan model, (2) Dashboard Visualisasi Dataset, (3) Tabel Perbandingan Performa 6 Model, (4) Edukasi/Penjelasan Model Klasifikasi.</a:t>
+            </a:r>
+          </a:p>
+          <a:p>
+            <a:pPr>
+              <a:spcBef>
+                <a:spcPts val="600"/>
+              </a:spcBef>
+              <a:defRPr sz="1600" b="1">
+                <a:solidFill>
+                  <a:srgbClr val="2C3E50"/>
+                </a:solidFill>
+              </a:defRPr>
+            </a:pPr>
+            <a:r>
+              <a:t>⚡ FastAPI Backend Rest API</a:t>
             </a:r>
           </a:p>
           <a:p>
             <a:pPr>
               <a:spcAft>
-                <a:spcPts val="400"/>
+                <a:spcPts val="600"/>
               </a:spcAft>
-              <a:defRPr sz="1600" b="0">
-                <a:solidFill>
-                  <a:srgbClr val="FFFFFF"/>
-                </a:solidFill>
-              </a:defRPr>
-            </a:pPr>
-            <a:r>
-              <a:t>  1. Prediksi (input 10 fitur + confidence score)</a:t>
+              <a:defRPr sz="1300">
+                <a:solidFill>
+                  <a:srgbClr val="7F8C8D"/>
+                </a:solidFill>
+              </a:defRPr>
+            </a:pPr>
+            <a:r>
+              <a:t>Menyediakan endpoint `/predict` berbasis JSON yang siap diintegrasikan dengan Sistem Informasi Akademik (SIAKAD) universitas secara real-time.</a:t>
+            </a:r>
+          </a:p>
+          <a:p>
+            <a:pPr>
+              <a:spcBef>
+                <a:spcPts val="600"/>
+              </a:spcBef>
+              <a:defRPr sz="1600" b="1">
+                <a:solidFill>
+                  <a:srgbClr val="2C3E50"/>
+                </a:solidFill>
+              </a:defRPr>
+            </a:pPr>
+            <a:r>
+              <a:t>🎛️ Gradio Alternative UI</a:t>
             </a:r>
           </a:p>
           <a:p>
             <a:pPr>
               <a:spcAft>
-                <a:spcPts val="400"/>
+                <a:spcPts val="600"/>
               </a:spcAft>
-              <a:defRPr sz="1600" b="0">
-                <a:solidFill>
-                  <a:srgbClr val="FFFFFF"/>
-                </a:solidFill>
-              </a:defRPr>
-            </a:pPr>
-            <a:r>
-              <a:t>  2. Dashboard Data (distribusi &amp; statistik)</a:t>
+              <a:defRPr sz="1300">
+                <a:solidFill>
+                  <a:srgbClr val="7F8C8D"/>
+                </a:solidFill>
+              </a:defRPr>
+            </a:pPr>
+            <a:r>
+              <a:t>UI alternatif berdesain minimalis yang memfasilitasi pengujian model cepat dengan drag-and-drop input.</a:t>
+            </a:r>
+          </a:p>
+          <a:p>
+            <a:pPr>
+              <a:spcBef>
+                <a:spcPts val="600"/>
+              </a:spcBef>
+              <a:defRPr sz="1600" b="1">
+                <a:solidFill>
+                  <a:srgbClr val="2C3E50"/>
+                </a:solidFill>
+              </a:defRPr>
+            </a:pPr>
+            <a:r>
+              <a:t>🛡️ Fitur Keamanan &amp; Desain Etis</a:t>
             </a:r>
           </a:p>
           <a:p>
             <a:pPr>
               <a:spcAft>
-                <a:spcPts val="400"/>
+                <a:spcPts val="600"/>
               </a:spcAft>
-              <a:defRPr sz="1600" b="0">
-                <a:solidFill>
-                  <a:srgbClr val="FFFFFF"/>
-                </a:solidFill>
-              </a:defRPr>
-            </a:pPr>
-            <a:r>
-              <a:t>  3. Performa Model (tabel 6 model + grafik)</a:t>
-            </a:r>
-          </a:p>
-          <a:p>
-            <a:pPr>
-              <a:spcAft>
-                <a:spcPts val="400"/>
-              </a:spcAft>
-              <a:defRPr sz="1600" b="0">
-                <a:solidFill>
-                  <a:srgbClr val="FFFFFF"/>
-                </a:solidFill>
-              </a:defRPr>
-            </a:pPr>
-            <a:r>
-              <a:t>  4. Penjelasan Model (SVM dalam Bahasa Indonesia)</a:t>
-            </a:r>
-          </a:p>
-          <a:p>
-            <a:pPr>
-              <a:spcAft>
-                <a:spcPts val="400"/>
-              </a:spcAft>
-              <a:defRPr sz="1600" b="0">
-                <a:solidFill>
-                  <a:srgbClr val="FFFFFF"/>
-                </a:solidFill>
-              </a:defRPr>
-            </a:pPr>
-          </a:p>
-          <a:p>
-            <a:pPr>
-              <a:spcAft>
-                <a:spcPts val="400"/>
-              </a:spcAft>
-              <a:defRPr sz="1600" b="0">
-                <a:solidFill>
-                  <a:srgbClr val="FFFFFF"/>
-                </a:solidFill>
-              </a:defRPr>
-            </a:pPr>
-            <a:r>
-              <a:t>⚡ FastAPI — Backend REST API</a:t>
-            </a:r>
-          </a:p>
-          <a:p>
-            <a:pPr>
-              <a:spcAft>
-                <a:spcPts val="400"/>
-              </a:spcAft>
-              <a:defRPr sz="1600" b="0">
-                <a:solidFill>
-                  <a:srgbClr val="FFFFFF"/>
-                </a:solidFill>
-              </a:defRPr>
-            </a:pPr>
-            <a:r>
-              <a:t>🎛️ Gradio — Alternatif UI</a:t>
-            </a:r>
-          </a:p>
-          <a:p>
-            <a:pPr>
-              <a:spcAft>
-                <a:spcPts val="400"/>
-              </a:spcAft>
-              <a:defRPr sz="1600" b="0">
-                <a:solidFill>
-                  <a:srgbClr val="FFFFFF"/>
-                </a:solidFill>
-              </a:defRPr>
-            </a:pPr>
-          </a:p>
-          <a:p>
-            <a:pPr>
-              <a:spcAft>
-                <a:spcPts val="400"/>
-              </a:spcAft>
-              <a:defRPr sz="1600" b="0">
-                <a:solidFill>
-                  <a:srgbClr val="FFFFFF"/>
-                </a:solidFill>
-              </a:defRPr>
-            </a:pPr>
-            <a:r>
-              <a:t>✅ Disclaimer etis di setiap halaman</a:t>
+              <a:defRPr sz="1300">
+                <a:solidFill>
+                  <a:srgbClr val="7F8C8D"/>
+                </a:solidFill>
+              </a:defRPr>
+            </a:pPr>
+            <a:r>
+              <a:t>Tiap antarmuka dilengkapi disclaimer etika, penanganan input tidak valid, serta peringatan probabilitas rendah.</a:t>
             </a:r>
           </a:p>
         </p:txBody>
@@ -5196,7 +5092,7 @@
     <p:bg>
       <p:bgPr>
         <a:solidFill>
-          <a:srgbClr val="2C3E50"/>
+          <a:srgbClr val="1F2761"/>
         </a:solidFill>
         <a:effectLst/>
       </p:bgPr>
@@ -5216,7 +5112,7 @@
         </p:nvSpPr>
         <p:spPr>
           <a:xfrm>
-            <a:off x="731520" y="274320"/>
+            <a:off x="731520" y="365760"/>
             <a:ext cx="10698480" cy="731520"/>
           </a:xfrm>
           <a:prstGeom prst="rect">
@@ -5225,7 +5121,7 @@
           <a:noFill/>
         </p:spPr>
         <p:txBody>
-          <a:bodyPr wrap="none">
+          <a:bodyPr wrap="square">
             <a:spAutoFit/>
           </a:bodyPr>
           <a:lstStyle/>
@@ -5238,7 +5134,7 @@
               </a:defRPr>
             </a:pPr>
             <a:r>
-              <a:t>Kesimpulan</a:t>
+              <a:t>Kesimpulan &amp; Rekomendasi</a:t>
             </a:r>
           </a:p>
         </p:txBody>
@@ -5264,115 +5160,103 @@
             <a:spAutoFit/>
           </a:bodyPr>
           <a:lstStyle/>
+          <a:p/>
+          <a:p>
+            <a:pPr>
+              <a:spcBef>
+                <a:spcPts val="800"/>
+              </a:spcBef>
+              <a:defRPr sz="1700" b="1">
+                <a:solidFill>
+                  <a:srgbClr val="FFFFFF"/>
+                </a:solidFill>
+              </a:defRPr>
+            </a:pPr>
+            <a:r>
+              <a:t>1. Capaian Target Model</a:t>
+            </a:r>
+          </a:p>
           <a:p>
             <a:pPr>
               <a:spcAft>
-                <a:spcPts val="400"/>
+                <a:spcPts val="800"/>
               </a:spcAft>
-              <a:defRPr sz="1600" b="0">
-                <a:solidFill>
-                  <a:srgbClr val="F2F2F2"/>
-                </a:solidFill>
-              </a:defRPr>
-            </a:pPr>
-            <a:r>
-              <a:t>1️⃣ SVM Baseline terbaik: F1=0.887, Acc=0.894</a:t>
+              <a:defRPr sz="1300">
+                <a:solidFill>
+                  <a:srgbClr val="CADCFC"/>
+                </a:solidFill>
+              </a:defRPr>
+            </a:pPr>
+            <a:r>
+              <a:t>Model SVM Baseline berhasil mendeteksi risiko kelulusan mahasiswa dengan akurasi 89,39% dan F1-Macro 0.8869, sangat stabil dan siap dideploy.</a:t>
+            </a:r>
+          </a:p>
+          <a:p>
+            <a:pPr>
+              <a:spcBef>
+                <a:spcPts val="800"/>
+              </a:spcBef>
+              <a:defRPr sz="1700" b="1">
+                <a:solidFill>
+                  <a:srgbClr val="FFFFFF"/>
+                </a:solidFill>
+              </a:defRPr>
+            </a:pPr>
+            <a:r>
+              <a:t>2. Keterbatasan Penelitian</a:t>
             </a:r>
           </a:p>
           <a:p>
             <a:pPr>
               <a:spcAft>
-                <a:spcPts val="400"/>
+                <a:spcPts val="800"/>
               </a:spcAft>
-              <a:defRPr sz="1600" b="0">
-                <a:solidFill>
-                  <a:srgbClr val="F2F2F2"/>
-                </a:solidFill>
-              </a:defRPr>
-            </a:pPr>
+              <a:defRPr sz="1300">
+                <a:solidFill>
+                  <a:srgbClr val="CADCFC"/>
+                </a:solidFill>
+              </a:defRPr>
+            </a:pPr>
+            <a:r>
+              <a:t>Dataset yang digunakan didominasi oleh riwayat mahasiswa dari Portugal. Diperlukan penyesuaian (transfer learning) sebelum diterapkan langsung di Indonesia.</a:t>
+            </a:r>
+          </a:p>
+          <a:p>
+            <a:pPr>
+              <a:spcBef>
+                <a:spcPts val="800"/>
+              </a:spcBef>
+              <a:defRPr sz="1700" b="1">
+                <a:solidFill>
+                  <a:srgbClr val="FFFFFF"/>
+                </a:solidFill>
+              </a:defRPr>
+            </a:pPr>
+            <a:r>
+              <a:t>3. Rekomendasi Pengembangan Masa Depan</a:t>
+            </a:r>
           </a:p>
           <a:p>
             <a:pPr>
               <a:spcAft>
-                <a:spcPts val="400"/>
+                <a:spcPts val="800"/>
               </a:spcAft>
-              <a:defRPr sz="1600" b="0">
-                <a:solidFill>
-                  <a:srgbClr val="F2F2F2"/>
-                </a:solidFill>
-              </a:defRPr>
-            </a:pPr>
-            <a:r>
-              <a:t>2️⃣ 10 fitur terpilih efektif untuk prediksi</a:t>
-            </a:r>
-          </a:p>
-          <a:p>
-            <a:pPr>
-              <a:spcAft>
-                <a:spcPts val="400"/>
-              </a:spcAft>
-              <a:defRPr sz="1600" b="0">
-                <a:solidFill>
-                  <a:srgbClr val="F2F2F2"/>
-                </a:solidFill>
-              </a:defRPr>
-            </a:pPr>
-          </a:p>
-          <a:p>
-            <a:pPr>
-              <a:spcAft>
-                <a:spcPts val="400"/>
-              </a:spcAft>
-              <a:defRPr sz="1600" b="0">
-                <a:solidFill>
-                  <a:srgbClr val="F2F2F2"/>
-                </a:solidFill>
-              </a:defRPr>
-            </a:pPr>
-            <a:r>
-              <a:t>3️⃣ Keterbatasan: Dataset Portugal → perlu validasi lokal</a:t>
-            </a:r>
-          </a:p>
-          <a:p>
-            <a:pPr>
-              <a:spcAft>
-                <a:spcPts val="400"/>
-              </a:spcAft>
-              <a:defRPr sz="1600" b="0">
-                <a:solidFill>
-                  <a:srgbClr val="F2F2F2"/>
-                </a:solidFill>
-              </a:defRPr>
-            </a:pPr>
-          </a:p>
-          <a:p>
-            <a:pPr>
-              <a:spcAft>
-                <a:spcPts val="400"/>
-              </a:spcAft>
-              <a:defRPr sz="1600" b="0">
-                <a:solidFill>
-                  <a:srgbClr val="F2F2F2"/>
-                </a:solidFill>
-              </a:defRPr>
-            </a:pPr>
-            <a:r>
-              <a:t>4️⃣ Rekomendasi: Ensemble methods, SHAP/LIME,</a:t>
-            </a:r>
-          </a:p>
-          <a:p>
-            <a:pPr>
-              <a:spcAft>
-                <a:spcPts val="400"/>
-              </a:spcAft>
-              <a:defRPr sz="1600" b="0">
-                <a:solidFill>
-                  <a:srgbClr val="F2F2F2"/>
-                </a:solidFill>
-              </a:defRPr>
-            </a:pPr>
-            <a:r>
-              <a:t>   Docker deployment</a:t>
+              <a:defRPr sz="1300">
+                <a:solidFill>
+                  <a:srgbClr val="CADCFC"/>
+                </a:solidFill>
+              </a:defRPr>
+            </a:pPr>
+            <a:r>
+              <a:t>• Integrasikan dengan data lokal universitas untuk pelatihan ulang.</a:t>
+            </a:r>
+            <a:br/>
+            <a:r>
+              <a:t>• Gunakan metode Ensemble Stacking (kombinasi SVM, KNN, Random Forest) untuk menaikkan performa.</a:t>
+            </a:r>
+            <a:br/>
+            <a:r>
+              <a:t>• Implementasikan framework eXplainable AI (seperti SHAP) agar dosen wali memahami alasan di balik setiap prediksi.</a:t>
             </a:r>
           </a:p>
         </p:txBody>

</xml_diff>

<commit_message>
docs: comprehensive formal presentation + separate video script
</commit_message>
<xml_diff>
--- a/presentation/presentasi_uas_ml.pptx
+++ b/presentation/presentasi_uas_ml.pptx
@@ -3150,7 +3150,7 @@
               </a:defRPr>
             </a:pPr>
             <a:r>
-              <a:t>Menggunakan Klasifikasi Machine Learning &amp; Optimasi Berbasis OBE</a:t>
+              <a:t>Pendekatan Machine Learning dan Implementasi Outcome-Based Education (OBE)</a:t>
             </a:r>
           </a:p>
         </p:txBody>
@@ -3192,11 +3192,11 @@
             </a:r>
             <a:br/>
             <a:r>
-              <a:t>Kelompok: A11.4401 &amp; A11.4410 — Universitas Dian Nuswantoro</a:t>
+              <a:t>Kelompok: A11.4401 &amp; A11.4410</a:t>
             </a:r>
             <a:br/>
             <a:r>
-              <a:t>UAS Pembelajaran Mesin 2026</a:t>
+              <a:t>Universitas Dian Nuswantoro — Ujian Akhir Semester Pembelajaran Mesin 2026</a:t>
             </a:r>
           </a:p>
         </p:txBody>
@@ -3272,7 +3272,7 @@
               </a:defRPr>
             </a:pPr>
             <a:r>
-              <a:t>Seluruh source code, dataset, dan laporan lengkap dapat diakses pada repository GitHub:</a:t>
+              <a:t>Repositori proyek memuat seluruh basis kode instruksional, dataset, serta laporan akhir akademis:</a:t>
             </a:r>
           </a:p>
           <a:p>
@@ -3293,7 +3293,7 @@
           <a:p>
             <a:pPr algn="ctr">
               <a:spcBef>
-                <a:spcPts val="2000"/>
+                <a:spcPts val="3000"/>
               </a:spcBef>
               <a:defRPr sz="1800">
                 <a:solidFill>
@@ -3356,14 +3356,14 @@
           <a:lstStyle/>
           <a:p>
             <a:pPr>
-              <a:defRPr sz="3600" b="1">
+              <a:defRPr sz="3400" b="1">
                 <a:solidFill>
                   <a:srgbClr val="FFFFFF"/>
                 </a:solidFill>
               </a:defRPr>
             </a:pPr>
             <a:r>
-              <a:t>Latar Belakang &amp; Urgensi Masalah</a:t>
+              <a:t>Latar Belakang &amp; Urgensi Penelitian</a:t>
             </a:r>
           </a:p>
         </p:txBody>
@@ -3395,6 +3395,9 @@
               <a:spcBef>
                 <a:spcPts val="800"/>
               </a:spcBef>
+              <a:spcAft>
+                <a:spcPts val="200"/>
+              </a:spcAft>
               <a:defRPr sz="1800" b="1">
                 <a:solidFill>
                   <a:srgbClr val="FFFFFF"/>
@@ -3402,22 +3405,25 @@
               </a:defRPr>
             </a:pPr>
             <a:r>
-              <a:t>🔴 Potret Krisis Dropout di Perguruan Tinggi</a:t>
-            </a:r>
-          </a:p>
-          <a:p>
-            <a:pPr>
+              <a:t>Krisis Angka Putus Kuliah (Dropout) di Perguruan Tinggi</a:t>
+            </a:r>
+          </a:p>
+          <a:p>
+            <a:pPr lvl="1">
+              <a:spcBef>
+                <a:spcPts val="0"/>
+              </a:spcBef>
               <a:spcAft>
-                <a:spcPts val="800"/>
+                <a:spcPts val="1000"/>
               </a:spcAft>
-              <a:defRPr sz="1400">
+              <a:defRPr sz="1400" b="0">
                 <a:solidFill>
                   <a:srgbClr val="CADCFC"/>
                 </a:solidFill>
               </a:defRPr>
             </a:pPr>
             <a:r>
-              <a:t>   Berdasarkan dataset UCI Academic Success, tercatat angka dropout mahasiswa mencapai 39% (dari total 4.424 mahasiswa). Ini menunjukkan kerentanan besar dalam proses studi mahasiswa.</a:t>
+              <a:t>Berdasarkan analisis awal pada dataset akademik, tercatat tingkat putus kuliah mencapai 39% dari total 4.424 mahasiswa. Tingginya angka ini secara langsung merusak Indikator Kinerja Utama (IKU) institusi pendidikan, menyebabkan inefisiensi alokasi anggaran, dan memberikan dampak sosio-ekonomi negatif pada masa depan mahasiswa.</a:t>
             </a:r>
           </a:p>
           <a:p>
@@ -3425,6 +3431,9 @@
               <a:spcBef>
                 <a:spcPts val="800"/>
               </a:spcBef>
+              <a:spcAft>
+                <a:spcPts val="200"/>
+              </a:spcAft>
               <a:defRPr sz="1800" b="1">
                 <a:solidFill>
                   <a:srgbClr val="FFFFFF"/>
@@ -3432,22 +3441,25 @@
               </a:defRPr>
             </a:pPr>
             <a:r>
-              <a:t>🏫 Dampak Kritis bagi Institusi Pendidikan</a:t>
-            </a:r>
-          </a:p>
-          <a:p>
-            <a:pPr>
+              <a:t>Pengembangan Sistem Deteksi Dini (Early Warning System)</a:t>
+            </a:r>
+          </a:p>
+          <a:p>
+            <a:pPr lvl="1">
+              <a:spcBef>
+                <a:spcPts val="0"/>
+              </a:spcBef>
               <a:spcAft>
-                <a:spcPts val="800"/>
+                <a:spcPts val="1000"/>
               </a:spcAft>
-              <a:defRPr sz="1400">
+              <a:defRPr sz="1400" b="0">
                 <a:solidFill>
                   <a:srgbClr val="CADCFC"/>
                 </a:solidFill>
               </a:defRPr>
             </a:pPr>
             <a:r>
-              <a:t>   Tingginya angka dropout merusak Indikator Kinerja Utama (IKU) universitas, menyebabkan inefisiensi alokasi anggaran, serta merugikan masa depan mahasiswa.</a:t>
+              <a:t>Penelitian ini difokuskan untuk membangun sebuah model klasifikasi cerdas berbasis Machine Learning. Tujuannya adalah mendeteksi secara proaktif mahasiswa yang memiliki probabilitas tinggi untuk dropout sejak semester-semester awal, sehingga pihak akademik dapat melakukan intervensi pencegahan.</a:t>
             </a:r>
           </a:p>
           <a:p>
@@ -3455,6 +3467,9 @@
               <a:spcBef>
                 <a:spcPts val="800"/>
               </a:spcBef>
+              <a:spcAft>
+                <a:spcPts val="200"/>
+              </a:spcAft>
               <a:defRPr sz="1800" b="1">
                 <a:solidFill>
                   <a:srgbClr val="FFFFFF"/>
@@ -3462,52 +3477,25 @@
               </a:defRPr>
             </a:pPr>
             <a:r>
-              <a:t>🎯 Solusi Prediksi Dini (Early Warning System)</a:t>
-            </a:r>
-          </a:p>
-          <a:p>
-            <a:pPr>
+              <a:t>Keselarasan dengan Outcome-Based Education (OBE)</a:t>
+            </a:r>
+          </a:p>
+          <a:p>
+            <a:pPr lvl="1">
+              <a:spcBef>
+                <a:spcPts val="0"/>
+              </a:spcBef>
               <a:spcAft>
-                <a:spcPts val="800"/>
+                <a:spcPts val="1000"/>
               </a:spcAft>
-              <a:defRPr sz="1400">
+              <a:defRPr sz="1400" b="0">
                 <a:solidFill>
                   <a:srgbClr val="CADCFC"/>
                 </a:solidFill>
               </a:defRPr>
             </a:pPr>
             <a:r>
-              <a:t>   Project ini bertujuan mengembangkan sistem klasifikasi cerdas untuk mendeteksi risiko dropout secara otomatis sebelum semester akhir, agar dosen wali dapat melakukan pembinaan preventif.</a:t>
-            </a:r>
-          </a:p>
-          <a:p>
-            <a:pPr>
-              <a:spcBef>
-                <a:spcPts val="800"/>
-              </a:spcBef>
-              <a:defRPr sz="1800" b="1">
-                <a:solidFill>
-                  <a:srgbClr val="FFFFFF"/>
-                </a:solidFill>
-              </a:defRPr>
-            </a:pPr>
-            <a:r>
-              <a:t>📚 Keselarasan dengan OBE (Outcome-Based Education)</a:t>
-            </a:r>
-          </a:p>
-          <a:p>
-            <a:pPr>
-              <a:spcAft>
-                <a:spcPts val="800"/>
-              </a:spcAft>
-              <a:defRPr sz="1400">
-                <a:solidFill>
-                  <a:srgbClr val="CADCFC"/>
-                </a:solidFill>
-              </a:defRPr>
-            </a:pPr>
-            <a:r>
-              <a:t>   Memenuhi capaian pembelajaran CPL-8 (keterampilan analitik dan pemodelan machine learning) serta CPL-10 (pemahaman dampak etis dan tanggung jawab sosial pemanfaatan AI).</a:t>
+              <a:t>Proyek ini disusun untuk mendemonstrasikan pencapaian CPL-8 (Kemampuan analitik dan pemodelan Machine Learning tingkat lanjut) serta CPL-10 (Tanggung jawab etis dalam perancangan dan implementasi kecerdasan buatan).</a:t>
             </a:r>
           </a:p>
         </p:txBody>
@@ -3561,14 +3549,14 @@
           <a:lstStyle/>
           <a:p>
             <a:pPr>
-              <a:defRPr sz="3600" b="1">
+              <a:defRPr sz="3400" b="1">
                 <a:solidFill>
                   <a:srgbClr val="2C3E50"/>
                 </a:solidFill>
               </a:defRPr>
             </a:pPr>
             <a:r>
-              <a:t>Dataset &amp; Data Preprocessing Pipeline</a:t>
+              <a:t>Dataset dan Pemrosesan Data (Preprocessing)</a:t>
             </a:r>
           </a:p>
         </p:txBody>
@@ -3582,7 +3570,7 @@
         <p:spPr>
           <a:xfrm>
             <a:off x="731520" y="1280160"/>
-            <a:ext cx="10698480" cy="4754880"/>
+            <a:ext cx="10698480" cy="5029200"/>
           </a:xfrm>
           <a:prstGeom prst="rect">
             <a:avLst/>
@@ -3600,6 +3588,9 @@
               <a:spcBef>
                 <a:spcPts val="600"/>
               </a:spcBef>
+              <a:spcAft>
+                <a:spcPts val="200"/>
+              </a:spcAft>
               <a:defRPr sz="1600" b="1">
                 <a:solidFill>
                   <a:srgbClr val="2C3E50"/>
@@ -3607,22 +3598,25 @@
               </a:defRPr>
             </a:pPr>
             <a:r>
-              <a:t>1. Dataset &amp; Filtering</a:t>
-            </a:r>
-          </a:p>
-          <a:p>
-            <a:pPr>
+              <a:t>Sumber Data dan Pra-Pemrosesan Target</a:t>
+            </a:r>
+          </a:p>
+          <a:p>
+            <a:pPr lvl="1">
+              <a:spcBef>
+                <a:spcPts val="0"/>
+              </a:spcBef>
               <a:spcAft>
-                <a:spcPts val="600"/>
+                <a:spcPts val="800"/>
               </a:spcAft>
-              <a:defRPr sz="1300">
-                <a:solidFill>
-                  <a:srgbClr val="7F8C8D"/>
-                </a:solidFill>
-              </a:defRPr>
-            </a:pPr>
-            <a:r>
-              <a:t>   Menggunakan dataset UCI 'Predict Students Dropout'. Data Enrolled disaring keluar sehingga menyisakan 3.630 baris data biner: Kelas 1 (Graduate) vs Kelas 0 (Dropout).</a:t>
+              <a:defRPr sz="1300" b="0">
+                <a:solidFill>
+                  <a:srgbClr val="555555"/>
+                </a:solidFill>
+              </a:defRPr>
+            </a:pPr>
+            <a:r>
+              <a:t>Dataset bersumber dari UCI Machine Learning Repository ('Predict Students Dropout and Academic Success'). Observasi dengan status 'Enrolled' disaring keluar untuk memformulasikan masalah ini sebagai klasifikasi biner, menghasilkan 3.630 baris data valid (Graduate vs Dropout).</a:t>
             </a:r>
           </a:p>
           <a:p>
@@ -3630,6 +3624,9 @@
               <a:spcBef>
                 <a:spcPts val="600"/>
               </a:spcBef>
+              <a:spcAft>
+                <a:spcPts val="200"/>
+              </a:spcAft>
               <a:defRPr sz="1600" b="1">
                 <a:solidFill>
                   <a:srgbClr val="2C3E50"/>
@@ -3637,22 +3634,25 @@
               </a:defRPr>
             </a:pPr>
             <a:r>
-              <a:t>2. Seleksi 10 Fitur Terbaik (Mutual Information)</a:t>
-            </a:r>
-          </a:p>
-          <a:p>
-            <a:pPr>
+              <a:t>Seleksi Fitur Terarah (Mutual Information)</a:t>
+            </a:r>
+          </a:p>
+          <a:p>
+            <a:pPr lvl="1">
+              <a:spcBef>
+                <a:spcPts val="0"/>
+              </a:spcBef>
               <a:spcAft>
-                <a:spcPts val="600"/>
+                <a:spcPts val="800"/>
               </a:spcAft>
-              <a:defRPr sz="1300">
-                <a:solidFill>
-                  <a:srgbClr val="7F8C8D"/>
-                </a:solidFill>
-              </a:defRPr>
-            </a:pPr>
-            <a:r>
-              <a:t>   Fitur dipilih berdasarkan skor informasi timbal-balik tertinggi, seperti IPK Semester 1-2, SKS yang disetujui, Usia saat mendaftar, Status pembayaran UKT, dan Penerima Beasiswa.</a:t>
+              <a:defRPr sz="1300" b="0">
+                <a:solidFill>
+                  <a:srgbClr val="555555"/>
+                </a:solidFill>
+              </a:defRPr>
+            </a:pPr>
+            <a:r>
+              <a:t>Untuk menghindari curse of dimensionality, kami mengekstraksi 10 fitur paling prediktif menggunakan pengukuran Mutual Information. Fitur terpilih meliputi riwayat akademik semester 1 dan 2, status pembayaran UKT, serta riwayat beasiswa.</a:t>
             </a:r>
           </a:p>
           <a:p>
@@ -3660,6 +3660,9 @@
               <a:spcBef>
                 <a:spcPts val="600"/>
               </a:spcBef>
+              <a:spcAft>
+                <a:spcPts val="200"/>
+              </a:spcAft>
               <a:defRPr sz="1600" b="1">
                 <a:solidFill>
                   <a:srgbClr val="2C3E50"/>
@@ -3667,22 +3670,25 @@
               </a:defRPr>
             </a:pPr>
             <a:r>
-              <a:t>3. Stratified Data Splitting (80/20)</a:t>
-            </a:r>
-          </a:p>
-          <a:p>
-            <a:pPr>
+              <a:t>Stratified Splitting dan Normalisasi</a:t>
+            </a:r>
+          </a:p>
+          <a:p>
+            <a:pPr lvl="1">
+              <a:spcBef>
+                <a:spcPts val="0"/>
+              </a:spcBef>
               <a:spcAft>
-                <a:spcPts val="600"/>
+                <a:spcPts val="800"/>
               </a:spcAft>
-              <a:defRPr sz="1300">
-                <a:solidFill>
-                  <a:srgbClr val="7F8C8D"/>
-                </a:solidFill>
-              </a:defRPr>
-            </a:pPr>
-            <a:r>
-              <a:t>   Pemisahan data training (2.904 baris) dan testing (726 baris) dengan mempertahankan proporsi kelas asli untuk menjaga objektivitas evaluasi.</a:t>
+              <a:defRPr sz="1300" b="0">
+                <a:solidFill>
+                  <a:srgbClr val="555555"/>
+                </a:solidFill>
+              </a:defRPr>
+            </a:pPr>
+            <a:r>
+              <a:t>Data dibagi menjadi set pelatihan (80%) dan pengujian (20%) secara stratified untuk menjaga proporsi kelas. Seluruh fitur numerik kemudian distandardisasi menggunakan StandardScaler agar model berbasis jarak (KNN, SVM) tidak mengalami bias dimensi.</a:t>
             </a:r>
           </a:p>
           <a:p>
@@ -3690,6 +3696,9 @@
               <a:spcBef>
                 <a:spcPts val="600"/>
               </a:spcBef>
+              <a:spcAft>
+                <a:spcPts val="200"/>
+              </a:spcAft>
               <a:defRPr sz="1600" b="1">
                 <a:solidFill>
                   <a:srgbClr val="2C3E50"/>
@@ -3697,52 +3706,25 @@
               </a:defRPr>
             </a:pPr>
             <a:r>
-              <a:t>4. Robust Scaling (StandardScaler)</a:t>
-            </a:r>
-          </a:p>
-          <a:p>
-            <a:pPr>
+              <a:t>Penanganan Ketidakseimbangan Kelas (SMOTE)</a:t>
+            </a:r>
+          </a:p>
+          <a:p>
+            <a:pPr lvl="1">
+              <a:spcBef>
+                <a:spcPts val="0"/>
+              </a:spcBef>
               <a:spcAft>
-                <a:spcPts val="600"/>
+                <a:spcPts val="800"/>
               </a:spcAft>
-              <a:defRPr sz="1300">
-                <a:solidFill>
-                  <a:srgbClr val="7F8C8D"/>
-                </a:solidFill>
-              </a:defRPr>
-            </a:pPr>
-            <a:r>
-              <a:t>   Normalisasi semua fitur numerik agar tidak ada bias rentang nilai pada KNN dan SVM. Parameter fit hanya diambil dari training set.</a:t>
-            </a:r>
-          </a:p>
-          <a:p>
-            <a:pPr>
-              <a:spcBef>
-                <a:spcPts val="600"/>
-              </a:spcBef>
-              <a:defRPr sz="1600" b="1">
-                <a:solidFill>
-                  <a:srgbClr val="2C3E50"/>
-                </a:solidFill>
-              </a:defRPr>
-            </a:pPr>
-            <a:r>
-              <a:t>5. Class Imbalance Handling (SMOTE)</a:t>
-            </a:r>
-          </a:p>
-          <a:p>
-            <a:pPr>
-              <a:spcAft>
-                <a:spcPts val="600"/>
-              </a:spcAft>
-              <a:defRPr sz="1300">
-                <a:solidFill>
-                  <a:srgbClr val="7F8C8D"/>
-                </a:solidFill>
-              </a:defRPr>
-            </a:pPr>
-            <a:r>
-              <a:t>   Penerapan SMOTE pada data training untuk menyeimbangkan kelas minoritas (Dropout) secara sintetis menjadi 50:50. Data test dibiarkan murni.</a:t>
+              <a:defRPr sz="1300" b="0">
+                <a:solidFill>
+                  <a:srgbClr val="555555"/>
+                </a:solidFill>
+              </a:defRPr>
+            </a:pPr>
+            <a:r>
+              <a:t>Synthetic Minority Over-sampling Technique (SMOTE) diterapkan secara eksklusif pada data latih untuk menyeimbangkan kelas minoritas tanpa menimbulkan fenomena data leakage pada tahap pengujian.</a:t>
             </a:r>
           </a:p>
         </p:txBody>
@@ -3796,14 +3778,14 @@
           <a:lstStyle/>
           <a:p>
             <a:pPr>
-              <a:defRPr sz="3600" b="1">
+              <a:defRPr sz="3400" b="1">
                 <a:solidFill>
                   <a:srgbClr val="FFFFFF"/>
                 </a:solidFill>
               </a:defRPr>
             </a:pPr>
             <a:r>
-              <a:t>Desain Eksperimen &amp; Strategi Optimasi</a:t>
+              <a:t>Desain Eksperimen dan Strategi Optimasi</a:t>
             </a:r>
           </a:p>
         </p:txBody>
@@ -3835,40 +3817,35 @@
               <a:spcBef>
                 <a:spcPts val="800"/>
               </a:spcBef>
-              <a:defRPr sz="1700" b="1">
+              <a:spcAft>
+                <a:spcPts val="200"/>
+              </a:spcAft>
+              <a:defRPr sz="1800" b="1">
                 <a:solidFill>
                   <a:srgbClr val="FFFFFF"/>
                 </a:solidFill>
               </a:defRPr>
             </a:pPr>
             <a:r>
-              <a:t>📊 Tiga Model Klasifikasi</a:t>
-            </a:r>
-          </a:p>
-          <a:p>
-            <a:pPr>
+              <a:t>Algoritma Klasifikasi Baseline</a:t>
+            </a:r>
+          </a:p>
+          <a:p>
+            <a:pPr lvl="1">
               <a:spcBef>
-                <a:spcPts val="300"/>
+                <a:spcPts val="0"/>
               </a:spcBef>
               <a:spcAft>
-                <a:spcPts val="800"/>
+                <a:spcPts val="1000"/>
               </a:spcAft>
-              <a:defRPr sz="1300">
+              <a:defRPr sz="1400" b="0">
                 <a:solidFill>
                   <a:srgbClr val="CADCFC"/>
                 </a:solidFill>
               </a:defRPr>
             </a:pPr>
             <a:r>
-              <a:t>1) K-Nearest Neighbors (KNN)</a:t>
-            </a:r>
-            <a:br/>
-            <a:r>
-              <a:t>2) Naive Bayes (GaussianNB)</a:t>
-            </a:r>
-            <a:br/>
-            <a:r>
-              <a:t>3) Support Vector Machine (SVM) dengan Kernel RBF</a:t>
+              <a:t>Penelitian ini membandingkan kinerja dari tiga algoritma fundamental: K-Nearest Neighbors (KNN), Naive Bayes (GaussianNB), dan Support Vector Machine (SVM). Setiap model dikonfigurasi dengan parameter awal standar untuk mendapatkan garis ukur performa.</a:t>
             </a:r>
           </a:p>
           <a:p>
@@ -3876,44 +3853,47 @@
               <a:spcBef>
                 <a:spcPts val="800"/>
               </a:spcBef>
-              <a:defRPr sz="1700" b="1">
+              <a:spcAft>
+                <a:spcPts val="200"/>
+              </a:spcAft>
+              <a:defRPr sz="1800" b="1">
                 <a:solidFill>
                   <a:srgbClr val="FFFFFF"/>
                 </a:solidFill>
               </a:defRPr>
             </a:pPr>
             <a:r>
-              <a:t>⚙️ Empat Strategi Optimasi Utama</a:t>
-            </a:r>
-          </a:p>
-          <a:p>
-            <a:pPr>
+              <a:t>Implementasi Empat Strategi Optimasi Utama</a:t>
+            </a:r>
+          </a:p>
+          <a:p>
+            <a:pPr lvl="1">
               <a:spcBef>
-                <a:spcPts val="300"/>
+                <a:spcPts val="0"/>
               </a:spcBef>
               <a:spcAft>
-                <a:spcPts val="800"/>
+                <a:spcPts val="1000"/>
               </a:spcAft>
-              <a:defRPr sz="1300">
+              <a:defRPr sz="1400" b="0">
                 <a:solidFill>
                   <a:srgbClr val="CADCFC"/>
                 </a:solidFill>
               </a:defRPr>
             </a:pPr>
             <a:r>
-              <a:t>• Hyperparameter Tuning: GridSearchCV mencari parameter K terbaik pada KNN, smoothing parameter pada NB, dan parameter regulasi C pada SVM.</a:t>
+              <a:t>1. Penyetelan Hyperparameter (Hyperparameter Tuning): Menggunakan GridSearchCV untuk menguji berbagai kombinasi parameter secara ekstensif.</a:t>
             </a:r>
             <a:br/>
             <a:r>
-              <a:t>• Cross-Validation: 5-Fold Stratified CV digunakan untuk menjamin generalisasi parameter.</a:t>
+              <a:t>2. Validasi Silang (Cross-Validation): Menerapkan 5-Fold Stratified CV guna mencegah overfitting dan memastikan keandalan metrik.</a:t>
             </a:r>
             <a:br/>
             <a:r>
-              <a:t>• Dimensionality/Feature Selection: Seleksi 10 fitur Mutual Information.</a:t>
+              <a:t>3. Seleksi Fitur Kuantitatif: Mereduksi dimensi data berbasis signifikansi statistik.</a:t>
             </a:r>
             <a:br/>
             <a:r>
-              <a:t>• Class Balancing: SMOTE oversampling.</a:t>
+              <a:t>4. Balancing Dataset: Modifikasi distribusi data kelas minoritas secara sintetis.</a:t>
             </a:r>
           </a:p>
           <a:p>
@@ -3921,32 +3901,35 @@
               <a:spcBef>
                 <a:spcPts val="800"/>
               </a:spcBef>
-              <a:defRPr sz="1700" b="1">
+              <a:spcAft>
+                <a:spcPts val="200"/>
+              </a:spcAft>
+              <a:defRPr sz="1800" b="1">
                 <a:solidFill>
                   <a:srgbClr val="FFFFFF"/>
                 </a:solidFill>
               </a:defRPr>
             </a:pPr>
             <a:r>
-              <a:t>📈 Pemilihan Metrik Utama (F1-Macro &amp; Balanced Accuracy)</a:t>
-            </a:r>
-          </a:p>
-          <a:p>
-            <a:pPr>
+              <a:t>Pemilihan Metrik Evaluasi Kritis</a:t>
+            </a:r>
+          </a:p>
+          <a:p>
+            <a:pPr lvl="1">
               <a:spcBef>
-                <a:spcPts val="300"/>
+                <a:spcPts val="0"/>
               </a:spcBef>
               <a:spcAft>
-                <a:spcPts val="800"/>
+                <a:spcPts val="1000"/>
               </a:spcAft>
-              <a:defRPr sz="1300">
+              <a:defRPr sz="1400" b="0">
                 <a:solidFill>
                   <a:srgbClr val="CADCFC"/>
                 </a:solidFill>
               </a:defRPr>
             </a:pPr>
             <a:r>
-              <a:t>Metrik F1-Macro dipilih sebagai metrik prioritas pengganti akurasi karena mampu menilai keadilan model terhadap kedua kelas target secara seimbang (tidak bias mayoritas).</a:t>
+              <a:t>Mengingat distribusi data yang tidak seimbang, penilaian model ditekankan pada metrik F1-Macro dan Balanced Accuracy, alih-alih Akurasi konvensional, untuk memastikan evaluasi yang adil terhadap sensitivitas pendeteksian mahasiswa putus kuliah.</a:t>
             </a:r>
           </a:p>
         </p:txBody>
@@ -4000,14 +3983,14 @@
           <a:lstStyle/>
           <a:p>
             <a:pPr>
-              <a:defRPr sz="3600" b="1">
+              <a:defRPr sz="3400" b="1">
                 <a:solidFill>
                   <a:srgbClr val="2C3E50"/>
                 </a:solidFill>
               </a:defRPr>
             </a:pPr>
             <a:r>
-              <a:t>Hasil Eksperimen &amp; Model Terbaik</a:t>
+              <a:t>Hasil Eksperimen Komparatif</a:t>
             </a:r>
           </a:p>
         </p:txBody>
@@ -4031,9 +4014,9 @@
                 <a:tableStyleId>{5C22544A-7EE6-4342-B048-85BDC9FD1C3A}</a:tableStyleId>
               </a:tblPr>
               <a:tblGrid>
-                <a:gridCol w="2377440"/>
-                <a:gridCol w="1463040"/>
-                <a:gridCol w="1463040"/>
+                <a:gridCol w="2926080"/>
+                <a:gridCol w="1188720"/>
+                <a:gridCol w="1188720"/>
               </a:tblGrid>
               <a:tr h="496388">
                 <a:tc>
@@ -4049,7 +4032,7 @@
                         </a:defRPr>
                       </a:pPr>
                       <a:r>
-                        <a:t>Model</a:t>
+                        <a:t>Model Klasifikasi</a:t>
                       </a:r>
                     </a:p>
                   </a:txBody>
@@ -4116,7 +4099,7 @@
                         <a:defRPr sz="1200"/>
                       </a:pPr>
                       <a:r>
-                        <a:t>KNN Baseline</a:t>
+                        <a:t>K-Nearest Neighbors (Baseline)</a:t>
                       </a:r>
                     </a:p>
                   </a:txBody>
@@ -4163,7 +4146,7 @@
                         <a:defRPr sz="1200"/>
                       </a:pPr>
                       <a:r>
-                        <a:t>Naive Bayes Baseline</a:t>
+                        <a:t>Naive Bayes (Baseline)</a:t>
                       </a:r>
                     </a:p>
                   </a:txBody>
@@ -4222,7 +4205,7 @@
                         <a:defRPr sz="1200" b="1"/>
                       </a:pPr>
                       <a:r>
-                        <a:t>SVM Baseline 🏆</a:t>
+                        <a:t>Support Vector Machine (Baseline)</a:t>
                       </a:r>
                     </a:p>
                   </a:txBody>
@@ -4281,7 +4264,7 @@
                         <a:defRPr sz="1200"/>
                       </a:pPr>
                       <a:r>
-                        <a:t>KNN Optimized</a:t>
+                        <a:t>K-Nearest Neighbors (Optimized)</a:t>
                       </a:r>
                     </a:p>
                   </a:txBody>
@@ -4340,7 +4323,7 @@
                         <a:defRPr sz="1200"/>
                       </a:pPr>
                       <a:r>
-                        <a:t>Naive Bayes Optimized</a:t>
+                        <a:t>Naive Bayes (Optimized)</a:t>
                       </a:r>
                     </a:p>
                   </a:txBody>
@@ -4387,7 +4370,7 @@
                         <a:defRPr sz="1200"/>
                       </a:pPr>
                       <a:r>
-                        <a:t>SVM Optimized</a:t>
+                        <a:t>Support Vector Machine (Optimized)</a:t>
                       </a:r>
                     </a:p>
                   </a:txBody>
@@ -4485,20 +4468,41 @@
             <a:spAutoFit/>
           </a:bodyPr>
           <a:lstStyle/>
+          <a:p/>
           <a:p>
             <a:pPr>
-              <a:defRPr sz="1300" b="1">
+              <a:spcBef>
+                <a:spcPts val="0"/>
+              </a:spcBef>
+              <a:spcAft>
+                <a:spcPts val="200"/>
+              </a:spcAft>
+              <a:defRPr sz="1400" b="1">
                 <a:solidFill>
                   <a:srgbClr val="2C3E50"/>
                 </a:solidFill>
               </a:defRPr>
             </a:pPr>
             <a:r>
-              <a:t>🏆 MODEL TERBAIK: SVM Baseline (Kernel RBF, C=1.0, class_weight='balanced') dengan F1-Macro 0.8869.</a:t>
-            </a:r>
-            <a:br/>
-            <a:r>
-              <a:t>Optimasi eksternal (SMOTE + 8 fitur) mengalami sedikit degradasi F1 (0.884) karena hilangnya beberapa informasi prediktif.</a:t>
+              <a:t>Model Terbaik: Support Vector Machine (Baseline)</a:t>
+            </a:r>
+          </a:p>
+          <a:p>
+            <a:pPr>
+              <a:spcBef>
+                <a:spcPts val="0"/>
+              </a:spcBef>
+              <a:spcAft>
+                <a:spcPts val="0"/>
+              </a:spcAft>
+              <a:defRPr sz="1200" b="0">
+                <a:solidFill>
+                  <a:srgbClr val="555555"/>
+                </a:solidFill>
+              </a:defRPr>
+            </a:pPr>
+            <a:r>
+              <a:t>Model SVM Baseline yang dikonfigurasi dengan kernel RBF dan parameter penyeimbang bobot kelas internal terbukti menghasilkan metrik evaluasi tertinggi. Eksperimen optimasi sekunder (SMOTE dan pengurangan jumlah fitur) pada SVM menyebabkan sedikit penurunan performa analitik karena terjadinya kehilangan beberapa informasi residual.</a:t>
             </a:r>
           </a:p>
         </p:txBody>
@@ -4552,14 +4556,14 @@
           <a:lstStyle/>
           <a:p>
             <a:pPr>
-              <a:defRPr sz="3600" b="1">
+              <a:defRPr sz="3400" b="1">
                 <a:solidFill>
                   <a:srgbClr val="2C3E50"/>
                 </a:solidFill>
               </a:defRPr>
             </a:pPr>
             <a:r>
-              <a:t>Empirical Error Analysis</a:t>
+              <a:t>Analisis Kesalahan Empiris (Error Analysis)</a:t>
             </a:r>
           </a:p>
         </p:txBody>
@@ -4573,7 +4577,7 @@
         <p:spPr>
           <a:xfrm>
             <a:off x="731520" y="1371600"/>
-            <a:ext cx="5303520" cy="4572000"/>
+            <a:ext cx="5486400" cy="4572000"/>
           </a:xfrm>
           <a:prstGeom prst="rect">
             <a:avLst/>
@@ -4591,6 +4595,9 @@
               <a:spcBef>
                 <a:spcPts val="600"/>
               </a:spcBef>
+              <a:spcAft>
+                <a:spcPts val="200"/>
+              </a:spcAft>
               <a:defRPr sz="1500" b="1">
                 <a:solidFill>
                   <a:srgbClr val="2C3E50"/>
@@ -4598,26 +4605,41 @@
               </a:defRPr>
             </a:pPr>
             <a:r>
-              <a:t>📊 Distribusi Kesalahan Model</a:t>
-            </a:r>
-          </a:p>
-          <a:p>
-            <a:pPr>
+              <a:t>Distribusi Kesalahan Prediksi Klasifikasi</a:t>
+            </a:r>
+          </a:p>
+          <a:p>
+            <a:pPr lvl="1">
+              <a:spcBef>
+                <a:spcPts val="0"/>
+              </a:spcBef>
               <a:spcAft>
-                <a:spcPts val="600"/>
+                <a:spcPts val="800"/>
               </a:spcAft>
-              <a:defRPr sz="1200">
-                <a:solidFill>
-                  <a:srgbClr val="7F8C8D"/>
-                </a:solidFill>
-              </a:defRPr>
-            </a:pPr>
-            <a:r>
-              <a:t>• True Positive: 415 | True Negative: 234</a:t>
+              <a:defRPr sz="1300" b="0">
+                <a:solidFill>
+                  <a:srgbClr val="555555"/>
+                </a:solidFill>
+              </a:defRPr>
+            </a:pPr>
+            <a:r>
+              <a:t>Berdasarkan matriks kebingungan (Confusion Matrix) di samping, SVM menghasilkan:</a:t>
             </a:r>
             <a:br/>
             <a:r>
-              <a:t>• False Positive (FP): 50 | False Negative (FN): 27</a:t>
+              <a:t>- True Positive: 415 observasi</a:t>
+            </a:r>
+            <a:br/>
+            <a:r>
+              <a:t>- True Negative: 234 observasi</a:t>
+            </a:r>
+            <a:br/>
+            <a:r>
+              <a:t>- False Positive (Salah klasifikasi sebagai Lulus): 50 observasi</a:t>
+            </a:r>
+            <a:br/>
+            <a:r>
+              <a:t>- False Negative (Salah klasifikasi sebagai Dropout): 27 observasi</a:t>
             </a:r>
           </a:p>
           <a:p>
@@ -4625,6 +4647,9 @@
               <a:spcBef>
                 <a:spcPts val="600"/>
               </a:spcBef>
+              <a:spcAft>
+                <a:spcPts val="200"/>
+              </a:spcAft>
               <a:defRPr sz="1500" b="1">
                 <a:solidFill>
                   <a:srgbClr val="2C3E50"/>
@@ -4632,22 +4657,25 @@
               </a:defRPr>
             </a:pPr>
             <a:r>
-              <a:t>🕵️ Pola Kesalahan yang Ditemukan</a:t>
-            </a:r>
-          </a:p>
-          <a:p>
-            <a:pPr>
+              <a:t>Identifikasi Pola Kesalahan</a:t>
+            </a:r>
+          </a:p>
+          <a:p>
+            <a:pPr lvl="1">
+              <a:spcBef>
+                <a:spcPts val="0"/>
+              </a:spcBef>
               <a:spcAft>
-                <a:spcPts val="600"/>
+                <a:spcPts val="800"/>
               </a:spcAft>
-              <a:defRPr sz="1200">
-                <a:solidFill>
-                  <a:srgbClr val="7F8C8D"/>
-                </a:solidFill>
-              </a:defRPr>
-            </a:pPr>
-            <a:r>
-              <a:t>Mahasiswa yang memiliki SKS tinggi (Semester 1 &amp; 2 lengkap) tetapi mendadak dropout sering kali gagal dideteksi oleh model (terprediksi Graduate).</a:t>
+              <a:defRPr sz="1300" b="0">
+                <a:solidFill>
+                  <a:srgbClr val="555555"/>
+                </a:solidFill>
+              </a:defRPr>
+            </a:pPr>
+            <a:r>
+              <a:t>Penyelidikan lebih mendalam terhadap 50 kasus False Positive menunjukkan suatu pola konsisten: mahasiswa yang teridentifikasi memiliki skor akademis (SKS dan IPK) yang memuaskan di tahun pertama, namun pada kenyataannya tetap mengalami status putus kuliah.</a:t>
             </a:r>
           </a:p>
           <a:p>
@@ -4655,6 +4683,9 @@
               <a:spcBef>
                 <a:spcPts val="600"/>
               </a:spcBef>
+              <a:spcAft>
+                <a:spcPts val="200"/>
+              </a:spcAft>
               <a:defRPr sz="1500" b="1">
                 <a:solidFill>
                   <a:srgbClr val="2C3E50"/>
@@ -4662,22 +4693,25 @@
               </a:defRPr>
             </a:pPr>
             <a:r>
-              <a:t>💡 Penyebab Logis Kegagalan Model</a:t>
-            </a:r>
-          </a:p>
-          <a:p>
-            <a:pPr>
+              <a:t>Kesimpulan Keterbatasan Data Tabular</a:t>
+            </a:r>
+          </a:p>
+          <a:p>
+            <a:pPr lvl="1">
+              <a:spcBef>
+                <a:spcPts val="0"/>
+              </a:spcBef>
               <a:spcAft>
-                <a:spcPts val="600"/>
+                <a:spcPts val="800"/>
               </a:spcAft>
-              <a:defRPr sz="1200">
-                <a:solidFill>
-                  <a:srgbClr val="7F8C8D"/>
-                </a:solidFill>
-              </a:defRPr>
-            </a:pPr>
-            <a:r>
-              <a:t>Banyak mahasiswa dropout karena faktor eksternal (seperti kesulitan finansial pribadi, masalah kesehatan, atau faktor keluarga) yang datanya tidak terekam dalam atribut akademis. Ini membuktikan batasan machine learning tabular akademik.</a:t>
+              <a:defRPr sz="1300" b="0">
+                <a:solidFill>
+                  <a:srgbClr val="555555"/>
+                </a:solidFill>
+              </a:defRPr>
+            </a:pPr>
+            <a:r>
+              <a:t>Model secara fundamental terbatas oleh cakupan variabel yang diukur. Dropout pada mahasiswa berprestasi seringkali dipicu oleh anomali non-akademik, seperti kesulitan perekonomian keluarga atau persoalan medis, yang sama sekali tidak direpresentasikan dalam struktur dataset ini.</a:t>
             </a:r>
           </a:p>
         </p:txBody>
@@ -4698,8 +4732,8 @@
         </p:blipFill>
         <p:spPr>
           <a:xfrm>
-            <a:off x="6583680" y="1371600"/>
-            <a:ext cx="4572000" cy="3810000"/>
+            <a:off x="6766560" y="1371600"/>
+            <a:ext cx="4389120" cy="3657600"/>
           </a:xfrm>
           <a:prstGeom prst="rect">
             <a:avLst/>
@@ -4755,14 +4789,14 @@
           <a:lstStyle/>
           <a:p>
             <a:pPr>
-              <a:defRPr sz="3600" b="1">
+              <a:defRPr sz="3400" b="1">
                 <a:solidFill>
                   <a:srgbClr val="FFFFFF"/>
                 </a:solidFill>
               </a:defRPr>
             </a:pPr>
             <a:r>
-              <a:t>Pembahasan Akademik &amp; Implikasi Institusi</a:t>
+              <a:t>Pembahasan Analitis dan Implikasi Praktis</a:t>
             </a:r>
           </a:p>
         </p:txBody>
@@ -4791,6 +4825,12 @@
           <a:p/>
           <a:p>
             <a:pPr>
+              <a:spcBef>
+                <a:spcPts val="800"/>
+              </a:spcBef>
+              <a:spcAft>
+                <a:spcPts val="200"/>
+              </a:spcAft>
               <a:defRPr sz="1800" b="1">
                 <a:solidFill>
                   <a:srgbClr val="FFFFFF"/>
@@ -4798,77 +4838,97 @@
               </a:defRPr>
             </a:pPr>
             <a:r>
-              <a:t>⚖️ Trade-off Akurasi vs Kompleksitas vs Interpretabilitas</a:t>
+              <a:t>Trade-off Performa Pemodelan dan Interpretabilitas</a:t>
+            </a:r>
+          </a:p>
+          <a:p>
+            <a:pPr lvl="1">
+              <a:spcBef>
+                <a:spcPts val="0"/>
+              </a:spcBef>
+              <a:spcAft>
+                <a:spcPts val="1000"/>
+              </a:spcAft>
+              <a:defRPr sz="1400" b="0">
+                <a:solidFill>
+                  <a:srgbClr val="CADCFC"/>
+                </a:solidFill>
+              </a:defRPr>
+            </a:pPr>
+            <a:r>
+              <a:t>Evaluasi model menyoroti keseimbangan klasik dalam Machine Learning: algoritma kompleks seperti SVM RBF menghasilkan presisi dan F1-Macro tertinggi (0.887), namun beroperasi dengan sifat black-box. Sebaliknya, metode probabilistik Naive Bayes sangat transparan untuk dijelaskan fungsinya secara statistik, tetapi gagal mencapai recall yang memadai pada kelas mayoritas.</a:t>
             </a:r>
           </a:p>
           <a:p>
             <a:pPr>
+              <a:spcBef>
+                <a:spcPts val="800"/>
+              </a:spcBef>
               <a:spcAft>
+                <a:spcPts val="200"/>
+              </a:spcAft>
+              <a:defRPr sz="1800" b="1">
+                <a:solidFill>
+                  <a:srgbClr val="FFFFFF"/>
+                </a:solidFill>
+              </a:defRPr>
+            </a:pPr>
+            <a:r>
+              <a:t>Signifikansi dan Implikasi Kebijakan Institusi</a:t>
+            </a:r>
+          </a:p>
+          <a:p>
+            <a:pPr lvl="1">
+              <a:spcBef>
+                <a:spcPts val="0"/>
+              </a:spcBef>
+              <a:spcAft>
+                <a:spcPts val="1000"/>
+              </a:spcAft>
+              <a:defRPr sz="1400" b="0">
+                <a:solidFill>
+                  <a:srgbClr val="CADCFC"/>
+                </a:solidFill>
+              </a:defRPr>
+            </a:pPr>
+            <a:r>
+              <a:t>Sistem klasifikasi ini memiliki potensi strategis sebagai komponen inti dari Early Warning System di universitas. Mahasiswa yang diproyeksikan memiliki risiko tinggi dapat segera dialokasikan pada program intervensi preventif, seperti konseling akademik intensif atau penyediaan opsi bantuan finansial berkelanjutan.</a:t>
+            </a:r>
+          </a:p>
+          <a:p>
+            <a:pPr>
+              <a:spcBef>
                 <a:spcPts val="1200"/>
+              </a:spcBef>
+              <a:spcAft>
+                <a:spcPts val="200"/>
               </a:spcAft>
-              <a:defRPr sz="1400">
+              <a:defRPr sz="1600" b="1">
+                <a:solidFill>
+                  <a:srgbClr val="C0392B"/>
+                </a:solidFill>
+              </a:defRPr>
+            </a:pPr>
+            <a:r>
+              <a:t>Batasan Etis Implementasi Kecerdasan Buatan</a:t>
+            </a:r>
+          </a:p>
+          <a:p>
+            <a:pPr lvl="1">
+              <a:spcBef>
+                <a:spcPts val="0"/>
+              </a:spcBef>
+              <a:spcAft>
+                <a:spcPts val="1000"/>
+              </a:spcAft>
+              <a:defRPr sz="1300" b="0">
                 <a:solidFill>
                   <a:srgbClr val="CADCFC"/>
                 </a:solidFill>
               </a:defRPr>
             </a:pPr>
             <a:r>
-              <a:t>   • SVM RBF: Akurasi &amp; F1-Macro tertinggi (0.887), tetapi sulit diinterpretasikan secara langsung (black-box).</a:t>
-            </a:r>
-            <a:br/>
-            <a:r>
-              <a:t>   • Naive Bayes: Paling cepat dan sangat mudah diinterpretasikan secara statistik, tetapi recall kelas Dropout-nya paling rendah.</a:t>
-            </a:r>
-            <a:br/>
-            <a:r>
-              <a:t>   • K-Nearest Neighbors: Sederhana dan intuitif, tetapi sensitif terhadap noise dan penentuan nilai K.</a:t>
-            </a:r>
-          </a:p>
-          <a:p>
-            <a:pPr>
-              <a:defRPr sz="1800" b="1">
-                <a:solidFill>
-                  <a:srgbClr val="FFFFFF"/>
-                </a:solidFill>
-              </a:defRPr>
-            </a:pPr>
-            <a:r>
-              <a:t>🏛️ Implikasi untuk Institusi Pendidikan</a:t>
-            </a:r>
-          </a:p>
-          <a:p>
-            <a:pPr>
-              <a:spcAft>
-                <a:spcPts val="1200"/>
-              </a:spcAft>
-              <a:defRPr sz="1400">
-                <a:solidFill>
-                  <a:srgbClr val="CADCFC"/>
-                </a:solidFill>
-              </a:defRPr>
-            </a:pPr>
-            <a:r>
-              <a:t>   1. Pemasangan Early Warning System (EWS): Membantu Biro Akademik mendeteksi mahasiswa terancam DO sejak semester 2.</a:t>
-            </a:r>
-            <a:br/>
-            <a:r>
-              <a:t>   2. Program Intervensi Preventif: Pihak kampus dapat memberikan beasiswa bagi yang terkendala ukt atau konseling khusus.</a:t>
-            </a:r>
-            <a:br/>
-            <a:r>
-              <a:t>   3. Tanggung Jawab Sosial: Meminimalisir angka putus kuliah secara signifikan guna meningkatkan reputasi institusi.</a:t>
-            </a:r>
-          </a:p>
-          <a:p>
-            <a:pPr>
-              <a:defRPr sz="1300" b="1">
-                <a:solidFill>
-                  <a:srgbClr val="FF8C8C"/>
-                </a:solidFill>
-              </a:defRPr>
-            </a:pPr>
-            <a:r>
-              <a:t>⚠️ BATASAN ETIS: Model HANYA berfungsi sebagai sistem pendukung keputusan (Decision Support System) bagi dosen wali. Keputusan drop out tidak boleh dilakukan secara otomatis oleh sistem AI.</a:t>
+              <a:t>Model prediktif ini dikonstruksi secara eksklusif sebagai Decision Support System (sistem penunjang keputusan). Kebijakan akademik yang memengaruhi nasib mahasiswa dilarang dieksekusi secara otomatis oleh algoritma, dan validasi otoritas tenaga pendidik (Dosen Wali) tetap bersifat mutlak.</a:t>
             </a:r>
           </a:p>
         </p:txBody>
@@ -4922,14 +4982,14 @@
           <a:lstStyle/>
           <a:p>
             <a:pPr>
-              <a:defRPr sz="3600" b="1">
+              <a:defRPr sz="3400" b="1">
                 <a:solidFill>
                   <a:srgbClr val="2C3E50"/>
                 </a:solidFill>
               </a:defRPr>
             </a:pPr>
             <a:r>
-              <a:t>Desain Aplikasi &amp; Antarmuka UI/UX</a:t>
+              <a:t>Desain Aplikasi Antarmuka Pengguna</a:t>
             </a:r>
           </a:p>
         </p:txBody>
@@ -4961,6 +5021,9 @@
               <a:spcBef>
                 <a:spcPts val="600"/>
               </a:spcBef>
+              <a:spcAft>
+                <a:spcPts val="200"/>
+              </a:spcAft>
               <a:defRPr sz="1600" b="1">
                 <a:solidFill>
                   <a:srgbClr val="2C3E50"/>
@@ -4968,22 +5031,25 @@
               </a:defRPr>
             </a:pPr>
             <a:r>
-              <a:t>🖥️ Streamlit Frontend Dashboard</a:t>
-            </a:r>
-          </a:p>
-          <a:p>
-            <a:pPr>
+              <a:t>Arsitektur Antarmuka Streamlit (Main Frontend)</a:t>
+            </a:r>
+          </a:p>
+          <a:p>
+            <a:pPr lvl="1">
+              <a:spcBef>
+                <a:spcPts val="0"/>
+              </a:spcBef>
               <a:spcAft>
-                <a:spcPts val="600"/>
+                <a:spcPts val="1000"/>
               </a:spcAft>
-              <a:defRPr sz="1300">
-                <a:solidFill>
-                  <a:srgbClr val="7F8C8D"/>
-                </a:solidFill>
-              </a:defRPr>
-            </a:pPr>
-            <a:r>
-              <a:t>Didesain dengan 4 menu utama: (1) Prediksi Mandiri: Form interaktif 10 input dengan output status kelulusan + tingkat kepercayaan model, (2) Dashboard Visualisasi Dataset, (3) Tabel Perbandingan Performa 6 Model, (4) Edukasi/Penjelasan Model Klasifikasi.</a:t>
+              <a:defRPr sz="1400" b="0">
+                <a:solidFill>
+                  <a:srgbClr val="555555"/>
+                </a:solidFill>
+              </a:defRPr>
+            </a:pPr>
+            <a:r>
+              <a:t>Sebuah web dashboard komprehensif dikembangkan mencakup empat struktur panel: (1) Mesin Prediksi Interaktif dengan penunjuk nilai kepercayaan model, (2) Panel Visualisasi Eksploratori Dataset, (3) Laporan Integritas Metrik Evaluasi, dan (4) Dokumentasi Edukasi Model secara naratif.</a:t>
             </a:r>
           </a:p>
           <a:p>
@@ -4991,6 +5057,9 @@
               <a:spcBef>
                 <a:spcPts val="600"/>
               </a:spcBef>
+              <a:spcAft>
+                <a:spcPts val="200"/>
+              </a:spcAft>
               <a:defRPr sz="1600" b="1">
                 <a:solidFill>
                   <a:srgbClr val="2C3E50"/>
@@ -4998,22 +5067,25 @@
               </a:defRPr>
             </a:pPr>
             <a:r>
-              <a:t>⚡ FastAPI Backend Rest API</a:t>
-            </a:r>
-          </a:p>
-          <a:p>
-            <a:pPr>
+              <a:t>Desain Restful API (FastAPI Backend)</a:t>
+            </a:r>
+          </a:p>
+          <a:p>
+            <a:pPr lvl="1">
+              <a:spcBef>
+                <a:spcPts val="0"/>
+              </a:spcBef>
               <a:spcAft>
-                <a:spcPts val="600"/>
+                <a:spcPts val="1000"/>
               </a:spcAft>
-              <a:defRPr sz="1300">
-                <a:solidFill>
-                  <a:srgbClr val="7F8C8D"/>
-                </a:solidFill>
-              </a:defRPr>
-            </a:pPr>
-            <a:r>
-              <a:t>Menyediakan endpoint `/predict` berbasis JSON yang siap diintegrasikan dengan Sistem Informasi Akademik (SIAKAD) universitas secara real-time.</a:t>
+              <a:defRPr sz="1400" b="0">
+                <a:solidFill>
+                  <a:srgbClr val="555555"/>
+                </a:solidFill>
+              </a:defRPr>
+            </a:pPr>
+            <a:r>
+              <a:t>Infrastruktur inferensi dienkapsulasi menggunakan protokol FastAPI, menghasilkan endpoint berbasis JSON yang terstandardisasi dan mendukung dokumentasi Swagger UI. Arsitektur ini memungkinkan injeksi langsung ke dalam Sistem Informasi Akademik (SIAKAD) berskala produksi.</a:t>
             </a:r>
           </a:p>
           <a:p>
@@ -5021,6 +5093,9 @@
               <a:spcBef>
                 <a:spcPts val="600"/>
               </a:spcBef>
+              <a:spcAft>
+                <a:spcPts val="200"/>
+              </a:spcAft>
               <a:defRPr sz="1600" b="1">
                 <a:solidFill>
                   <a:srgbClr val="2C3E50"/>
@@ -5028,52 +5103,25 @@
               </a:defRPr>
             </a:pPr>
             <a:r>
-              <a:t>🎛️ Gradio Alternative UI</a:t>
-            </a:r>
-          </a:p>
-          <a:p>
-            <a:pPr>
+              <a:t>Integrasi Kepatuhan Etika</a:t>
+            </a:r>
+          </a:p>
+          <a:p>
+            <a:pPr lvl="1">
+              <a:spcBef>
+                <a:spcPts val="0"/>
+              </a:spcBef>
               <a:spcAft>
-                <a:spcPts val="600"/>
+                <a:spcPts val="1000"/>
               </a:spcAft>
-              <a:defRPr sz="1300">
-                <a:solidFill>
-                  <a:srgbClr val="7F8C8D"/>
-                </a:solidFill>
-              </a:defRPr>
-            </a:pPr>
-            <a:r>
-              <a:t>UI alternatif berdesain minimalis yang memfasilitasi pengujian model cepat dengan drag-and-drop input.</a:t>
-            </a:r>
-          </a:p>
-          <a:p>
-            <a:pPr>
-              <a:spcBef>
-                <a:spcPts val="600"/>
-              </a:spcBef>
-              <a:defRPr sz="1600" b="1">
-                <a:solidFill>
-                  <a:srgbClr val="2C3E50"/>
-                </a:solidFill>
-              </a:defRPr>
-            </a:pPr>
-            <a:r>
-              <a:t>🛡️ Fitur Keamanan &amp; Desain Etis</a:t>
-            </a:r>
-          </a:p>
-          <a:p>
-            <a:pPr>
-              <a:spcAft>
-                <a:spcPts val="600"/>
-              </a:spcAft>
-              <a:defRPr sz="1300">
-                <a:solidFill>
-                  <a:srgbClr val="7F8C8D"/>
-                </a:solidFill>
-              </a:defRPr>
-            </a:pPr>
-            <a:r>
-              <a:t>Tiap antarmuka dilengkapi disclaimer etika, penanganan input tidak valid, serta peringatan probabilitas rendah.</a:t>
+              <a:defRPr sz="1400" b="0">
+                <a:solidFill>
+                  <a:srgbClr val="555555"/>
+                </a:solidFill>
+              </a:defRPr>
+            </a:pPr>
+            <a:r>
+              <a:t>Seluruh antarmuka secara eksplisit mencantumkan penafian (disclaimer) etis dan instruksi pemahaman probabilitas. Hal ini mengedukasi pengguna akhir bahwa setiap output mesin hanyalah alat bantu administratif, bukan vonis akademis pasti.</a:t>
             </a:r>
           </a:p>
         </p:txBody>
@@ -5127,14 +5175,14 @@
           <a:lstStyle/>
           <a:p>
             <a:pPr>
-              <a:defRPr sz="3600" b="1">
+              <a:defRPr sz="3400" b="1">
                 <a:solidFill>
                   <a:srgbClr val="FFFFFF"/>
                 </a:solidFill>
               </a:defRPr>
             </a:pPr>
             <a:r>
-              <a:t>Kesimpulan &amp; Rekomendasi</a:t>
+              <a:t>Kesimpulan dan Rekomendasi Lanjutan</a:t>
             </a:r>
           </a:p>
         </p:txBody>
@@ -5166,29 +5214,35 @@
               <a:spcBef>
                 <a:spcPts val="800"/>
               </a:spcBef>
-              <a:defRPr sz="1700" b="1">
+              <a:spcAft>
+                <a:spcPts val="200"/>
+              </a:spcAft>
+              <a:defRPr sz="1800" b="1">
                 <a:solidFill>
                   <a:srgbClr val="FFFFFF"/>
                 </a:solidFill>
               </a:defRPr>
             </a:pPr>
             <a:r>
-              <a:t>1. Capaian Target Model</a:t>
-            </a:r>
-          </a:p>
-          <a:p>
-            <a:pPr>
+              <a:t>Kesimpulan Efektivitas Model</a:t>
+            </a:r>
+          </a:p>
+          <a:p>
+            <a:pPr lvl="1">
+              <a:spcBef>
+                <a:spcPts val="0"/>
+              </a:spcBef>
               <a:spcAft>
-                <a:spcPts val="800"/>
+                <a:spcPts val="1000"/>
               </a:spcAft>
-              <a:defRPr sz="1300">
+              <a:defRPr sz="1400" b="0">
                 <a:solidFill>
                   <a:srgbClr val="CADCFC"/>
                 </a:solidFill>
               </a:defRPr>
             </a:pPr>
             <a:r>
-              <a:t>Model SVM Baseline berhasil mendeteksi risiko kelulusan mahasiswa dengan akurasi 89,39% dan F1-Macro 0.8869, sangat stabil dan siap dideploy.</a:t>
+              <a:t>Pendekatan berbasis Support Vector Machine secara konsisten mempertahankan superioritas metrik dengan F1-Macro sebesar 0.8869 dan akurasi umum 89,39%. Reduksi set parameter ke dalam 10 fitur utama terbukti mumpuni untuk membentuk batas keputusan yang tangguh tanpa mencederai komputasi waktu inferensi.</a:t>
             </a:r>
           </a:p>
           <a:p>
@@ -5196,29 +5250,35 @@
               <a:spcBef>
                 <a:spcPts val="800"/>
               </a:spcBef>
-              <a:defRPr sz="1700" b="1">
+              <a:spcAft>
+                <a:spcPts val="200"/>
+              </a:spcAft>
+              <a:defRPr sz="1800" b="1">
                 <a:solidFill>
                   <a:srgbClr val="FFFFFF"/>
                 </a:solidFill>
               </a:defRPr>
             </a:pPr>
             <a:r>
-              <a:t>2. Keterbatasan Penelitian</a:t>
-            </a:r>
-          </a:p>
-          <a:p>
-            <a:pPr>
+              <a:t>Identifikasi Keterbatasan Domain</a:t>
+            </a:r>
+          </a:p>
+          <a:p>
+            <a:pPr lvl="1">
+              <a:spcBef>
+                <a:spcPts val="0"/>
+              </a:spcBef>
               <a:spcAft>
-                <a:spcPts val="800"/>
+                <a:spcPts val="1000"/>
               </a:spcAft>
-              <a:defRPr sz="1300">
+              <a:defRPr sz="1400" b="0">
                 <a:solidFill>
                   <a:srgbClr val="CADCFC"/>
                 </a:solidFill>
               </a:defRPr>
             </a:pPr>
             <a:r>
-              <a:t>Dataset yang digunakan didominasi oleh riwayat mahasiswa dari Portugal. Diperlukan penyesuaian (transfer learning) sebelum diterapkan langsung di Indonesia.</a:t>
+              <a:t>Validitas algoritma saat ini dibatasi oleh demografi asal (data historis mahasiswa Portugal). Generalisasi performa terhadap data mahasiswa di lanskap pendidikan Indonesia mengharuskan proses kalibrasi ulang atau penerapan metode transfer learning.</a:t>
             </a:r>
           </a:p>
           <a:p>
@@ -5226,37 +5286,35 @@
               <a:spcBef>
                 <a:spcPts val="800"/>
               </a:spcBef>
-              <a:defRPr sz="1700" b="1">
+              <a:spcAft>
+                <a:spcPts val="200"/>
+              </a:spcAft>
+              <a:defRPr sz="1800" b="1">
                 <a:solidFill>
                   <a:srgbClr val="FFFFFF"/>
                 </a:solidFill>
               </a:defRPr>
             </a:pPr>
             <a:r>
-              <a:t>3. Rekomendasi Pengembangan Masa Depan</a:t>
-            </a:r>
-          </a:p>
-          <a:p>
-            <a:pPr>
+              <a:t>Saran Pengembangan Penelitian Berkala</a:t>
+            </a:r>
+          </a:p>
+          <a:p>
+            <a:pPr lvl="1">
+              <a:spcBef>
+                <a:spcPts val="0"/>
+              </a:spcBef>
               <a:spcAft>
-                <a:spcPts val="800"/>
+                <a:spcPts val="1000"/>
               </a:spcAft>
-              <a:defRPr sz="1300">
+              <a:defRPr sz="1400" b="0">
                 <a:solidFill>
                   <a:srgbClr val="CADCFC"/>
                 </a:solidFill>
               </a:defRPr>
             </a:pPr>
             <a:r>
-              <a:t>• Integrasikan dengan data lokal universitas untuk pelatihan ulang.</a:t>
-            </a:r>
-            <a:br/>
-            <a:r>
-              <a:t>• Gunakan metode Ensemble Stacking (kombinasi SVM, KNN, Random Forest) untuk menaikkan performa.</a:t>
-            </a:r>
-            <a:br/>
-            <a:r>
-              <a:t>• Implementasikan framework eXplainable AI (seperti SHAP) agar dosen wali memahami alasan di balik setiap prediksi.</a:t>
+              <a:t>Direkomendasikan agar studi masa depan merangkul teknologi Ensemble Stacking multivariat, mengintegrasikan framework Explainable AI (khususnya nilai Shapley/SHAP) guna menghapus sifat black-box model, serta mengemas keseluruhan lingkungan deployment ke dalam arsitektur terisolasi berbasis Docker.</a:t>
             </a:r>
           </a:p>
         </p:txBody>

</xml_diff>

<commit_message>
docs: add 3 new charts to presentation (target distribution, MI features, ROC)
</commit_message>
<xml_diff>
--- a/presentation/presentasi_uas_ml.pptx
+++ b/presentation/presentasi_uas_ml.pptx
@@ -3143,7 +3143,10 @@
               <a:spcBef>
                 <a:spcPts val="1000"/>
               </a:spcBef>
-              <a:defRPr sz="2200">
+              <a:spcAft>
+                <a:spcPts val="0"/>
+              </a:spcAft>
+              <a:defRPr sz="2200" b="0">
                 <a:solidFill>
                   <a:srgbClr val="CADCFC"/>
                 </a:solidFill>
@@ -3178,9 +3181,6 @@
           <a:lstStyle/>
           <a:p>
             <a:pPr>
-              <a:spcBef>
-                <a:spcPts val="500"/>
-              </a:spcBef>
               <a:defRPr sz="1600">
                 <a:solidFill>
                   <a:srgbClr val="CADCFC"/>
@@ -3188,7 +3188,7 @@
               </a:defRPr>
             </a:pPr>
             <a:r>
-              <a:t>Oleh: Na'ilah Azfa Zarqarida (NIM: A11.2024.15549)</a:t>
+              <a:t>Na'ilah Azfa Zarqarida (NIM: A11.2024.15549)</a:t>
             </a:r>
             <a:br/>
             <a:r>
@@ -3272,7 +3272,7 @@
               </a:defRPr>
             </a:pPr>
             <a:r>
-              <a:t>Repositori proyek memuat seluruh basis kode instruksional, dataset, serta laporan akhir akademis:</a:t>
+              <a:t>Repositori lengkap (kode, dataset, laporan, dan aplikasi):</a:t>
             </a:r>
           </a:p>
           <a:p>
@@ -3363,7 +3363,7 @@
               </a:defRPr>
             </a:pPr>
             <a:r>
-              <a:t>Latar Belakang &amp; Urgensi Penelitian</a:t>
+              <a:t>Latar Belakang dan Urgensi Penelitian</a:t>
             </a:r>
           </a:p>
         </p:txBody>
@@ -3405,7 +3405,7 @@
               </a:defRPr>
             </a:pPr>
             <a:r>
-              <a:t>Krisis Angka Putus Kuliah (Dropout) di Perguruan Tinggi</a:t>
+              <a:t>Krisis Angka Putus Kuliah di Perguruan Tinggi</a:t>
             </a:r>
           </a:p>
           <a:p>
@@ -3423,7 +3423,7 @@
               </a:defRPr>
             </a:pPr>
             <a:r>
-              <a:t>Berdasarkan analisis awal pada dataset akademik, tercatat tingkat putus kuliah mencapai 39% dari total 4.424 mahasiswa. Tingginya angka ini secara langsung merusak Indikator Kinerja Utama (IKU) institusi pendidikan, menyebabkan inefisiensi alokasi anggaran, dan memberikan dampak sosio-ekonomi negatif pada masa depan mahasiswa.</a:t>
+              <a:t>Analisis data empiris menunjukkan tingkat putus kuliah mencapai 39% dari total 4.424 mahasiswa pada dataset UCI. Angka ini secara langsung merusak Indikator Kinerja Utama (IKU) institusi, menyebabkan inefisiensi alokasi anggaran, serta memberikan dampak sosio-ekonomi negatif pada masa depan mahasiswa. Masalah dropout menjadi indikator krusial bagi institusi untuk melakukan intervensi dini.</a:t>
             </a:r>
           </a:p>
           <a:p>
@@ -3459,7 +3459,7 @@
               </a:defRPr>
             </a:pPr>
             <a:r>
-              <a:t>Penelitian ini difokuskan untuk membangun sebuah model klasifikasi cerdas berbasis Machine Learning. Tujuannya adalah mendeteksi secara proaktif mahasiswa yang memiliki probabilitas tinggi untuk dropout sejak semester-semester awal, sehingga pihak akademik dapat melakukan intervensi pencegahan.</a:t>
+              <a:t>Penelitian ini difokuskan untuk membangun model klasifikasi berbasis Machine Learning yang mampu mendeteksi secara proaktif mahasiswa dengan probabilitas tinggi untuk dropout sejak semester awal, sehingga pihak akademik dapat melakukan intervensi pencegahan secara tepat sasaran.</a:t>
             </a:r>
           </a:p>
           <a:p>
@@ -3477,7 +3477,7 @@
               </a:defRPr>
             </a:pPr>
             <a:r>
-              <a:t>Keselarasan dengan Outcome-Based Education (OBE)</a:t>
+              <a:t>Keselarasan dengan Outcome-Based Education</a:t>
             </a:r>
           </a:p>
           <a:p>
@@ -3495,7 +3495,7 @@
               </a:defRPr>
             </a:pPr>
             <a:r>
-              <a:t>Proyek ini disusun untuk mendemonstrasikan pencapaian CPL-8 (Kemampuan analitik dan pemodelan Machine Learning tingkat lanjut) serta CPL-10 (Tanggung jawab etis dalam perancangan dan implementasi kecerdasan buatan).</a:t>
+              <a:t>Proyek ini disusun untuk mendemonstrasikan pencapaian CPL-8 (kemampuan analitik dan pemodelan Machine Learning) serta CPL-10 (tanggung jawab etis dalam perancangan dan implementasi kecerdasan buatan) pada program studi informatika.</a:t>
             </a:r>
           </a:p>
         </p:txBody>
@@ -3570,7 +3570,7 @@
         <p:spPr>
           <a:xfrm>
             <a:off x="731520" y="1280160"/>
-            <a:ext cx="10698480" cy="5029200"/>
+            <a:ext cx="5669280" cy="5029200"/>
           </a:xfrm>
           <a:prstGeom prst="rect">
             <a:avLst/>
@@ -3616,7 +3616,7 @@
               </a:defRPr>
             </a:pPr>
             <a:r>
-              <a:t>Dataset bersumber dari UCI Machine Learning Repository ('Predict Students Dropout and Academic Success'). Observasi dengan status 'Enrolled' disaring keluar untuk memformulasikan masalah ini sebagai klasifikasi biner, menghasilkan 3.630 baris data valid (Graduate vs Dropout).</a:t>
+              <a:t>Dataset bersumber dari UCI Machine Learning Repository. Observasi dengan status 'Enrolled' disaring keluar untuk memformulasikan masalah sebagai klasifikasi biner, menghasilkan 3.630 baris data valid: Graduate (61.1%) vs Dropout (38.9%).</a:t>
             </a:r>
           </a:p>
           <a:p>
@@ -3634,7 +3634,7 @@
               </a:defRPr>
             </a:pPr>
             <a:r>
-              <a:t>Seleksi Fitur Terarah (Mutual Information)</a:t>
+              <a:t>Seleksi Fitur dengan Mutual Information</a:t>
             </a:r>
           </a:p>
           <a:p>
@@ -3652,7 +3652,7 @@
               </a:defRPr>
             </a:pPr>
             <a:r>
-              <a:t>Untuk menghindari curse of dimensionality, kami mengekstraksi 10 fitur paling prediktif menggunakan pengukuran Mutual Information. Fitur terpilih meliputi riwayat akademik semester 1 dan 2, status pembayaran UKT, serta riwayat beasiswa.</a:t>
+              <a:t>Fitur dipilih menggunakan skor Mutual Information untuk menyaring 10 variabel paling prediktif, termasuk indeks prestasi, riwayat SKS, status pembayaran UKT, dan penerimaan beasiswa. 10 fitur ini terbukti memberikan kontribusi informasi tertinggi terhadap variabel target.</a:t>
             </a:r>
           </a:p>
           <a:p>
@@ -3688,7 +3688,7 @@
               </a:defRPr>
             </a:pPr>
             <a:r>
-              <a:t>Data dibagi menjadi set pelatihan (80%) dan pengujian (20%) secara stratified untuk menjaga proporsi kelas. Seluruh fitur numerik kemudian distandardisasi menggunakan StandardScaler agar model berbasis jarak (KNN, SVM) tidak mengalami bias dimensi.</a:t>
+              <a:t>Data dibagi 80:20 secara stratified. Fitur numerik distandardisasi menggunakan StandardScaler agar algoritma berbasis jarak (KNN, SVM) tidak mengalami bias dimensi.</a:t>
             </a:r>
           </a:p>
           <a:p>
@@ -3724,11 +3724,59 @@
               </a:defRPr>
             </a:pPr>
             <a:r>
-              <a:t>Synthetic Minority Over-sampling Technique (SMOTE) diterapkan secara eksklusif pada data latih untuk menyeimbangkan kelas minoritas tanpa menimbulkan fenomena data leakage pada tahap pengujian.</a:t>
-            </a:r>
-          </a:p>
-        </p:txBody>
-      </p:sp>
+              <a:t>SMOTE diterapkan eksklusif pada data latih untuk menyeimbangkan kelas minoritas secara sintetis, menjaga integritas evaluasi pada data test.</a:t>
+            </a:r>
+          </a:p>
+        </p:txBody>
+      </p:sp>
+      <p:pic>
+        <p:nvPicPr>
+          <p:cNvPr id="4" name="Picture 3" descr="target_distribution.png"/>
+          <p:cNvPicPr>
+            <a:picLocks noChangeAspect="1"/>
+          </p:cNvPicPr>
+          <p:nvPr/>
+        </p:nvPicPr>
+        <p:blipFill>
+          <a:blip r:embed="rId2"/>
+          <a:stretch>
+            <a:fillRect/>
+          </a:stretch>
+        </p:blipFill>
+        <p:spPr>
+          <a:xfrm>
+            <a:off x="6858000" y="1097280"/>
+            <a:ext cx="4754880" cy="2358163"/>
+          </a:xfrm>
+          <a:prstGeom prst="rect">
+            <a:avLst/>
+          </a:prstGeom>
+        </p:spPr>
+      </p:pic>
+      <p:pic>
+        <p:nvPicPr>
+          <p:cNvPr id="5" name="Picture 4" descr="feature_importance_mi.png"/>
+          <p:cNvPicPr>
+            <a:picLocks noChangeAspect="1"/>
+          </p:cNvPicPr>
+          <p:nvPr/>
+        </p:nvPicPr>
+        <p:blipFill>
+          <a:blip r:embed="rId3"/>
+          <a:stretch>
+            <a:fillRect/>
+          </a:stretch>
+        </p:blipFill>
+        <p:spPr>
+          <a:xfrm>
+            <a:off x="6858000" y="3840480"/>
+            <a:ext cx="4754880" cy="2650986"/>
+          </a:xfrm>
+          <a:prstGeom prst="rect">
+            <a:avLst/>
+          </a:prstGeom>
+        </p:spPr>
+      </p:pic>
     </p:spTree>
   </p:cSld>
   <p:clrMapOvr>
@@ -3827,7 +3875,7 @@
               </a:defRPr>
             </a:pPr>
             <a:r>
-              <a:t>Algoritma Klasifikasi Baseline</a:t>
+              <a:t>Algoritma Klasifikasi yang Diuji</a:t>
             </a:r>
           </a:p>
           <a:p>
@@ -3845,7 +3893,7 @@
               </a:defRPr>
             </a:pPr>
             <a:r>
-              <a:t>Penelitian ini membandingkan kinerja dari tiga algoritma fundamental: K-Nearest Neighbors (KNN), Naive Bayes (GaussianNB), dan Support Vector Machine (SVM). Setiap model dikonfigurasi dengan parameter awal standar untuk mendapatkan garis ukur performa.</a:t>
+              <a:t>Penelitian ini membandingkan tiga algoritma fundamental: K-Nearest Neighbors (KNN), Naive Bayes (GaussianNB), dan Support Vector Machine (SVM). Setiap model dikonfigurasi dengan parameter awal standar sebagai garis ukur baseline.</a:t>
             </a:r>
           </a:p>
           <a:p>
@@ -3863,7 +3911,7 @@
               </a:defRPr>
             </a:pPr>
             <a:r>
-              <a:t>Implementasi Empat Strategi Optimasi Utama</a:t>
+              <a:t>Empat Strategi Optimasi yang Diterapkan</a:t>
             </a:r>
           </a:p>
           <a:p>
@@ -3881,19 +3929,19 @@
               </a:defRPr>
             </a:pPr>
             <a:r>
-              <a:t>1. Penyetelan Hyperparameter (Hyperparameter Tuning): Menggunakan GridSearchCV untuk menguji berbagai kombinasi parameter secara ekstensif.</a:t>
+              <a:t>1. Penyetelan Hyperparameter: GridSearchCV menguji kombinasi parameter secara ekstensif untuk setiap model.</a:t>
             </a:r>
             <a:br/>
             <a:r>
-              <a:t>2. Validasi Silang (Cross-Validation): Menerapkan 5-Fold Stratified CV guna mencegah overfitting dan memastikan keandalan metrik.</a:t>
+              <a:t>2. Validasi Silang: 5-Fold Stratified Cross Validation mencegah overfitting dan memastikan keandalan metrik.</a:t>
             </a:r>
             <a:br/>
             <a:r>
-              <a:t>3. Seleksi Fitur Kuantitatif: Mereduksi dimensi data berbasis signifikansi statistik.</a:t>
+              <a:t>3. Seleksi Fitur: Reduksi dimensi berbasis signifikansi statistik Mutual Information.</a:t>
             </a:r>
             <a:br/>
             <a:r>
-              <a:t>4. Balancing Dataset: Modifikasi distribusi data kelas minoritas secara sintetis.</a:t>
+              <a:t>4. Balancing Dataset: SMOTE oversampling untuk menyeimbangkan proporsi kelas.</a:t>
             </a:r>
           </a:p>
           <a:p>
@@ -3911,7 +3959,7 @@
               </a:defRPr>
             </a:pPr>
             <a:r>
-              <a:t>Pemilihan Metrik Evaluasi Kritis</a:t>
+              <a:t>Pemilihan Metrik Evaluasi</a:t>
             </a:r>
           </a:p>
           <a:p>
@@ -3929,7 +3977,7 @@
               </a:defRPr>
             </a:pPr>
             <a:r>
-              <a:t>Mengingat distribusi data yang tidak seimbang, penilaian model ditekankan pada metrik F1-Macro dan Balanced Accuracy, alih-alih Akurasi konvensional, untuk memastikan evaluasi yang adil terhadap sensitivitas pendeteksian mahasiswa putus kuliah.</a:t>
+              <a:t>Mengingat distribusi data tidak seimbang, metrik evaluasi prioritas adalah F1-Macro dan Balanced Accuracy. Kedua metrik ini menilai keadilan model terhadap kedua kelas target secara setara, sehingga tidak bias terhadap kelas mayoritas.</a:t>
             </a:r>
           </a:p>
         </p:txBody>
@@ -4005,7 +4053,7 @@
         </p:nvGraphicFramePr>
         <p:xfrm>
           <a:off x="731520" y="1371600"/>
-          <a:ext cx="5303520" cy="3474720"/>
+          <a:ext cx="5303520" cy="3200400"/>
         </p:xfrm>
         <a:graphic>
           <a:graphicData uri="http://schemas.openxmlformats.org/drawingml/2006/table">
@@ -4018,7 +4066,7 @@
                 <a:gridCol w="1188720"/>
                 <a:gridCol w="1188720"/>
               </a:tblGrid>
-              <a:tr h="496388">
+              <a:tr h="457200">
                 <a:tc>
                   <a:txBody>
                     <a:bodyPr/>
@@ -4089,7 +4137,7 @@
                   </a:tcPr>
                 </a:tc>
               </a:tr>
-              <a:tr h="496388">
+              <a:tr h="457200">
                 <a:tc>
                   <a:txBody>
                     <a:bodyPr/>
@@ -4099,7 +4147,7 @@
                         <a:defRPr sz="1200"/>
                       </a:pPr>
                       <a:r>
-                        <a:t>K-Nearest Neighbors (Baseline)</a:t>
+                        <a:t>KNN Baseline</a:t>
                       </a:r>
                     </a:p>
                   </a:txBody>
@@ -4136,7 +4184,7 @@
                   <a:tcPr/>
                 </a:tc>
               </a:tr>
-              <a:tr h="496388">
+              <a:tr h="457200">
                 <a:tc>
                   <a:txBody>
                     <a:bodyPr/>
@@ -4146,7 +4194,7 @@
                         <a:defRPr sz="1200"/>
                       </a:pPr>
                       <a:r>
-                        <a:t>Naive Bayes (Baseline)</a:t>
+                        <a:t>Naive Bayes Baseline</a:t>
                       </a:r>
                     </a:p>
                   </a:txBody>
@@ -4195,7 +4243,7 @@
                   </a:tcPr>
                 </a:tc>
               </a:tr>
-              <a:tr h="496388">
+              <a:tr h="457200">
                 <a:tc>
                   <a:txBody>
                     <a:bodyPr/>
@@ -4205,7 +4253,7 @@
                         <a:defRPr sz="1200" b="1"/>
                       </a:pPr>
                       <a:r>
-                        <a:t>Support Vector Machine (Baseline)</a:t>
+                        <a:t>SVM Baseline</a:t>
                       </a:r>
                     </a:p>
                   </a:txBody>
@@ -4254,7 +4302,7 @@
                   </a:tcPr>
                 </a:tc>
               </a:tr>
-              <a:tr h="496388">
+              <a:tr h="457200">
                 <a:tc>
                   <a:txBody>
                     <a:bodyPr/>
@@ -4264,7 +4312,7 @@
                         <a:defRPr sz="1200"/>
                       </a:pPr>
                       <a:r>
-                        <a:t>K-Nearest Neighbors (Optimized)</a:t>
+                        <a:t>KNN Optimized</a:t>
                       </a:r>
                     </a:p>
                   </a:txBody>
@@ -4313,7 +4361,7 @@
                   </a:tcPr>
                 </a:tc>
               </a:tr>
-              <a:tr h="496388">
+              <a:tr h="457200">
                 <a:tc>
                   <a:txBody>
                     <a:bodyPr/>
@@ -4323,7 +4371,7 @@
                         <a:defRPr sz="1200"/>
                       </a:pPr>
                       <a:r>
-                        <a:t>Naive Bayes (Optimized)</a:t>
+                        <a:t>Naive Bayes Optimized</a:t>
                       </a:r>
                     </a:p>
                   </a:txBody>
@@ -4360,7 +4408,7 @@
                   <a:tcPr/>
                 </a:tc>
               </a:tr>
-              <a:tr h="496392">
+              <a:tr h="457200">
                 <a:tc>
                   <a:txBody>
                     <a:bodyPr/>
@@ -4370,7 +4418,7 @@
                         <a:defRPr sz="1200"/>
                       </a:pPr>
                       <a:r>
-                        <a:t>Support Vector Machine (Optimized)</a:t>
+                        <a:t>SVM Optimized</a:t>
                       </a:r>
                     </a:p>
                   </a:txBody>
@@ -4439,7 +4487,7 @@
         </p:blipFill>
         <p:spPr>
           <a:xfrm>
-            <a:off x="6400800" y="1371600"/>
+            <a:off x="6400800" y="1188720"/>
             <a:ext cx="5029200" cy="2828925"/>
           </a:xfrm>
           <a:prstGeom prst="rect">
@@ -4447,16 +4495,40 @@
           </a:prstGeom>
         </p:spPr>
       </p:pic>
-      <p:sp>
-        <p:nvSpPr>
-          <p:cNvPr id="5" name="TextBox 4"/>
+      <p:pic>
+        <p:nvPicPr>
+          <p:cNvPr id="5" name="Picture 4" descr="roc_curve_comparison.png"/>
+          <p:cNvPicPr>
+            <a:picLocks noChangeAspect="1"/>
+          </p:cNvPicPr>
+          <p:nvPr/>
+        </p:nvPicPr>
+        <p:blipFill>
+          <a:blip r:embed="rId3"/>
+          <a:stretch>
+            <a:fillRect/>
+          </a:stretch>
+        </p:blipFill>
+        <p:spPr>
+          <a:xfrm>
+            <a:off x="6400800" y="3840480"/>
+            <a:ext cx="5029200" cy="4294762"/>
+          </a:xfrm>
+          <a:prstGeom prst="rect">
+            <a:avLst/>
+          </a:prstGeom>
+        </p:spPr>
+      </p:pic>
+      <p:sp>
+        <p:nvSpPr>
+          <p:cNvPr id="6" name="TextBox 5"/>
           <p:cNvSpPr txBox="1"/>
           <p:nvPr/>
         </p:nvSpPr>
         <p:spPr>
           <a:xfrm>
-            <a:off x="731520" y="5120640"/>
-            <a:ext cx="10698480" cy="1097280"/>
+            <a:off x="731520" y="4937760"/>
+            <a:ext cx="5486400" cy="1371600"/>
           </a:xfrm>
           <a:prstGeom prst="rect">
             <a:avLst/>
@@ -4477,14 +4549,14 @@
               <a:spcAft>
                 <a:spcPts val="200"/>
               </a:spcAft>
-              <a:defRPr sz="1400" b="1">
+              <a:defRPr sz="1300" b="1">
                 <a:solidFill>
                   <a:srgbClr val="2C3E50"/>
                 </a:solidFill>
               </a:defRPr>
             </a:pPr>
             <a:r>
-              <a:t>Model Terbaik: Support Vector Machine (Baseline)</a:t>
+              <a:t>Model Terbaik: SVM Baseline (F1=0.887, AUC=0.94)</a:t>
             </a:r>
           </a:p>
           <a:p>
@@ -4495,14 +4567,14 @@
               <a:spcAft>
                 <a:spcPts val="0"/>
               </a:spcAft>
-              <a:defRPr sz="1200" b="0">
+              <a:defRPr sz="1100" b="0">
                 <a:solidFill>
                   <a:srgbClr val="555555"/>
                 </a:solidFill>
               </a:defRPr>
             </a:pPr>
             <a:r>
-              <a:t>Model SVM Baseline yang dikonfigurasi dengan kernel RBF dan parameter penyeimbang bobot kelas internal terbukti menghasilkan metrik evaluasi tertinggi. Eksperimen optimasi sekunder (SMOTE dan pengurangan jumlah fitur) pada SVM menyebabkan sedikit penurunan performa analitik karena terjadinya kehilangan beberapa informasi residual.</a:t>
+              <a:t>Kernel RBF dan class_weight=balanced menghasilkan F1-Macro tertinggi. SVM Optimized (0.884) mengalami sedikit degradasi karena pengurangan fitur dari 10 menjadi 8.</a:t>
             </a:r>
           </a:p>
         </p:txBody>
@@ -4577,7 +4649,7 @@
         <p:spPr>
           <a:xfrm>
             <a:off x="731520" y="1371600"/>
-            <a:ext cx="5486400" cy="4572000"/>
+            <a:ext cx="5486400" cy="5029200"/>
           </a:xfrm>
           <a:prstGeom prst="rect">
             <a:avLst/>
@@ -4605,7 +4677,7 @@
               </a:defRPr>
             </a:pPr>
             <a:r>
-              <a:t>Distribusi Kesalahan Prediksi Klasifikasi</a:t>
+              <a:t>Distribusi Kesalahan Prediksi</a:t>
             </a:r>
           </a:p>
           <a:p>
@@ -4623,23 +4695,23 @@
               </a:defRPr>
             </a:pPr>
             <a:r>
-              <a:t>Berdasarkan matriks kebingungan (Confusion Matrix) di samping, SVM menghasilkan:</a:t>
+              <a:t>Berdasarkan Confusion Matrix SVM Baseline:</a:t>
             </a:r>
             <a:br/>
             <a:r>
-              <a:t>- True Positive: 415 observasi</a:t>
+              <a:t>- True Positive (Graduate benar): 415</a:t>
             </a:r>
             <a:br/>
             <a:r>
-              <a:t>- True Negative: 234 observasi</a:t>
+              <a:t>- True Negative (Dropout benar): 234</a:t>
             </a:r>
             <a:br/>
             <a:r>
-              <a:t>- False Positive (Salah klasifikasi sebagai Lulus): 50 observasi</a:t>
+              <a:t>- False Positive (Dropout salah prediksi Graduate): 50</a:t>
             </a:r>
             <a:br/>
             <a:r>
-              <a:t>- False Negative (Salah klasifikasi sebagai Dropout): 27 observasi</a:t>
+              <a:t>- False Negative (Graduate salah prediksi Dropout): 27</a:t>
             </a:r>
           </a:p>
           <a:p>
@@ -4657,7 +4729,7 @@
               </a:defRPr>
             </a:pPr>
             <a:r>
-              <a:t>Identifikasi Pola Kesalahan</a:t>
+              <a:t>Pola Kesalahan yang Teridentifikasi</a:t>
             </a:r>
           </a:p>
           <a:p>
@@ -4675,7 +4747,7 @@
               </a:defRPr>
             </a:pPr>
             <a:r>
-              <a:t>Penyelidikan lebih mendalam terhadap 50 kasus False Positive menunjukkan suatu pola konsisten: mahasiswa yang teridentifikasi memiliki skor akademis (SKS dan IPK) yang memuaskan di tahun pertama, namun pada kenyataannya tetap mengalami status putus kuliah.</a:t>
+              <a:t>Penyelidikan terhadap 50 kasus False Positive menunjukkan pola konsisten: mahasiswa dengan nilai akademis memuaskan di semester 1-2 namun tetap mengalami dropout. Model gagal mendeteksi karena penurunan performa terjadi pada semester selanjutnya.</a:t>
             </a:r>
           </a:p>
           <a:p>
@@ -4693,7 +4765,7 @@
               </a:defRPr>
             </a:pPr>
             <a:r>
-              <a:t>Kesimpulan Keterbatasan Data Tabular</a:t>
+              <a:t>Keterbatasan Fundamental Model</a:t>
             </a:r>
           </a:p>
           <a:p>
@@ -4711,7 +4783,7 @@
               </a:defRPr>
             </a:pPr>
             <a:r>
-              <a:t>Model secara fundamental terbatas oleh cakupan variabel yang diukur. Dropout pada mahasiswa berprestasi seringkali dipicu oleh anomali non-akademik, seperti kesulitan perekonomian keluarga atau persoalan medis, yang sama sekali tidak direpresentasikan dalam struktur dataset ini.</a:t>
+              <a:t>Dropout pada mahasiswa berprestasi sering dipicu oleh faktor non-akademik (ekonomi, kesehatan, keluarga) yang tidak terekam dalam dataset tabular akademis. Ini membuktikan bahwa model memerlukan suplementasi data non-akademik untuk peningkatan performa.</a:t>
             </a:r>
           </a:p>
         </p:txBody>
@@ -4838,7 +4910,7 @@
               </a:defRPr>
             </a:pPr>
             <a:r>
-              <a:t>Trade-off Performa Pemodelan dan Interpretabilitas</a:t>
+              <a:t>Trade-off Performa dan Interpretabilitas</a:t>
             </a:r>
           </a:p>
           <a:p>
@@ -4856,7 +4928,7 @@
               </a:defRPr>
             </a:pPr>
             <a:r>
-              <a:t>Evaluasi model menyoroti keseimbangan klasik dalam Machine Learning: algoritma kompleks seperti SVM RBF menghasilkan presisi dan F1-Macro tertinggi (0.887), namun beroperasi dengan sifat black-box. Sebaliknya, metode probabilistik Naive Bayes sangat transparan untuk dijelaskan fungsinya secara statistik, tetapi gagal mencapai recall yang memadai pada kelas mayoritas.</a:t>
+              <a:t>Evaluasi menyoroti keseimbangan dalam machine learning: SVM RBF menghasilkan presisi tertinggi (F1-Macro 0.887) namun bersifat black-box. Naive Bayes transparan secara statistik namun recall dropout rendah. KNN intuitif tetapi sensitif terhadap noise dan penentuan parameter K.</a:t>
             </a:r>
           </a:p>
           <a:p>
@@ -4874,7 +4946,7 @@
               </a:defRPr>
             </a:pPr>
             <a:r>
-              <a:t>Signifikansi dan Implikasi Kebijakan Institusi</a:t>
+              <a:t>Implikasi Strategis bagi Institusi</a:t>
             </a:r>
           </a:p>
           <a:p>
@@ -4892,7 +4964,7 @@
               </a:defRPr>
             </a:pPr>
             <a:r>
-              <a:t>Sistem klasifikasi ini memiliki potensi strategis sebagai komponen inti dari Early Warning System di universitas. Mahasiswa yang diproyeksikan memiliki risiko tinggi dapat segera dialokasikan pada program intervensi preventif, seperti konseling akademik intensif atau penyediaan opsi bantuan finansial berkelanjutan.</a:t>
+              <a:t>Model ini layak menjadi komponen inti Early Warning System. Mahasiswa terancam dapat segera dialokasikan ke program intervensi preventif: konseling akademik intensif, bantuan finansial, atau program mentoring. Pendekatan proaktif ini terbukti menurunkan angka dropout secara signifikan di universitas yang sudah menerapkannya.</a:t>
             </a:r>
           </a:p>
           <a:p>
@@ -4910,7 +4982,7 @@
               </a:defRPr>
             </a:pPr>
             <a:r>
-              <a:t>Batasan Etis Implementasi Kecerdasan Buatan</a:t>
+              <a:t>Batasan Etis Implementasi</a:t>
             </a:r>
           </a:p>
           <a:p>
@@ -4928,7 +5000,7 @@
               </a:defRPr>
             </a:pPr>
             <a:r>
-              <a:t>Model prediktif ini dikonstruksi secara eksklusif sebagai Decision Support System (sistem penunjang keputusan). Kebijakan akademik yang memengaruhi nasib mahasiswa dilarang dieksekusi secara otomatis oleh algoritma, dan validasi otoritas tenaga pendidik (Dosen Wali) tetap bersifat mutlak.</a:t>
+              <a:t>Model ini dikonstruksi secara eksklusif sebagai Decision Support System. Kebijakan akademik yang memengaruhi nasib mahasiswa dilarang dieksekusi otomatis oleh algoritma. Validasi otoritas tenaga pendidik tetap bersifat mutlak dalam setiap tahapan pengambilan keputusan.</a:t>
             </a:r>
           </a:p>
         </p:txBody>
@@ -5031,7 +5103,7 @@
               </a:defRPr>
             </a:pPr>
             <a:r>
-              <a:t>Arsitektur Antarmuka Streamlit (Main Frontend)</a:t>
+              <a:t>Arsitektur Frontend Streamlit</a:t>
             </a:r>
           </a:p>
           <a:p>
@@ -5049,7 +5121,7 @@
               </a:defRPr>
             </a:pPr>
             <a:r>
-              <a:t>Sebuah web dashboard komprehensif dikembangkan mencakup empat struktur panel: (1) Mesin Prediksi Interaktif dengan penunjuk nilai kepercayaan model, (2) Panel Visualisasi Eksploratori Dataset, (3) Laporan Integritas Metrik Evaluasi, dan (4) Dokumentasi Edukasi Model secara naratif.</a:t>
+              <a:t>Dashboard web dikembangkan dengan empat struktur panel: (1) Mesin Prediksi Interaktif dengan 10 input sidebar dan output confidence score, (2) Panel Visualisasi Eksploratori Dataset, (3) Laporan Integritas Metrik Evaluasi dengan grafik perbandingan, dan (4) Dokumentasi Edukasi Model secara naratif.</a:t>
             </a:r>
           </a:p>
           <a:p>
@@ -5067,7 +5139,7 @@
               </a:defRPr>
             </a:pPr>
             <a:r>
-              <a:t>Desain Restful API (FastAPI Backend)</a:t>
+              <a:t>Backend Restful API (FastAPI)</a:t>
             </a:r>
           </a:p>
           <a:p>
@@ -5085,7 +5157,7 @@
               </a:defRPr>
             </a:pPr>
             <a:r>
-              <a:t>Infrastruktur inferensi dienkapsulasi menggunakan protokol FastAPI, menghasilkan endpoint berbasis JSON yang terstandardisasi dan mendukung dokumentasi Swagger UI. Arsitektur ini memungkinkan injeksi langsung ke dalam Sistem Informasi Akademik (SIAKAD) berskala produksi.</a:t>
+              <a:t>Infrastruktur inferensi dienkapsulasi menggunakan FastAPI, menghasilkan endpoint /predict berbasis JSON yang terstandardisasi dengan dokumentasi Swagger UI. Arsitektur ini memungkinkan integrasi langsung dengan Sistem Informasi Akademik (SIAKAD) berskala produksi.</a:t>
             </a:r>
           </a:p>
           <a:p>
@@ -5103,7 +5175,7 @@
               </a:defRPr>
             </a:pPr>
             <a:r>
-              <a:t>Integrasi Kepatuhan Etika</a:t>
+              <a:t>Antarmuka Alternatif dan Kepatuhan Etika</a:t>
             </a:r>
           </a:p>
           <a:p>
@@ -5121,7 +5193,7 @@
               </a:defRPr>
             </a:pPr>
             <a:r>
-              <a:t>Seluruh antarmuka secara eksplisit mencantumkan penafian (disclaimer) etis dan instruksi pemahaman probabilitas. Hal ini mengedukasi pengguna akhir bahwa setiap output mesin hanyalah alat bantu administratif, bukan vonis akademis pasti.</a:t>
+              <a:t>Gradio disediakan sebagai antarmuka minimalis untuk pengujian cepat. Seluruh interface mencantumkan disclaimer etika dan edukasi probabilitas untuk memastikan pengguna memahami bahwa output hanyalah alat bantu, bukan vonis akademis pasti.</a:t>
             </a:r>
           </a:p>
         </p:txBody>
@@ -5224,7 +5296,7 @@
               </a:defRPr>
             </a:pPr>
             <a:r>
-              <a:t>Kesimpulan Efektivitas Model</a:t>
+              <a:t>Efektivitas Model SVM Baseline</a:t>
             </a:r>
           </a:p>
           <a:p>
@@ -5242,7 +5314,7 @@
               </a:defRPr>
             </a:pPr>
             <a:r>
-              <a:t>Pendekatan berbasis Support Vector Machine secara konsisten mempertahankan superioritas metrik dengan F1-Macro sebesar 0.8869 dan akurasi umum 89,39%. Reduksi set parameter ke dalam 10 fitur utama terbukti mumpuni untuk membentuk batas keputusan yang tangguh tanpa mencederai komputasi waktu inferensi.</a:t>
+              <a:t>Model SVM Baseline dengan kernel RBF mempertahankan superioritas metrik: F1-Macro 0.8869, Akurasi 89.39%, dan AUC 0.94. Reduksi fitur ke 10 variabel utama terbukti mumpuni membentuk batas keputusan yang tangguh tanpa mengorbankan waktu inferensi.</a:t>
             </a:r>
           </a:p>
           <a:p>
@@ -5260,7 +5332,7 @@
               </a:defRPr>
             </a:pPr>
             <a:r>
-              <a:t>Identifikasi Keterbatasan Domain</a:t>
+              <a:t>Keterbatasan Generalisasi</a:t>
             </a:r>
           </a:p>
           <a:p>
@@ -5278,7 +5350,7 @@
               </a:defRPr>
             </a:pPr>
             <a:r>
-              <a:t>Validitas algoritma saat ini dibatasi oleh demografi asal (data historis mahasiswa Portugal). Generalisasi performa terhadap data mahasiswa di lanskap pendidikan Indonesia mengharuskan proses kalibrasi ulang atau penerapan metode transfer learning.</a:t>
+              <a:t>Validitas model saat ini dibatasi oleh demografi asal data (Portugal). Generalisasi terhadap mahasiswa Indonesia mengharuskan proses kalibrasi ulang, validasi silang lintas budaya, atau penerapan transfer learning domain-adapted.</a:t>
             </a:r>
           </a:p>
           <a:p>
@@ -5296,7 +5368,7 @@
               </a:defRPr>
             </a:pPr>
             <a:r>
-              <a:t>Saran Pengembangan Penelitian Berkala</a:t>
+              <a:t>Rekomendasi Pengembangan</a:t>
             </a:r>
           </a:p>
           <a:p>
@@ -5314,7 +5386,19 @@
               </a:defRPr>
             </a:pPr>
             <a:r>
-              <a:t>Direkomendasikan agar studi masa depan merangkul teknologi Ensemble Stacking multivariat, mengintegrasikan framework Explainable AI (khususnya nilai Shapley/SHAP) guna menghapus sifat black-box model, serta mengemas keseluruhan lingkungan deployment ke dalam arsitektur terisolasi berbasis Docker.</a:t>
+              <a:t>1. Integrasikan dataset lokal universitas untuk pelatihan model.</a:t>
+            </a:r>
+            <a:br/>
+            <a:r>
+              <a:t>2. Eksplorasi metode Ensemble Stacking (kombinasi SVM, KNN, Random Forest).</a:t>
+            </a:r>
+            <a:br/>
+            <a:r>
+              <a:t>3. Implementasi framework Explainable AI (SHAP/LIME) untuk transparansi.</a:t>
+            </a:r>
+            <a:br/>
+            <a:r>
+              <a:t>4. Deployment production menggunakan Docker untuk portabilitas.</a:t>
             </a:r>
           </a:p>
         </p:txBody>

</xml_diff>

<commit_message>
cleanup: remove temporary files and .venv
</commit_message>
<xml_diff>
--- a/presentation/presentasi_uas_ml.pptx
+++ b/presentation/presentasi_uas_ml.pptx
@@ -5,18 +5,18 @@
     <p:sldMasterId id="2147483648" r:id="rId1"/>
   </p:sldMasterIdLst>
   <p:sldIdLst>
-    <p:sldId id="256" r:id="rId7"/>
-    <p:sldId id="257" r:id="rId8"/>
-    <p:sldId id="258" r:id="rId9"/>
-    <p:sldId id="259" r:id="rId10"/>
-    <p:sldId id="260" r:id="rId11"/>
-    <p:sldId id="261" r:id="rId12"/>
-    <p:sldId id="262" r:id="rId13"/>
-    <p:sldId id="263" r:id="rId14"/>
-    <p:sldId id="264" r:id="rId15"/>
-    <p:sldId id="265" r:id="rId16"/>
+    <p:sldId id="256" r:id="rId2"/>
+    <p:sldId id="257" r:id="rId3"/>
+    <p:sldId id="258" r:id="rId4"/>
+    <p:sldId id="259" r:id="rId5"/>
+    <p:sldId id="260" r:id="rId6"/>
+    <p:sldId id="261" r:id="rId7"/>
+    <p:sldId id="262" r:id="rId8"/>
+    <p:sldId id="263" r:id="rId9"/>
+    <p:sldId id="264" r:id="rId10"/>
+    <p:sldId id="265" r:id="rId11"/>
   </p:sldIdLst>
-  <p:sldSz cx="12191695" cy="6858000" type="screen4x3"/>
+  <p:sldSz cx="12192000" cy="6858000"/>
   <p:notesSz cx="6858000" cy="9144000"/>
   <p:defaultTextStyle>
     <a:defPPr>
@@ -113,6 +113,22 @@
       </a:defRPr>
     </a:lvl9pPr>
   </p:defaultTextStyle>
+  <p:extLst>
+    <p:ext uri="{EFAFB233-063F-42B5-8137-9DF3F51BA10A}">
+      <p15:sldGuideLst xmlns:p15="http://schemas.microsoft.com/office/powerpoint/2012/main">
+        <p15:guide id="1" orient="horz" pos="2160">
+          <p15:clr>
+            <a:srgbClr val="A4A3A4"/>
+          </p15:clr>
+        </p15:guide>
+        <p15:guide id="2" pos="2880">
+          <p15:clr>
+            <a:srgbClr val="A4A3A4"/>
+          </p15:clr>
+        </p15:guide>
+      </p15:sldGuideLst>
+    </p:ext>
+  </p:extLst>
 </p:presentation>
 </file>
 
@@ -154,10 +170,9 @@
           <a:lstStyle/>
           <a:p>
             <a:r>
-              <a:rPr lang="en-US" smtClean="0"/>
+              <a:rPr lang="en-US"/>
               <a:t>Click to edit Master title style</a:t>
             </a:r>
-            <a:endParaRPr lang="en-US"/>
           </a:p>
         </p:txBody>
       </p:sp>
@@ -273,10 +288,9 @@
           </a:lstStyle>
           <a:p>
             <a:r>
-              <a:rPr lang="en-US" smtClean="0"/>
+              <a:rPr lang="en-US"/>
               <a:t>Click to edit Master subtitle style</a:t>
             </a:r>
-            <a:endParaRPr lang="en-US"/>
           </a:p>
         </p:txBody>
       </p:sp>
@@ -297,7 +311,7 @@
           <a:p>
             <a:fld id="{5BCAD085-E8A6-8845-BD4E-CB4CCA059FC4}" type="datetimeFigureOut">
               <a:rPr lang="en-US" smtClean="0"/>
-              <a:t>1/27/13</a:t>
+              <a:t>7/6/2026</a:t>
             </a:fld>
             <a:endParaRPr lang="en-US"/>
           </a:p>
@@ -391,10 +405,9 @@
           <a:lstStyle/>
           <a:p>
             <a:r>
-              <a:rPr lang="en-US" smtClean="0"/>
+              <a:rPr lang="en-US"/>
               <a:t>Click to edit Master title style</a:t>
             </a:r>
-            <a:endParaRPr lang="en-US"/>
           </a:p>
         </p:txBody>
       </p:sp>
@@ -415,38 +428,37 @@
           <a:p>
             <a:pPr lvl="0"/>
             <a:r>
-              <a:rPr lang="en-US" smtClean="0"/>
+              <a:rPr lang="en-US"/>
               <a:t>Click to edit Master text styles</a:t>
             </a:r>
           </a:p>
           <a:p>
             <a:pPr lvl="1"/>
             <a:r>
-              <a:rPr lang="en-US" smtClean="0"/>
+              <a:rPr lang="en-US"/>
               <a:t>Second level</a:t>
             </a:r>
           </a:p>
           <a:p>
             <a:pPr lvl="2"/>
             <a:r>
-              <a:rPr lang="en-US" smtClean="0"/>
+              <a:rPr lang="en-US"/>
               <a:t>Third level</a:t>
             </a:r>
           </a:p>
           <a:p>
             <a:pPr lvl="3"/>
             <a:r>
-              <a:rPr lang="en-US" smtClean="0"/>
+              <a:rPr lang="en-US"/>
               <a:t>Fourth level</a:t>
             </a:r>
           </a:p>
           <a:p>
             <a:pPr lvl="4"/>
             <a:r>
-              <a:rPr lang="en-US" smtClean="0"/>
+              <a:rPr lang="en-US"/>
               <a:t>Fifth level</a:t>
             </a:r>
-            <a:endParaRPr lang="en-US"/>
           </a:p>
         </p:txBody>
       </p:sp>
@@ -467,7 +479,7 @@
           <a:p>
             <a:fld id="{5BCAD085-E8A6-8845-BD4E-CB4CCA059FC4}" type="datetimeFigureOut">
               <a:rPr lang="en-US" smtClean="0"/>
-              <a:t>1/27/13</a:t>
+              <a:t>7/6/2026</a:t>
             </a:fld>
             <a:endParaRPr lang="en-US"/>
           </a:p>
@@ -566,10 +578,9 @@
           <a:lstStyle/>
           <a:p>
             <a:r>
-              <a:rPr lang="en-US" smtClean="0"/>
+              <a:rPr lang="en-US"/>
               <a:t>Click to edit Master title style</a:t>
             </a:r>
-            <a:endParaRPr lang="en-US"/>
           </a:p>
         </p:txBody>
       </p:sp>
@@ -595,38 +606,37 @@
           <a:p>
             <a:pPr lvl="0"/>
             <a:r>
-              <a:rPr lang="en-US" smtClean="0"/>
+              <a:rPr lang="en-US"/>
               <a:t>Click to edit Master text styles</a:t>
             </a:r>
           </a:p>
           <a:p>
             <a:pPr lvl="1"/>
             <a:r>
-              <a:rPr lang="en-US" smtClean="0"/>
+              <a:rPr lang="en-US"/>
               <a:t>Second level</a:t>
             </a:r>
           </a:p>
           <a:p>
             <a:pPr lvl="2"/>
             <a:r>
-              <a:rPr lang="en-US" smtClean="0"/>
+              <a:rPr lang="en-US"/>
               <a:t>Third level</a:t>
             </a:r>
           </a:p>
           <a:p>
             <a:pPr lvl="3"/>
             <a:r>
-              <a:rPr lang="en-US" smtClean="0"/>
+              <a:rPr lang="en-US"/>
               <a:t>Fourth level</a:t>
             </a:r>
           </a:p>
           <a:p>
             <a:pPr lvl="4"/>
             <a:r>
-              <a:rPr lang="en-US" smtClean="0"/>
+              <a:rPr lang="en-US"/>
               <a:t>Fifth level</a:t>
             </a:r>
-            <a:endParaRPr lang="en-US"/>
           </a:p>
         </p:txBody>
       </p:sp>
@@ -647,7 +657,7 @@
           <a:p>
             <a:fld id="{5BCAD085-E8A6-8845-BD4E-CB4CCA059FC4}" type="datetimeFigureOut">
               <a:rPr lang="en-US" smtClean="0"/>
-              <a:t>1/27/13</a:t>
+              <a:t>7/6/2026</a:t>
             </a:fld>
             <a:endParaRPr lang="en-US"/>
           </a:p>
@@ -741,10 +751,9 @@
           <a:lstStyle/>
           <a:p>
             <a:r>
-              <a:rPr lang="en-US" smtClean="0"/>
+              <a:rPr lang="en-US"/>
               <a:t>Click to edit Master title style</a:t>
             </a:r>
-            <a:endParaRPr lang="en-US"/>
           </a:p>
         </p:txBody>
       </p:sp>
@@ -765,38 +774,37 @@
           <a:p>
             <a:pPr lvl="0"/>
             <a:r>
-              <a:rPr lang="en-US" smtClean="0"/>
+              <a:rPr lang="en-US"/>
               <a:t>Click to edit Master text styles</a:t>
             </a:r>
           </a:p>
           <a:p>
             <a:pPr lvl="1"/>
             <a:r>
-              <a:rPr lang="en-US" smtClean="0"/>
+              <a:rPr lang="en-US"/>
               <a:t>Second level</a:t>
             </a:r>
           </a:p>
           <a:p>
             <a:pPr lvl="2"/>
             <a:r>
-              <a:rPr lang="en-US" smtClean="0"/>
+              <a:rPr lang="en-US"/>
               <a:t>Third level</a:t>
             </a:r>
           </a:p>
           <a:p>
             <a:pPr lvl="3"/>
             <a:r>
-              <a:rPr lang="en-US" smtClean="0"/>
+              <a:rPr lang="en-US"/>
               <a:t>Fourth level</a:t>
             </a:r>
           </a:p>
           <a:p>
             <a:pPr lvl="4"/>
             <a:r>
-              <a:rPr lang="en-US" smtClean="0"/>
+              <a:rPr lang="en-US"/>
               <a:t>Fifth level</a:t>
             </a:r>
-            <a:endParaRPr lang="en-US"/>
           </a:p>
         </p:txBody>
       </p:sp>
@@ -817,7 +825,7 @@
           <a:p>
             <a:fld id="{5BCAD085-E8A6-8845-BD4E-CB4CCA059FC4}" type="datetimeFigureOut">
               <a:rPr lang="en-US" smtClean="0"/>
-              <a:t>1/27/13</a:t>
+              <a:t>7/6/2026</a:t>
             </a:fld>
             <a:endParaRPr lang="en-US"/>
           </a:p>
@@ -920,10 +928,9 @@
           </a:lstStyle>
           <a:p>
             <a:r>
-              <a:rPr lang="en-US" smtClean="0"/>
+              <a:rPr lang="en-US"/>
               <a:t>Click to edit Master title style</a:t>
             </a:r>
-            <a:endParaRPr lang="en-US"/>
           </a:p>
         </p:txBody>
       </p:sp>
@@ -1040,7 +1047,7 @@
           <a:p>
             <a:pPr lvl="0"/>
             <a:r>
-              <a:rPr lang="en-US" smtClean="0"/>
+              <a:rPr lang="en-US"/>
               <a:t>Click to edit Master text styles</a:t>
             </a:r>
           </a:p>
@@ -1063,7 +1070,7 @@
           <a:p>
             <a:fld id="{5BCAD085-E8A6-8845-BD4E-CB4CCA059FC4}" type="datetimeFigureOut">
               <a:rPr lang="en-US" smtClean="0"/>
-              <a:t>1/27/13</a:t>
+              <a:t>7/6/2026</a:t>
             </a:fld>
             <a:endParaRPr lang="en-US"/>
           </a:p>
@@ -1157,10 +1164,9 @@
           <a:lstStyle/>
           <a:p>
             <a:r>
-              <a:rPr lang="en-US" smtClean="0"/>
+              <a:rPr lang="en-US"/>
               <a:t>Click to edit Master title style</a:t>
             </a:r>
-            <a:endParaRPr lang="en-US"/>
           </a:p>
         </p:txBody>
       </p:sp>
@@ -1214,38 +1220,37 @@
           <a:p>
             <a:pPr lvl="0"/>
             <a:r>
-              <a:rPr lang="en-US" smtClean="0"/>
+              <a:rPr lang="en-US"/>
               <a:t>Click to edit Master text styles</a:t>
             </a:r>
           </a:p>
           <a:p>
             <a:pPr lvl="1"/>
             <a:r>
-              <a:rPr lang="en-US" smtClean="0"/>
+              <a:rPr lang="en-US"/>
               <a:t>Second level</a:t>
             </a:r>
           </a:p>
           <a:p>
             <a:pPr lvl="2"/>
             <a:r>
-              <a:rPr lang="en-US" smtClean="0"/>
+              <a:rPr lang="en-US"/>
               <a:t>Third level</a:t>
             </a:r>
           </a:p>
           <a:p>
             <a:pPr lvl="3"/>
             <a:r>
-              <a:rPr lang="en-US" smtClean="0"/>
+              <a:rPr lang="en-US"/>
               <a:t>Fourth level</a:t>
             </a:r>
           </a:p>
           <a:p>
             <a:pPr lvl="4"/>
             <a:r>
-              <a:rPr lang="en-US" smtClean="0"/>
+              <a:rPr lang="en-US"/>
               <a:t>Fifth level</a:t>
             </a:r>
-            <a:endParaRPr lang="en-US"/>
           </a:p>
         </p:txBody>
       </p:sp>
@@ -1299,38 +1304,37 @@
           <a:p>
             <a:pPr lvl="0"/>
             <a:r>
-              <a:rPr lang="en-US" smtClean="0"/>
+              <a:rPr lang="en-US"/>
               <a:t>Click to edit Master text styles</a:t>
             </a:r>
           </a:p>
           <a:p>
             <a:pPr lvl="1"/>
             <a:r>
-              <a:rPr lang="en-US" smtClean="0"/>
+              <a:rPr lang="en-US"/>
               <a:t>Second level</a:t>
             </a:r>
           </a:p>
           <a:p>
             <a:pPr lvl="2"/>
             <a:r>
-              <a:rPr lang="en-US" smtClean="0"/>
+              <a:rPr lang="en-US"/>
               <a:t>Third level</a:t>
             </a:r>
           </a:p>
           <a:p>
             <a:pPr lvl="3"/>
             <a:r>
-              <a:rPr lang="en-US" smtClean="0"/>
+              <a:rPr lang="en-US"/>
               <a:t>Fourth level</a:t>
             </a:r>
           </a:p>
           <a:p>
             <a:pPr lvl="4"/>
             <a:r>
-              <a:rPr lang="en-US" smtClean="0"/>
+              <a:rPr lang="en-US"/>
               <a:t>Fifth level</a:t>
             </a:r>
-            <a:endParaRPr lang="en-US"/>
           </a:p>
         </p:txBody>
       </p:sp>
@@ -1351,7 +1355,7 @@
           <a:p>
             <a:fld id="{5BCAD085-E8A6-8845-BD4E-CB4CCA059FC4}" type="datetimeFigureOut">
               <a:rPr lang="en-US" smtClean="0"/>
-              <a:t>1/27/13</a:t>
+              <a:t>7/6/2026</a:t>
             </a:fld>
             <a:endParaRPr lang="en-US"/>
           </a:p>
@@ -1449,10 +1453,9 @@
           </a:lstStyle>
           <a:p>
             <a:r>
-              <a:rPr lang="en-US" smtClean="0"/>
+              <a:rPr lang="en-US"/>
               <a:t>Click to edit Master title style</a:t>
             </a:r>
-            <a:endParaRPr lang="en-US"/>
           </a:p>
         </p:txBody>
       </p:sp>
@@ -1515,7 +1518,7 @@
           <a:p>
             <a:pPr lvl="0"/>
             <a:r>
-              <a:rPr lang="en-US" smtClean="0"/>
+              <a:rPr lang="en-US"/>
               <a:t>Click to edit Master text styles</a:t>
             </a:r>
           </a:p>
@@ -1571,38 +1574,37 @@
           <a:p>
             <a:pPr lvl="0"/>
             <a:r>
-              <a:rPr lang="en-US" smtClean="0"/>
+              <a:rPr lang="en-US"/>
               <a:t>Click to edit Master text styles</a:t>
             </a:r>
           </a:p>
           <a:p>
             <a:pPr lvl="1"/>
             <a:r>
-              <a:rPr lang="en-US" smtClean="0"/>
+              <a:rPr lang="en-US"/>
               <a:t>Second level</a:t>
             </a:r>
           </a:p>
           <a:p>
             <a:pPr lvl="2"/>
             <a:r>
-              <a:rPr lang="en-US" smtClean="0"/>
+              <a:rPr lang="en-US"/>
               <a:t>Third level</a:t>
             </a:r>
           </a:p>
           <a:p>
             <a:pPr lvl="3"/>
             <a:r>
-              <a:rPr lang="en-US" smtClean="0"/>
+              <a:rPr lang="en-US"/>
               <a:t>Fourth level</a:t>
             </a:r>
           </a:p>
           <a:p>
             <a:pPr lvl="4"/>
             <a:r>
-              <a:rPr lang="en-US" smtClean="0"/>
+              <a:rPr lang="en-US"/>
               <a:t>Fifth level</a:t>
             </a:r>
-            <a:endParaRPr lang="en-US"/>
           </a:p>
         </p:txBody>
       </p:sp>
@@ -1665,7 +1667,7 @@
           <a:p>
             <a:pPr lvl="0"/>
             <a:r>
-              <a:rPr lang="en-US" smtClean="0"/>
+              <a:rPr lang="en-US"/>
               <a:t>Click to edit Master text styles</a:t>
             </a:r>
           </a:p>
@@ -1721,38 +1723,37 @@
           <a:p>
             <a:pPr lvl="0"/>
             <a:r>
-              <a:rPr lang="en-US" smtClean="0"/>
+              <a:rPr lang="en-US"/>
               <a:t>Click to edit Master text styles</a:t>
             </a:r>
           </a:p>
           <a:p>
             <a:pPr lvl="1"/>
             <a:r>
-              <a:rPr lang="en-US" smtClean="0"/>
+              <a:rPr lang="en-US"/>
               <a:t>Second level</a:t>
             </a:r>
           </a:p>
           <a:p>
             <a:pPr lvl="2"/>
             <a:r>
-              <a:rPr lang="en-US" smtClean="0"/>
+              <a:rPr lang="en-US"/>
               <a:t>Third level</a:t>
             </a:r>
           </a:p>
           <a:p>
             <a:pPr lvl="3"/>
             <a:r>
-              <a:rPr lang="en-US" smtClean="0"/>
+              <a:rPr lang="en-US"/>
               <a:t>Fourth level</a:t>
             </a:r>
           </a:p>
           <a:p>
             <a:pPr lvl="4"/>
             <a:r>
-              <a:rPr lang="en-US" smtClean="0"/>
+              <a:rPr lang="en-US"/>
               <a:t>Fifth level</a:t>
             </a:r>
-            <a:endParaRPr lang="en-US"/>
           </a:p>
         </p:txBody>
       </p:sp>
@@ -1773,7 +1774,7 @@
           <a:p>
             <a:fld id="{5BCAD085-E8A6-8845-BD4E-CB4CCA059FC4}" type="datetimeFigureOut">
               <a:rPr lang="en-US" smtClean="0"/>
-              <a:t>1/27/13</a:t>
+              <a:t>7/6/2026</a:t>
             </a:fld>
             <a:endParaRPr lang="en-US"/>
           </a:p>
@@ -1867,10 +1868,9 @@
           <a:lstStyle/>
           <a:p>
             <a:r>
-              <a:rPr lang="en-US" smtClean="0"/>
+              <a:rPr lang="en-US"/>
               <a:t>Click to edit Master title style</a:t>
             </a:r>
-            <a:endParaRPr lang="en-US"/>
           </a:p>
         </p:txBody>
       </p:sp>
@@ -1891,7 +1891,7 @@
           <a:p>
             <a:fld id="{5BCAD085-E8A6-8845-BD4E-CB4CCA059FC4}" type="datetimeFigureOut">
               <a:rPr lang="en-US" smtClean="0"/>
-              <a:t>1/27/13</a:t>
+              <a:t>7/6/2026</a:t>
             </a:fld>
             <a:endParaRPr lang="en-US"/>
           </a:p>
@@ -1986,7 +1986,7 @@
           <a:p>
             <a:fld id="{5BCAD085-E8A6-8845-BD4E-CB4CCA059FC4}" type="datetimeFigureOut">
               <a:rPr lang="en-US" smtClean="0"/>
-              <a:t>1/27/13</a:t>
+              <a:t>7/6/2026</a:t>
             </a:fld>
             <a:endParaRPr lang="en-US"/>
           </a:p>
@@ -2089,10 +2089,9 @@
           </a:lstStyle>
           <a:p>
             <a:r>
-              <a:rPr lang="en-US" smtClean="0"/>
+              <a:rPr lang="en-US"/>
               <a:t>Click to edit Master title style</a:t>
             </a:r>
-            <a:endParaRPr lang="en-US"/>
           </a:p>
         </p:txBody>
       </p:sp>
@@ -2146,38 +2145,37 @@
           <a:p>
             <a:pPr lvl="0"/>
             <a:r>
-              <a:rPr lang="en-US" smtClean="0"/>
+              <a:rPr lang="en-US"/>
               <a:t>Click to edit Master text styles</a:t>
             </a:r>
           </a:p>
           <a:p>
             <a:pPr lvl="1"/>
             <a:r>
-              <a:rPr lang="en-US" smtClean="0"/>
+              <a:rPr lang="en-US"/>
               <a:t>Second level</a:t>
             </a:r>
           </a:p>
           <a:p>
             <a:pPr lvl="2"/>
             <a:r>
-              <a:rPr lang="en-US" smtClean="0"/>
+              <a:rPr lang="en-US"/>
               <a:t>Third level</a:t>
             </a:r>
           </a:p>
           <a:p>
             <a:pPr lvl="3"/>
             <a:r>
-              <a:rPr lang="en-US" smtClean="0"/>
+              <a:rPr lang="en-US"/>
               <a:t>Fourth level</a:t>
             </a:r>
           </a:p>
           <a:p>
             <a:pPr lvl="4"/>
             <a:r>
-              <a:rPr lang="en-US" smtClean="0"/>
+              <a:rPr lang="en-US"/>
               <a:t>Fifth level</a:t>
             </a:r>
-            <a:endParaRPr lang="en-US"/>
           </a:p>
         </p:txBody>
       </p:sp>
@@ -2240,7 +2238,7 @@
           <a:p>
             <a:pPr lvl="0"/>
             <a:r>
-              <a:rPr lang="en-US" smtClean="0"/>
+              <a:rPr lang="en-US"/>
               <a:t>Click to edit Master text styles</a:t>
             </a:r>
           </a:p>
@@ -2263,7 +2261,7 @@
           <a:p>
             <a:fld id="{5BCAD085-E8A6-8845-BD4E-CB4CCA059FC4}" type="datetimeFigureOut">
               <a:rPr lang="en-US" smtClean="0"/>
-              <a:t>1/27/13</a:t>
+              <a:t>7/6/2026</a:t>
             </a:fld>
             <a:endParaRPr lang="en-US"/>
           </a:p>
@@ -2366,10 +2364,9 @@
           </a:lstStyle>
           <a:p>
             <a:r>
-              <a:rPr lang="en-US" smtClean="0"/>
+              <a:rPr lang="en-US"/>
               <a:t>Click to edit Master title style</a:t>
             </a:r>
-            <a:endParaRPr lang="en-US"/>
           </a:p>
         </p:txBody>
       </p:sp>
@@ -2493,7 +2490,7 @@
           <a:p>
             <a:pPr lvl="0"/>
             <a:r>
-              <a:rPr lang="en-US" smtClean="0"/>
+              <a:rPr lang="en-US"/>
               <a:t>Click to edit Master text styles</a:t>
             </a:r>
           </a:p>
@@ -2516,7 +2513,7 @@
           <a:p>
             <a:fld id="{5BCAD085-E8A6-8845-BD4E-CB4CCA059FC4}" type="datetimeFigureOut">
               <a:rPr lang="en-US" smtClean="0"/>
-              <a:t>1/27/13</a:t>
+              <a:t>7/6/2026</a:t>
             </a:fld>
             <a:endParaRPr lang="en-US"/>
           </a:p>
@@ -2625,10 +2622,9 @@
           <a:lstStyle/>
           <a:p>
             <a:r>
-              <a:rPr lang="en-US" smtClean="0"/>
+              <a:rPr lang="en-US"/>
               <a:t>Click to edit Master title style</a:t>
             </a:r>
-            <a:endParaRPr lang="en-US"/>
           </a:p>
         </p:txBody>
       </p:sp>
@@ -2659,38 +2655,37 @@
           <a:p>
             <a:pPr lvl="0"/>
             <a:r>
-              <a:rPr lang="en-US" smtClean="0"/>
+              <a:rPr lang="en-US"/>
               <a:t>Click to edit Master text styles</a:t>
             </a:r>
           </a:p>
           <a:p>
             <a:pPr lvl="1"/>
             <a:r>
-              <a:rPr lang="en-US" smtClean="0"/>
+              <a:rPr lang="en-US"/>
               <a:t>Second level</a:t>
             </a:r>
           </a:p>
           <a:p>
             <a:pPr lvl="2"/>
             <a:r>
-              <a:rPr lang="en-US" smtClean="0"/>
+              <a:rPr lang="en-US"/>
               <a:t>Third level</a:t>
             </a:r>
           </a:p>
           <a:p>
             <a:pPr lvl="3"/>
             <a:r>
-              <a:rPr lang="en-US" smtClean="0"/>
+              <a:rPr lang="en-US"/>
               <a:t>Fourth level</a:t>
             </a:r>
           </a:p>
           <a:p>
             <a:pPr lvl="4"/>
             <a:r>
-              <a:rPr lang="en-US" smtClean="0"/>
+              <a:rPr lang="en-US"/>
               <a:t>Fifth level</a:t>
             </a:r>
-            <a:endParaRPr lang="en-US"/>
           </a:p>
         </p:txBody>
       </p:sp>
@@ -2729,7 +2724,7 @@
           <a:p>
             <a:fld id="{5BCAD085-E8A6-8845-BD4E-CB4CCA059FC4}" type="datetimeFigureOut">
               <a:rPr lang="en-US" smtClean="0"/>
-              <a:t>1/27/13</a:t>
+              <a:t>7/6/2026</a:t>
             </a:fld>
             <a:endParaRPr lang="en-US"/>
           </a:p>
@@ -3088,7 +3083,7 @@
 </file>
 
 <file path=ppt/slides/slide1.xml><?xml version="1.0" encoding="utf-8"?>
-<p:sld xmlns:a="http://schemas.openxmlformats.org/drawingml/2006/main" xmlns:p="http://schemas.openxmlformats.org/presentationml/2006/main" xmlns:r="http://schemas.openxmlformats.org/officeDocument/2006/relationships">
+<p:sld xmlns:a="http://schemas.openxmlformats.org/drawingml/2006/main" xmlns:r="http://schemas.openxmlformats.org/officeDocument/2006/relationships" xmlns:p="http://schemas.openxmlformats.org/presentationml/2006/main">
   <p:cSld>
     <p:bg>
       <p:bgPr>
@@ -3104,7 +3099,14 @@
         <p:cNvGrpSpPr/>
         <p:nvPr/>
       </p:nvGrpSpPr>
-      <p:grpSpPr/>
+      <p:grpSpPr>
+        <a:xfrm>
+          <a:off x="0" y="0"/>
+          <a:ext cx="0" cy="0"/>
+          <a:chOff x="0" y="0"/>
+          <a:chExt cx="0" cy="0"/>
+        </a:xfrm>
+      </p:grpSpPr>
       <p:sp>
         <p:nvSpPr>
           <p:cNvPr id="2" name="TextBox 1"/>
@@ -3210,7 +3212,7 @@
 </file>
 
 <file path=ppt/slides/slide10.xml><?xml version="1.0" encoding="utf-8"?>
-<p:sld xmlns:a="http://schemas.openxmlformats.org/drawingml/2006/main" xmlns:p="http://schemas.openxmlformats.org/presentationml/2006/main" xmlns:r="http://schemas.openxmlformats.org/officeDocument/2006/relationships">
+<p:sld xmlns:a="http://schemas.openxmlformats.org/drawingml/2006/main" xmlns:r="http://schemas.openxmlformats.org/officeDocument/2006/relationships" xmlns:p="http://schemas.openxmlformats.org/presentationml/2006/main">
   <p:cSld>
     <p:bg>
       <p:bgPr>
@@ -3226,7 +3228,14 @@
         <p:cNvGrpSpPr/>
         <p:nvPr/>
       </p:nvGrpSpPr>
-      <p:grpSpPr/>
+      <p:grpSpPr>
+        <a:xfrm>
+          <a:off x="0" y="0"/>
+          <a:ext cx="0" cy="0"/>
+          <a:chOff x="0" y="0"/>
+          <a:chExt cx="0" cy="0"/>
+        </a:xfrm>
+      </p:grpSpPr>
       <p:sp>
         <p:nvSpPr>
           <p:cNvPr id="2" name="TextBox 1"/>
@@ -3316,7 +3325,7 @@
 </file>
 
 <file path=ppt/slides/slide2.xml><?xml version="1.0" encoding="utf-8"?>
-<p:sld xmlns:a="http://schemas.openxmlformats.org/drawingml/2006/main" xmlns:p="http://schemas.openxmlformats.org/presentationml/2006/main" xmlns:r="http://schemas.openxmlformats.org/officeDocument/2006/relationships">
+<p:sld xmlns:a="http://schemas.openxmlformats.org/drawingml/2006/main" xmlns:r="http://schemas.openxmlformats.org/officeDocument/2006/relationships" xmlns:p="http://schemas.openxmlformats.org/presentationml/2006/main">
   <p:cSld>
     <p:bg>
       <p:bgPr>
@@ -3332,7 +3341,14 @@
         <p:cNvGrpSpPr/>
         <p:nvPr/>
       </p:nvGrpSpPr>
-      <p:grpSpPr/>
+      <p:grpSpPr>
+        <a:xfrm>
+          <a:off x="0" y="0"/>
+          <a:ext cx="0" cy="0"/>
+          <a:chOff x="0" y="0"/>
+          <a:chExt cx="0" cy="0"/>
+        </a:xfrm>
+      </p:grpSpPr>
       <p:sp>
         <p:nvSpPr>
           <p:cNvPr id="2" name="TextBox 1"/>
@@ -3389,7 +3405,9 @@
             <a:spAutoFit/>
           </a:bodyPr>
           <a:lstStyle/>
-          <a:p/>
+          <a:p>
+            <a:endParaRPr/>
+          </a:p>
           <a:p>
             <a:pPr>
               <a:spcBef>
@@ -3509,7 +3527,7 @@
 </file>
 
 <file path=ppt/slides/slide3.xml><?xml version="1.0" encoding="utf-8"?>
-<p:sld xmlns:a="http://schemas.openxmlformats.org/drawingml/2006/main" xmlns:p="http://schemas.openxmlformats.org/presentationml/2006/main" xmlns:r="http://schemas.openxmlformats.org/officeDocument/2006/relationships">
+<p:sld xmlns:a="http://schemas.openxmlformats.org/drawingml/2006/main" xmlns:r="http://schemas.openxmlformats.org/officeDocument/2006/relationships" xmlns:p="http://schemas.openxmlformats.org/presentationml/2006/main">
   <p:cSld>
     <p:bg>
       <p:bgPr>
@@ -3525,7 +3543,14 @@
         <p:cNvGrpSpPr/>
         <p:nvPr/>
       </p:nvGrpSpPr>
-      <p:grpSpPr/>
+      <p:grpSpPr>
+        <a:xfrm>
+          <a:off x="0" y="0"/>
+          <a:ext cx="0" cy="0"/>
+          <a:chOff x="0" y="0"/>
+          <a:chExt cx="0" cy="0"/>
+        </a:xfrm>
+      </p:grpSpPr>
       <p:sp>
         <p:nvSpPr>
           <p:cNvPr id="2" name="TextBox 1"/>
@@ -3582,7 +3607,9 @@
             <a:spAutoFit/>
           </a:bodyPr>
           <a:lstStyle/>
-          <a:p/>
+          <a:p>
+            <a:endParaRPr/>
+          </a:p>
           <a:p>
             <a:pPr>
               <a:spcBef>
@@ -3745,8 +3772,8 @@
         </p:blipFill>
         <p:spPr>
           <a:xfrm>
-            <a:off x="6858000" y="1097280"/>
-            <a:ext cx="4754880" cy="2358163"/>
+            <a:off x="6400800" y="1097280"/>
+            <a:ext cx="5212080" cy="2584909"/>
           </a:xfrm>
           <a:prstGeom prst="rect">
             <a:avLst/>
@@ -3769,8 +3796,8 @@
         </p:blipFill>
         <p:spPr>
           <a:xfrm>
-            <a:off x="6858000" y="3840480"/>
-            <a:ext cx="4754880" cy="2650986"/>
+            <a:off x="6400800" y="3840480"/>
+            <a:ext cx="5212080" cy="2650986"/>
           </a:xfrm>
           <a:prstGeom prst="rect">
             <a:avLst/>
@@ -3786,7 +3813,7 @@
 </file>
 
 <file path=ppt/slides/slide4.xml><?xml version="1.0" encoding="utf-8"?>
-<p:sld xmlns:a="http://schemas.openxmlformats.org/drawingml/2006/main" xmlns:p="http://schemas.openxmlformats.org/presentationml/2006/main" xmlns:r="http://schemas.openxmlformats.org/officeDocument/2006/relationships">
+<p:sld xmlns:a="http://schemas.openxmlformats.org/drawingml/2006/main" xmlns:r="http://schemas.openxmlformats.org/officeDocument/2006/relationships" xmlns:p="http://schemas.openxmlformats.org/presentationml/2006/main">
   <p:cSld>
     <p:bg>
       <p:bgPr>
@@ -3802,7 +3829,14 @@
         <p:cNvGrpSpPr/>
         <p:nvPr/>
       </p:nvGrpSpPr>
-      <p:grpSpPr/>
+      <p:grpSpPr>
+        <a:xfrm>
+          <a:off x="0" y="0"/>
+          <a:ext cx="0" cy="0"/>
+          <a:chOff x="0" y="0"/>
+          <a:chExt cx="0" cy="0"/>
+        </a:xfrm>
+      </p:grpSpPr>
       <p:sp>
         <p:nvSpPr>
           <p:cNvPr id="2" name="TextBox 1"/>
@@ -3859,7 +3893,9 @@
             <a:spAutoFit/>
           </a:bodyPr>
           <a:lstStyle/>
-          <a:p/>
+          <a:p>
+            <a:endParaRPr/>
+          </a:p>
           <a:p>
             <a:pPr>
               <a:spcBef>
@@ -3991,7 +4027,7 @@
 </file>
 
 <file path=ppt/slides/slide5.xml><?xml version="1.0" encoding="utf-8"?>
-<p:sld xmlns:a="http://schemas.openxmlformats.org/drawingml/2006/main" xmlns:p="http://schemas.openxmlformats.org/presentationml/2006/main" xmlns:r="http://schemas.openxmlformats.org/officeDocument/2006/relationships">
+<p:sld xmlns:a="http://schemas.openxmlformats.org/drawingml/2006/main" xmlns:r="http://schemas.openxmlformats.org/officeDocument/2006/relationships" xmlns:p="http://schemas.openxmlformats.org/presentationml/2006/main">
   <p:cSld>
     <p:bg>
       <p:bgPr>
@@ -4007,7 +4043,14 @@
         <p:cNvGrpSpPr/>
         <p:nvPr/>
       </p:nvGrpSpPr>
-      <p:grpSpPr/>
+      <p:grpSpPr>
+        <a:xfrm>
+          <a:off x="0" y="0"/>
+          <a:ext cx="0" cy="0"/>
+          <a:chOff x="0" y="0"/>
+          <a:chExt cx="0" cy="0"/>
+        </a:xfrm>
+      </p:grpSpPr>
       <p:sp>
         <p:nvSpPr>
           <p:cNvPr id="2" name="TextBox 1"/>
@@ -4062,9 +4105,27 @@
                 <a:tableStyleId>{5C22544A-7EE6-4342-B048-85BDC9FD1C3A}</a:tableStyleId>
               </a:tblPr>
               <a:tblGrid>
-                <a:gridCol w="2926080"/>
-                <a:gridCol w="1188720"/>
-                <a:gridCol w="1188720"/>
+                <a:gridCol w="2926080">
+                  <a:extLst>
+                    <a:ext uri="{9D8B030D-6E8A-4147-A177-3AD203B41FA5}">
+                      <a16:colId xmlns:a16="http://schemas.microsoft.com/office/drawing/2014/main" val="20000"/>
+                    </a:ext>
+                  </a:extLst>
+                </a:gridCol>
+                <a:gridCol w="1188720">
+                  <a:extLst>
+                    <a:ext uri="{9D8B030D-6E8A-4147-A177-3AD203B41FA5}">
+                      <a16:colId xmlns:a16="http://schemas.microsoft.com/office/drawing/2014/main" val="20001"/>
+                    </a:ext>
+                  </a:extLst>
+                </a:gridCol>
+                <a:gridCol w="1188720">
+                  <a:extLst>
+                    <a:ext uri="{9D8B030D-6E8A-4147-A177-3AD203B41FA5}">
+                      <a16:colId xmlns:a16="http://schemas.microsoft.com/office/drawing/2014/main" val="20002"/>
+                    </a:ext>
+                  </a:extLst>
+                </a:gridCol>
               </a:tblGrid>
               <a:tr h="457200">
                 <a:tc>
@@ -4136,6 +4197,11 @@
                     </a:solidFill>
                   </a:tcPr>
                 </a:tc>
+                <a:extLst>
+                  <a:ext uri="{0D108BD9-81ED-4DB2-BD59-A6C34878D82A}">
+                    <a16:rowId xmlns:a16="http://schemas.microsoft.com/office/drawing/2014/main" val="10000"/>
+                  </a:ext>
+                </a:extLst>
               </a:tr>
               <a:tr h="457200">
                 <a:tc>
@@ -4183,6 +4249,11 @@
                   </a:txBody>
                   <a:tcPr/>
                 </a:tc>
+                <a:extLst>
+                  <a:ext uri="{0D108BD9-81ED-4DB2-BD59-A6C34878D82A}">
+                    <a16:rowId xmlns:a16="http://schemas.microsoft.com/office/drawing/2014/main" val="10001"/>
+                  </a:ext>
+                </a:extLst>
               </a:tr>
               <a:tr h="457200">
                 <a:tc>
@@ -4242,6 +4313,11 @@
                     </a:solidFill>
                   </a:tcPr>
                 </a:tc>
+                <a:extLst>
+                  <a:ext uri="{0D108BD9-81ED-4DB2-BD59-A6C34878D82A}">
+                    <a16:rowId xmlns:a16="http://schemas.microsoft.com/office/drawing/2014/main" val="10002"/>
+                  </a:ext>
+                </a:extLst>
               </a:tr>
               <a:tr h="457200">
                 <a:tc>
@@ -4301,6 +4377,11 @@
                     </a:solidFill>
                   </a:tcPr>
                 </a:tc>
+                <a:extLst>
+                  <a:ext uri="{0D108BD9-81ED-4DB2-BD59-A6C34878D82A}">
+                    <a16:rowId xmlns:a16="http://schemas.microsoft.com/office/drawing/2014/main" val="10003"/>
+                  </a:ext>
+                </a:extLst>
               </a:tr>
               <a:tr h="457200">
                 <a:tc>
@@ -4312,6 +4393,7 @@
                         <a:defRPr sz="1200"/>
                       </a:pPr>
                       <a:r>
+                        <a:rPr dirty="0"/>
                         <a:t>KNN Optimized</a:t>
                       </a:r>
                     </a:p>
@@ -4360,6 +4442,11 @@
                     </a:solidFill>
                   </a:tcPr>
                 </a:tc>
+                <a:extLst>
+                  <a:ext uri="{0D108BD9-81ED-4DB2-BD59-A6C34878D82A}">
+                    <a16:rowId xmlns:a16="http://schemas.microsoft.com/office/drawing/2014/main" val="10004"/>
+                  </a:ext>
+                </a:extLst>
               </a:tr>
               <a:tr h="457200">
                 <a:tc>
@@ -4407,6 +4494,11 @@
                   </a:txBody>
                   <a:tcPr/>
                 </a:tc>
+                <a:extLst>
+                  <a:ext uri="{0D108BD9-81ED-4DB2-BD59-A6C34878D82A}">
+                    <a16:rowId xmlns:a16="http://schemas.microsoft.com/office/drawing/2014/main" val="10005"/>
+                  </a:ext>
+                </a:extLst>
               </a:tr>
               <a:tr h="457200">
                 <a:tc>
@@ -4456,6 +4548,7 @@
                         <a:defRPr sz="1200"/>
                       </a:pPr>
                       <a:r>
+                        <a:rPr dirty="0"/>
                         <a:t>0.891</a:t>
                       </a:r>
                     </a:p>
@@ -4466,6 +4559,11 @@
                     </a:solidFill>
                   </a:tcPr>
                 </a:tc>
+                <a:extLst>
+                  <a:ext uri="{0D108BD9-81ED-4DB2-BD59-A6C34878D82A}">
+                    <a16:rowId xmlns:a16="http://schemas.microsoft.com/office/drawing/2014/main" val="10006"/>
+                  </a:ext>
+                </a:extLst>
               </a:tr>
             </a:tbl>
           </a:graphicData>
@@ -4487,7 +4585,7 @@
         </p:blipFill>
         <p:spPr>
           <a:xfrm>
-            <a:off x="6400800" y="1188720"/>
+            <a:off x="6400800" y="731520"/>
             <a:ext cx="5029200" cy="2828925"/>
           </a:xfrm>
           <a:prstGeom prst="rect">
@@ -4511,8 +4609,8 @@
         </p:blipFill>
         <p:spPr>
           <a:xfrm>
-            <a:off x="6400800" y="3840480"/>
-            <a:ext cx="5029200" cy="4294762"/>
+            <a:off x="6583680" y="3560445"/>
+            <a:ext cx="4846320" cy="3076980"/>
           </a:xfrm>
           <a:prstGeom prst="rect">
             <a:avLst/>
@@ -4528,7 +4626,7 @@
         <p:spPr>
           <a:xfrm>
             <a:off x="731520" y="4937760"/>
-            <a:ext cx="5486400" cy="1371600"/>
+            <a:ext cx="5793574" cy="933589"/>
           </a:xfrm>
           <a:prstGeom prst="rect">
             <a:avLst/>
@@ -4540,7 +4638,9 @@
             <a:spAutoFit/>
           </a:bodyPr>
           <a:lstStyle/>
-          <a:p/>
+          <a:p>
+            <a:endParaRPr dirty="0"/>
+          </a:p>
           <a:p>
             <a:pPr>
               <a:spcBef>
@@ -4556,7 +4656,16 @@
               </a:defRPr>
             </a:pPr>
             <a:r>
-              <a:t>Model Terbaik: SVM Baseline (F1=0.887, AUC=0.94)</a:t>
+              <a:rPr dirty="0"/>
+              <a:t>Model </a:t>
+            </a:r>
+            <a:r>
+              <a:rPr dirty="0" err="1"/>
+              <a:t>Terbaik</a:t>
+            </a:r>
+            <a:r>
+              <a:rPr dirty="0"/>
+              <a:t>: SVM Baseline (F1=0.887, AUC=0.94)</a:t>
             </a:r>
           </a:p>
           <a:p>
@@ -4574,7 +4683,115 @@
               </a:defRPr>
             </a:pPr>
             <a:r>
-              <a:t>Kernel RBF dan class_weight=balanced menghasilkan F1-Macro tertinggi. SVM Optimized (0.884) mengalami sedikit degradasi karena pengurangan fitur dari 10 menjadi 8.</a:t>
+              <a:rPr dirty="0"/>
+              <a:t>Kernel RBF dan </a:t>
+            </a:r>
+            <a:r>
+              <a:rPr dirty="0" err="1"/>
+              <a:t>class_weight</a:t>
+            </a:r>
+            <a:r>
+              <a:rPr dirty="0"/>
+              <a:t>=balanced </a:t>
+            </a:r>
+            <a:r>
+              <a:rPr dirty="0" err="1"/>
+              <a:t>menghasilkan</a:t>
+            </a:r>
+            <a:r>
+              <a:rPr dirty="0"/>
+              <a:t> F1-Macro </a:t>
+            </a:r>
+            <a:r>
+              <a:rPr dirty="0" err="1"/>
+              <a:t>tertinggi</a:t>
+            </a:r>
+            <a:r>
+              <a:rPr lang="en-US" dirty="0"/>
+              <a:t>.</a:t>
+            </a:r>
+          </a:p>
+          <a:p>
+            <a:pPr>
+              <a:spcBef>
+                <a:spcPts val="0"/>
+              </a:spcBef>
+              <a:spcAft>
+                <a:spcPts val="0"/>
+              </a:spcAft>
+              <a:defRPr sz="1100" b="0">
+                <a:solidFill>
+                  <a:srgbClr val="555555"/>
+                </a:solidFill>
+              </a:defRPr>
+            </a:pPr>
+            <a:r>
+              <a:rPr dirty="0"/>
+              <a:t> SVM Optimized (0.884) </a:t>
+            </a:r>
+            <a:r>
+              <a:rPr dirty="0" err="1"/>
+              <a:t>mengalami</a:t>
+            </a:r>
+            <a:r>
+              <a:rPr dirty="0"/>
+              <a:t> </a:t>
+            </a:r>
+            <a:r>
+              <a:rPr dirty="0" err="1"/>
+              <a:t>sedikit</a:t>
+            </a:r>
+            <a:r>
+              <a:rPr dirty="0"/>
+              <a:t> </a:t>
+            </a:r>
+            <a:r>
+              <a:rPr dirty="0" err="1"/>
+              <a:t>degradasi</a:t>
+            </a:r>
+            <a:r>
+              <a:rPr dirty="0"/>
+              <a:t> </a:t>
+            </a:r>
+            <a:r>
+              <a:rPr dirty="0" err="1"/>
+              <a:t>karena</a:t>
+            </a:r>
+            <a:r>
+              <a:rPr dirty="0"/>
+              <a:t> </a:t>
+            </a:r>
+            <a:r>
+              <a:rPr dirty="0" err="1"/>
+              <a:t>pengurangan</a:t>
+            </a:r>
+            <a:r>
+              <a:rPr dirty="0"/>
+              <a:t> </a:t>
+            </a:r>
+            <a:r>
+              <a:rPr dirty="0" err="1"/>
+              <a:t>fitur</a:t>
+            </a:r>
+            <a:r>
+              <a:rPr dirty="0"/>
+              <a:t> </a:t>
+            </a:r>
+            <a:r>
+              <a:rPr dirty="0" err="1"/>
+              <a:t>dari</a:t>
+            </a:r>
+            <a:r>
+              <a:rPr dirty="0"/>
+              <a:t> 10 </a:t>
+            </a:r>
+            <a:r>
+              <a:rPr dirty="0" err="1"/>
+              <a:t>menjadi</a:t>
+            </a:r>
+            <a:r>
+              <a:rPr dirty="0"/>
+              <a:t> 8.</a:t>
             </a:r>
           </a:p>
         </p:txBody>
@@ -4588,7 +4805,7 @@
 </file>
 
 <file path=ppt/slides/slide6.xml><?xml version="1.0" encoding="utf-8"?>
-<p:sld xmlns:a="http://schemas.openxmlformats.org/drawingml/2006/main" xmlns:p="http://schemas.openxmlformats.org/presentationml/2006/main" xmlns:r="http://schemas.openxmlformats.org/officeDocument/2006/relationships">
+<p:sld xmlns:a="http://schemas.openxmlformats.org/drawingml/2006/main" xmlns:r="http://schemas.openxmlformats.org/officeDocument/2006/relationships" xmlns:p="http://schemas.openxmlformats.org/presentationml/2006/main">
   <p:cSld>
     <p:bg>
       <p:bgPr>
@@ -4604,7 +4821,14 @@
         <p:cNvGrpSpPr/>
         <p:nvPr/>
       </p:nvGrpSpPr>
-      <p:grpSpPr/>
+      <p:grpSpPr>
+        <a:xfrm>
+          <a:off x="0" y="0"/>
+          <a:ext cx="0" cy="0"/>
+          <a:chOff x="0" y="0"/>
+          <a:chExt cx="0" cy="0"/>
+        </a:xfrm>
+      </p:grpSpPr>
       <p:sp>
         <p:nvSpPr>
           <p:cNvPr id="2" name="TextBox 1"/>
@@ -4661,7 +4885,9 @@
             <a:spAutoFit/>
           </a:bodyPr>
           <a:lstStyle/>
-          <a:p/>
+          <a:p>
+            <a:endParaRPr/>
+          </a:p>
           <a:p>
             <a:pPr>
               <a:spcBef>
@@ -4821,7 +5047,7 @@
 </file>
 
 <file path=ppt/slides/slide7.xml><?xml version="1.0" encoding="utf-8"?>
-<p:sld xmlns:a="http://schemas.openxmlformats.org/drawingml/2006/main" xmlns:p="http://schemas.openxmlformats.org/presentationml/2006/main" xmlns:r="http://schemas.openxmlformats.org/officeDocument/2006/relationships">
+<p:sld xmlns:a="http://schemas.openxmlformats.org/drawingml/2006/main" xmlns:r="http://schemas.openxmlformats.org/officeDocument/2006/relationships" xmlns:p="http://schemas.openxmlformats.org/presentationml/2006/main">
   <p:cSld>
     <p:bg>
       <p:bgPr>
@@ -4837,7 +5063,14 @@
         <p:cNvGrpSpPr/>
         <p:nvPr/>
       </p:nvGrpSpPr>
-      <p:grpSpPr/>
+      <p:grpSpPr>
+        <a:xfrm>
+          <a:off x="0" y="0"/>
+          <a:ext cx="0" cy="0"/>
+          <a:chOff x="0" y="0"/>
+          <a:chExt cx="0" cy="0"/>
+        </a:xfrm>
+      </p:grpSpPr>
       <p:sp>
         <p:nvSpPr>
           <p:cNvPr id="2" name="TextBox 1"/>
@@ -4894,7 +5127,9 @@
             <a:spAutoFit/>
           </a:bodyPr>
           <a:lstStyle/>
-          <a:p/>
+          <a:p>
+            <a:endParaRPr/>
+          </a:p>
           <a:p>
             <a:pPr>
               <a:spcBef>
@@ -5014,7 +5249,7 @@
 </file>
 
 <file path=ppt/slides/slide8.xml><?xml version="1.0" encoding="utf-8"?>
-<p:sld xmlns:a="http://schemas.openxmlformats.org/drawingml/2006/main" xmlns:p="http://schemas.openxmlformats.org/presentationml/2006/main" xmlns:r="http://schemas.openxmlformats.org/officeDocument/2006/relationships">
+<p:sld xmlns:a="http://schemas.openxmlformats.org/drawingml/2006/main" xmlns:r="http://schemas.openxmlformats.org/officeDocument/2006/relationships" xmlns:p="http://schemas.openxmlformats.org/presentationml/2006/main">
   <p:cSld>
     <p:bg>
       <p:bgPr>
@@ -5030,7 +5265,14 @@
         <p:cNvGrpSpPr/>
         <p:nvPr/>
       </p:nvGrpSpPr>
-      <p:grpSpPr/>
+      <p:grpSpPr>
+        <a:xfrm>
+          <a:off x="0" y="0"/>
+          <a:ext cx="0" cy="0"/>
+          <a:chOff x="0" y="0"/>
+          <a:chExt cx="0" cy="0"/>
+        </a:xfrm>
+      </p:grpSpPr>
       <p:sp>
         <p:nvSpPr>
           <p:cNvPr id="2" name="TextBox 1"/>
@@ -5087,7 +5329,9 @@
             <a:spAutoFit/>
           </a:bodyPr>
           <a:lstStyle/>
-          <a:p/>
+          <a:p>
+            <a:endParaRPr/>
+          </a:p>
           <a:p>
             <a:pPr>
               <a:spcBef>
@@ -5207,7 +5451,7 @@
 </file>
 
 <file path=ppt/slides/slide9.xml><?xml version="1.0" encoding="utf-8"?>
-<p:sld xmlns:a="http://schemas.openxmlformats.org/drawingml/2006/main" xmlns:p="http://schemas.openxmlformats.org/presentationml/2006/main" xmlns:r="http://schemas.openxmlformats.org/officeDocument/2006/relationships">
+<p:sld xmlns:a="http://schemas.openxmlformats.org/drawingml/2006/main" xmlns:r="http://schemas.openxmlformats.org/officeDocument/2006/relationships" xmlns:p="http://schemas.openxmlformats.org/presentationml/2006/main">
   <p:cSld>
     <p:bg>
       <p:bgPr>
@@ -5223,7 +5467,14 @@
         <p:cNvGrpSpPr/>
         <p:nvPr/>
       </p:nvGrpSpPr>
-      <p:grpSpPr/>
+      <p:grpSpPr>
+        <a:xfrm>
+          <a:off x="0" y="0"/>
+          <a:ext cx="0" cy="0"/>
+          <a:chOff x="0" y="0"/>
+          <a:chExt cx="0" cy="0"/>
+        </a:xfrm>
+      </p:grpSpPr>
       <p:sp>
         <p:nvSpPr>
           <p:cNvPr id="2" name="TextBox 1"/>
@@ -5280,7 +5531,9 @@
             <a:spAutoFit/>
           </a:bodyPr>
           <a:lstStyle/>
-          <a:p/>
+          <a:p>
+            <a:endParaRPr/>
+          </a:p>
           <a:p>
             <a:pPr>
               <a:spcBef>

</xml_diff>